<commit_message>
fix: enlarge presentation demo captures by fifteen percent
</commit_message>
<xml_diff>
--- a/presentation/finals/안전반장_4분·10분_공용.pptx
+++ b/presentation/finals/안전반장_4분·10분_공용.pptx
@@ -2,57 +2,57 @@
 <file path=ppt/presentation.xml><?xml version="1.0" encoding="utf-8"?>
 <p:presentation xmlns:p="http://schemas.openxmlformats.org/presentationml/2006/main">
   <p:sldMasterIdLst>
-    <p:sldMasterId xmlns:r="http://schemas.openxmlformats.org/officeDocument/2006/relationships" id="2147483648" r:id="Refa7ac0cc97a48c2"/>
+    <p:sldMasterId xmlns:r="http://schemas.openxmlformats.org/officeDocument/2006/relationships" id="2147483648" r:id="R1ea50e8b66614c47"/>
   </p:sldMasterIdLst>
   <p:notesMasterIdLst>
-    <p:notesMasterId xmlns:r="http://schemas.openxmlformats.org/officeDocument/2006/relationships" r:id="Rec55973790414bd7"/>
+    <p:notesMasterId xmlns:r="http://schemas.openxmlformats.org/officeDocument/2006/relationships" r:id="R86ee802e091045f8"/>
   </p:notesMasterIdLst>
   <p:sldIdLst>
-    <p:sldId xmlns:r="http://schemas.openxmlformats.org/officeDocument/2006/relationships" id="256" r:id="Rddbd6892e136425b"/>
-    <p:sldId xmlns:r="http://schemas.openxmlformats.org/officeDocument/2006/relationships" id="257" r:id="R18429f226bd04b5a"/>
-    <p:sldId xmlns:r="http://schemas.openxmlformats.org/officeDocument/2006/relationships" id="258" r:id="Rbc8d1764e6764518"/>
-    <p:sldId xmlns:r="http://schemas.openxmlformats.org/officeDocument/2006/relationships" id="259" r:id="R15e84b3a50844ed7"/>
-    <p:sldId xmlns:r="http://schemas.openxmlformats.org/officeDocument/2006/relationships" id="260" r:id="R7de5c47be7944323"/>
-    <p:sldId xmlns:r="http://schemas.openxmlformats.org/officeDocument/2006/relationships" id="261" r:id="R6c649aa8b3c44087"/>
-    <p:sldId xmlns:r="http://schemas.openxmlformats.org/officeDocument/2006/relationships" id="262" r:id="R6c32bbec66d24c70"/>
-    <p:sldId xmlns:r="http://schemas.openxmlformats.org/officeDocument/2006/relationships" id="263" r:id="R1670939d066f4cd2"/>
-    <p:sldId xmlns:r="http://schemas.openxmlformats.org/officeDocument/2006/relationships" id="264" r:id="R6669e2bd430149fc"/>
-    <p:sldId xmlns:r="http://schemas.openxmlformats.org/officeDocument/2006/relationships" id="265" r:id="Rbb52a47f2528411b"/>
-    <p:sldId xmlns:r="http://schemas.openxmlformats.org/officeDocument/2006/relationships" id="266" r:id="R4d27588023d54ce2"/>
-    <p:sldId xmlns:r="http://schemas.openxmlformats.org/officeDocument/2006/relationships" id="267" r:id="R076b0f5effdc42db"/>
-    <p:sldId xmlns:r="http://schemas.openxmlformats.org/officeDocument/2006/relationships" id="268" r:id="R3524dcbb4ecc40f7"/>
-    <p:sldId xmlns:r="http://schemas.openxmlformats.org/officeDocument/2006/relationships" id="269" r:id="R1b9abeb7ff2741e5"/>
+    <p:sldId xmlns:r="http://schemas.openxmlformats.org/officeDocument/2006/relationships" id="256" r:id="R94704823c01f4bf3"/>
+    <p:sldId xmlns:r="http://schemas.openxmlformats.org/officeDocument/2006/relationships" id="257" r:id="R12e70f02b8ea4ca2"/>
+    <p:sldId xmlns:r="http://schemas.openxmlformats.org/officeDocument/2006/relationships" id="258" r:id="Rda131028f3514877"/>
+    <p:sldId xmlns:r="http://schemas.openxmlformats.org/officeDocument/2006/relationships" id="259" r:id="Rb0afdd1049f541cf"/>
+    <p:sldId xmlns:r="http://schemas.openxmlformats.org/officeDocument/2006/relationships" id="260" r:id="R85ab26709cc54c4c"/>
+    <p:sldId xmlns:r="http://schemas.openxmlformats.org/officeDocument/2006/relationships" id="261" r:id="R5453736deacb4680"/>
+    <p:sldId xmlns:r="http://schemas.openxmlformats.org/officeDocument/2006/relationships" id="262" r:id="Rc541a3be6c4943ae"/>
+    <p:sldId xmlns:r="http://schemas.openxmlformats.org/officeDocument/2006/relationships" id="263" r:id="R3ac3e850ca6840df"/>
+    <p:sldId xmlns:r="http://schemas.openxmlformats.org/officeDocument/2006/relationships" id="264" r:id="R41b7c16c2da3436f"/>
+    <p:sldId xmlns:r="http://schemas.openxmlformats.org/officeDocument/2006/relationships" id="265" r:id="Rf86a29e63b984ba6"/>
+    <p:sldId xmlns:r="http://schemas.openxmlformats.org/officeDocument/2006/relationships" id="266" r:id="Rb190d2da5bf549c1"/>
+    <p:sldId xmlns:r="http://schemas.openxmlformats.org/officeDocument/2006/relationships" id="267" r:id="R52423c72efca4cca"/>
+    <p:sldId xmlns:r="http://schemas.openxmlformats.org/officeDocument/2006/relationships" id="268" r:id="R00abcc4d7d3f4741"/>
+    <p:sldId xmlns:r="http://schemas.openxmlformats.org/officeDocument/2006/relationships" id="269" r:id="Rfd186a39a0d04e37"/>
   </p:sldIdLst>
   <p:sldSz cx="12192000" cy="6858000"/>
   <p:notesSz cx="6858000" cy="9144000"/>
   <p:custShowLst xmlns:r="http://schemas.openxmlformats.org/officeDocument/2006/relationships">
     <p:custShow name="4분 핵심 발표" id="0">
       <p:sldLst>
-        <p:sld r:id="Rddbd6892e136425b"/>
-        <p:sld r:id="R18429f226bd04b5a"/>
-        <p:sld r:id="R7de5c47be7944323"/>
-        <p:sld r:id="R6c649aa8b3c44087"/>
-        <p:sld r:id="R1670939d066f4cd2"/>
-        <p:sld r:id="R6669e2bd430149fc"/>
-        <p:sld r:id="R1b9abeb7ff2741e5"/>
+        <p:sld r:id="R94704823c01f4bf3"/>
+        <p:sld r:id="R12e70f02b8ea4ca2"/>
+        <p:sld r:id="R85ab26709cc54c4c"/>
+        <p:sld r:id="R5453736deacb4680"/>
+        <p:sld r:id="R3ac3e850ca6840df"/>
+        <p:sld r:id="R41b7c16c2da3436f"/>
+        <p:sld r:id="Rfd186a39a0d04e37"/>
       </p:sldLst>
     </p:custShow>
     <p:custShow name="10분 본선 발표" id="1">
       <p:sldLst>
-        <p:sld r:id="Rddbd6892e136425b"/>
-        <p:sld r:id="R18429f226bd04b5a"/>
-        <p:sld r:id="Rbc8d1764e6764518"/>
-        <p:sld r:id="R15e84b3a50844ed7"/>
-        <p:sld r:id="R7de5c47be7944323"/>
-        <p:sld r:id="R6c649aa8b3c44087"/>
-        <p:sld r:id="R6c32bbec66d24c70"/>
-        <p:sld r:id="R1670939d066f4cd2"/>
-        <p:sld r:id="R6669e2bd430149fc"/>
-        <p:sld r:id="Rbb52a47f2528411b"/>
-        <p:sld r:id="R4d27588023d54ce2"/>
-        <p:sld r:id="R076b0f5effdc42db"/>
-        <p:sld r:id="R3524dcbb4ecc40f7"/>
-        <p:sld r:id="R1b9abeb7ff2741e5"/>
+        <p:sld r:id="R94704823c01f4bf3"/>
+        <p:sld r:id="R12e70f02b8ea4ca2"/>
+        <p:sld r:id="Rda131028f3514877"/>
+        <p:sld r:id="Rb0afdd1049f541cf"/>
+        <p:sld r:id="R85ab26709cc54c4c"/>
+        <p:sld r:id="R5453736deacb4680"/>
+        <p:sld r:id="Rc541a3be6c4943ae"/>
+        <p:sld r:id="R3ac3e850ca6840df"/>
+        <p:sld r:id="R41b7c16c2da3436f"/>
+        <p:sld r:id="Rf86a29e63b984ba6"/>
+        <p:sld r:id="Rb190d2da5bf549c1"/>
+        <p:sld r:id="R52423c72efca4cca"/>
+        <p:sld r:id="R00abcc4d7d3f4741"/>
+        <p:sld r:id="Rfd186a39a0d04e37"/>
       </p:sldLst>
     </p:custShow>
   </p:custShowLst>
@@ -1854,7 +1854,7 @@
           <p:cNvPr id="2" name="Title Placeholder 1">
             <a:extLst xmlns:a="http://schemas.openxmlformats.org/drawingml/2006/main">
               <a:ext uri="{FF2B5EF4-FFF2-40B4-BE49-F238E27FC236}">
-                <a16:creationId xmlns:a16="http://schemas.microsoft.com/office/drawing/2014/main" id="{97FC9890-AB35-4356-A6BA-8BD5EF17D175}"/>
+                <a16:creationId xmlns:a16="http://schemas.microsoft.com/office/drawing/2014/main" id="{F504E715-2BE6-4123-9576-839047FB78C1}"/>
               </a:ext>
             </a:extLst>
           </p:cNvPr>
@@ -1909,7 +1909,7 @@
           <p:cNvPr id="3" name="Text Placeholder 2">
             <a:extLst xmlns:a="http://schemas.openxmlformats.org/drawingml/2006/main">
               <a:ext uri="{FF2B5EF4-FFF2-40B4-BE49-F238E27FC236}">
-                <a16:creationId xmlns:a16="http://schemas.microsoft.com/office/drawing/2014/main" id="{A1ACFFA6-803D-424D-87F1-B7D71E3B092E}"/>
+                <a16:creationId xmlns:a16="http://schemas.microsoft.com/office/drawing/2014/main" id="{42BF4FDB-EC8D-480E-8FAF-F14DED5C2C93}"/>
               </a:ext>
             </a:extLst>
           </p:cNvPr>
@@ -1970,7 +1970,7 @@
     <p:bg>
       <p:bgPr>
         <a:blipFill xmlns:a="http://schemas.openxmlformats.org/drawingml/2006/main" rotWithShape="1">
-          <a:blip xmlns:r="http://schemas.openxmlformats.org/officeDocument/2006/relationships" r:embed="Rf566d9d8afd748fa">
+          <a:blip xmlns:r="http://schemas.openxmlformats.org/officeDocument/2006/relationships" r:embed="Rc5f572b95f1544fa">
             <a:lum/>
           </a:blip>
           <a:srcRect l="0" t="0" r="0" b="0"/>
@@ -1994,7 +1994,7 @@
           <p:cNvPr id="2" name="Title Placeholder 1">
             <a:extLst xmlns:a="http://schemas.openxmlformats.org/drawingml/2006/main">
               <a:ext uri="{FF2B5EF4-FFF2-40B4-BE49-F238E27FC236}">
-                <a16:creationId xmlns:a16="http://schemas.microsoft.com/office/drawing/2014/main" id="{73963969-F851-4634-A7F9-50BE2F466A1B}"/>
+                <a16:creationId xmlns:a16="http://schemas.microsoft.com/office/drawing/2014/main" id="{96B88AF7-9344-416B-8247-89B8A57F4D9C}"/>
               </a:ext>
             </a:extLst>
           </p:cNvPr>
@@ -2049,7 +2049,7 @@
           <p:cNvPr id="3" name="Text Placeholder 2">
             <a:extLst xmlns:a="http://schemas.openxmlformats.org/drawingml/2006/main">
               <a:ext uri="{FF2B5EF4-FFF2-40B4-BE49-F238E27FC236}">
-                <a16:creationId xmlns:a16="http://schemas.microsoft.com/office/drawing/2014/main" id="{307C648A-C1D4-442D-8FE5-56D14B1DEF6C}"/>
+                <a16:creationId xmlns:a16="http://schemas.microsoft.com/office/drawing/2014/main" id="{2D24323D-AF7C-4A87-8B88-77431EE4D6A3}"/>
               </a:ext>
             </a:extLst>
           </p:cNvPr>
@@ -2128,7 +2128,7 @@
           <p:cNvPr id="2" name="Title Placeholder 1">
             <a:extLst xmlns:a="http://schemas.openxmlformats.org/drawingml/2006/main">
               <a:ext uri="{FF2B5EF4-FFF2-40B4-BE49-F238E27FC236}">
-                <a16:creationId xmlns:a16="http://schemas.microsoft.com/office/drawing/2014/main" id="{9158902A-D75D-498C-9082-9B7A4A74A1D2}"/>
+                <a16:creationId xmlns:a16="http://schemas.microsoft.com/office/drawing/2014/main" id="{E0080B16-2197-4DF3-882A-C27B549ADEAF}"/>
               </a:ext>
             </a:extLst>
           </p:cNvPr>
@@ -2183,7 +2183,7 @@
           <p:cNvPr id="3" name="Text Placeholder 2">
             <a:extLst xmlns:a="http://schemas.openxmlformats.org/drawingml/2006/main">
               <a:ext uri="{FF2B5EF4-FFF2-40B4-BE49-F238E27FC236}">
-                <a16:creationId xmlns:a16="http://schemas.microsoft.com/office/drawing/2014/main" id="{D5353041-99CD-4B48-AB47-AD782B95DB57}"/>
+                <a16:creationId xmlns:a16="http://schemas.microsoft.com/office/drawing/2014/main" id="{B63BF714-FB11-46DB-BF0A-86D2D78E9646}"/>
               </a:ext>
             </a:extLst>
           </p:cNvPr>
@@ -2237,9 +2237,9 @@
   </p:cSld>
   <p:clrMap bg1="lt1" tx1="dk1" bg2="lt2" tx2="dk2" accent1="accent1" accent2="accent2" accent3="accent3" accent4="accent4" accent5="accent5" accent6="accent6" hlink="hlink" folHlink="folHlink"/>
   <p:sldLayoutIdLst>
-    <p:sldLayoutId xmlns:r="http://schemas.openxmlformats.org/officeDocument/2006/relationships" id="2147483649" r:id="Ra563ad809ac7414f"/>
-    <p:sldLayoutId xmlns:r="http://schemas.openxmlformats.org/officeDocument/2006/relationships" id="2147483650" r:id="R095bf196b43446c1"/>
-    <p:sldLayoutId xmlns:r="http://schemas.openxmlformats.org/officeDocument/2006/relationships" id="2147483651" r:id="R4d0a4d25de3e4ec0"/>
+    <p:sldLayoutId xmlns:r="http://schemas.openxmlformats.org/officeDocument/2006/relationships" id="2147483649" r:id="R4e54259091a34511"/>
+    <p:sldLayoutId xmlns:r="http://schemas.openxmlformats.org/officeDocument/2006/relationships" id="2147483650" r:id="Rf551b59e8da244e3"/>
+    <p:sldLayoutId xmlns:r="http://schemas.openxmlformats.org/officeDocument/2006/relationships" id="2147483651" r:id="Rbe388903d0a54c46"/>
   </p:sldLayoutIdLst>
   <p:hf sldNum="0" hdr="0" ftr="0" dt="0"/>
   <p:txStyles>
@@ -2803,7 +2803,7 @@
           <p:cNvPr id="2" name="Image 0">
             <a:extLst xmlns:a="http://schemas.openxmlformats.org/drawingml/2006/main">
               <a:ext uri="{FF2B5EF4-FFF2-40B4-BE49-F238E27FC236}">
-                <a16:creationId xmlns:a16="http://schemas.microsoft.com/office/drawing/2014/main" id="{FBA9B11A-795D-4128-AB4A-9C94BBEC859C}"/>
+                <a16:creationId xmlns:a16="http://schemas.microsoft.com/office/drawing/2014/main" id="{E6019DD2-0E0B-4D49-B5E9-5300C22685AE}"/>
               </a:ext>
             </a:extLst>
           </p:cNvPr>
@@ -2813,7 +2813,7 @@
           <p:nvPr/>
         </p:nvPicPr>
         <p:blipFill>
-          <a:blip xmlns:r="http://schemas.openxmlformats.org/officeDocument/2006/relationships" xmlns:a="http://schemas.openxmlformats.org/drawingml/2006/main" r:embed="R21ea131052254a00"/>
+          <a:blip xmlns:r="http://schemas.openxmlformats.org/officeDocument/2006/relationships" xmlns:a="http://schemas.openxmlformats.org/drawingml/2006/main" r:embed="Rbd786cf2102f4a2b"/>
           <a:srcRect xmlns:a="http://schemas.openxmlformats.org/drawingml/2006/main" l="0" t="0" r="0" b="0"/>
           <a:stretch xmlns:a="http://schemas.openxmlformats.org/drawingml/2006/main"/>
         </p:blipFill>
@@ -2841,7 +2841,7 @@
           <p:cNvPr id="3" name="Shape 0">
             <a:extLst xmlns:a="http://schemas.openxmlformats.org/drawingml/2006/main">
               <a:ext uri="{FF2B5EF4-FFF2-40B4-BE49-F238E27FC236}">
-                <a16:creationId xmlns:a16="http://schemas.microsoft.com/office/drawing/2014/main" id="{55FF59C5-50E4-4FD6-A737-29CA339CB0E5}"/>
+                <a16:creationId xmlns:a16="http://schemas.microsoft.com/office/drawing/2014/main" id="{D1C65FA5-AFB0-47C2-B3D0-5015927E9D1C}"/>
               </a:ext>
             </a:extLst>
           </p:cNvPr>
@@ -2870,7 +2870,7 @@
           <p:cNvPr id="4" name="Shape 1">
             <a:extLst xmlns:a="http://schemas.openxmlformats.org/drawingml/2006/main">
               <a:ext uri="{FF2B5EF4-FFF2-40B4-BE49-F238E27FC236}">
-                <a16:creationId xmlns:a16="http://schemas.microsoft.com/office/drawing/2014/main" id="{F7BB05F1-7F98-4BB8-9411-B23F296F212F}"/>
+                <a16:creationId xmlns:a16="http://schemas.microsoft.com/office/drawing/2014/main" id="{F3C1C0F9-17D1-4B16-BC30-9FA79D5857F4}"/>
               </a:ext>
             </a:extLst>
           </p:cNvPr>
@@ -2899,7 +2899,7 @@
           <p:cNvPr id="5" name="Shape 2">
             <a:extLst xmlns:a="http://schemas.openxmlformats.org/drawingml/2006/main">
               <a:ext uri="{FF2B5EF4-FFF2-40B4-BE49-F238E27FC236}">
-                <a16:creationId xmlns:a16="http://schemas.microsoft.com/office/drawing/2014/main" id="{AEC02015-C137-44EF-A4D9-61AD1EAB19E8}"/>
+                <a16:creationId xmlns:a16="http://schemas.microsoft.com/office/drawing/2014/main" id="{C95B4F1D-0A1C-4FE3-8BFA-E4DBCDB61FD1}"/>
               </a:ext>
             </a:extLst>
           </p:cNvPr>
@@ -2928,7 +2928,7 @@
           <p:cNvPr id="6" name="Shape 3">
             <a:extLst xmlns:a="http://schemas.openxmlformats.org/drawingml/2006/main">
               <a:ext uri="{FF2B5EF4-FFF2-40B4-BE49-F238E27FC236}">
-                <a16:creationId xmlns:a16="http://schemas.microsoft.com/office/drawing/2014/main" id="{C6484D10-8DFD-4414-A7E8-60C6079CD52F}"/>
+                <a16:creationId xmlns:a16="http://schemas.microsoft.com/office/drawing/2014/main" id="{8E9A6E29-8F75-48C4-B4F6-D2C4FFA3FFEF}"/>
               </a:ext>
             </a:extLst>
           </p:cNvPr>
@@ -2957,7 +2957,7 @@
           <p:cNvPr id="7" name="Shape 4">
             <a:extLst xmlns:a="http://schemas.openxmlformats.org/drawingml/2006/main">
               <a:ext uri="{FF2B5EF4-FFF2-40B4-BE49-F238E27FC236}">
-                <a16:creationId xmlns:a16="http://schemas.microsoft.com/office/drawing/2014/main" id="{B219AADC-EA78-4583-A2B1-08F986E51D39}"/>
+                <a16:creationId xmlns:a16="http://schemas.microsoft.com/office/drawing/2014/main" id="{23A551AD-B7F6-4DFB-844D-04A7BCA4E8E2}"/>
               </a:ext>
             </a:extLst>
           </p:cNvPr>
@@ -2986,7 +2986,7 @@
           <p:cNvPr id="8" name="Text 5">
             <a:extLst xmlns:a="http://schemas.openxmlformats.org/drawingml/2006/main">
               <a:ext uri="{FF2B5EF4-FFF2-40B4-BE49-F238E27FC236}">
-                <a16:creationId xmlns:a16="http://schemas.microsoft.com/office/drawing/2014/main" id="{87EB2075-6295-434D-9468-03EF50E934CD}"/>
+                <a16:creationId xmlns:a16="http://schemas.microsoft.com/office/drawing/2014/main" id="{D1F2CFB9-32DC-43D1-B0CA-7F404B9E6863}"/>
               </a:ext>
             </a:extLst>
           </p:cNvPr>
@@ -3037,7 +3037,7 @@
           <p:cNvPr id="9" name="Text 6">
             <a:extLst xmlns:a="http://schemas.openxmlformats.org/drawingml/2006/main">
               <a:ext uri="{FF2B5EF4-FFF2-40B4-BE49-F238E27FC236}">
-                <a16:creationId xmlns:a16="http://schemas.microsoft.com/office/drawing/2014/main" id="{A2C3FA47-FDB6-4C1A-97F1-619355CE2E46}"/>
+                <a16:creationId xmlns:a16="http://schemas.microsoft.com/office/drawing/2014/main" id="{A8E40D1D-52A2-4FE3-9C81-3DBC200797E6}"/>
               </a:ext>
             </a:extLst>
           </p:cNvPr>
@@ -3090,7 +3090,7 @@
           <p:cNvPr id="10" name="Text 7">
             <a:extLst xmlns:a="http://schemas.openxmlformats.org/drawingml/2006/main">
               <a:ext uri="{FF2B5EF4-FFF2-40B4-BE49-F238E27FC236}">
-                <a16:creationId xmlns:a16="http://schemas.microsoft.com/office/drawing/2014/main" id="{7ECAA3EA-3B8B-4B18-A310-D57181D9B4BA}"/>
+                <a16:creationId xmlns:a16="http://schemas.microsoft.com/office/drawing/2014/main" id="{23357184-3D40-4EF4-9D20-6A60256B306D}"/>
               </a:ext>
             </a:extLst>
           </p:cNvPr>
@@ -3161,7 +3161,7 @@
           <p:cNvPr id="11" name="Shape 8">
             <a:extLst xmlns:a="http://schemas.openxmlformats.org/drawingml/2006/main">
               <a:ext uri="{FF2B5EF4-FFF2-40B4-BE49-F238E27FC236}">
-                <a16:creationId xmlns:a16="http://schemas.microsoft.com/office/drawing/2014/main" id="{4916329E-3C41-4BE0-A9CF-2A588A1C157A}"/>
+                <a16:creationId xmlns:a16="http://schemas.microsoft.com/office/drawing/2014/main" id="{08BF416B-2146-4DBD-9CDF-7BE9E24868F2}"/>
               </a:ext>
             </a:extLst>
           </p:cNvPr>
@@ -3192,7 +3192,7 @@
           <p:cNvPr id="12" name="Text 9">
             <a:extLst xmlns:a="http://schemas.openxmlformats.org/drawingml/2006/main">
               <a:ext uri="{FF2B5EF4-FFF2-40B4-BE49-F238E27FC236}">
-                <a16:creationId xmlns:a16="http://schemas.microsoft.com/office/drawing/2014/main" id="{2ABB2A75-D82C-4431-B3F9-C69844C7D968}"/>
+                <a16:creationId xmlns:a16="http://schemas.microsoft.com/office/drawing/2014/main" id="{FA915221-AC92-4F20-8CDC-1F44515F46AE}"/>
               </a:ext>
             </a:extLst>
           </p:cNvPr>
@@ -3243,7 +3243,7 @@
           <p:cNvPr id="13" name="Text 10">
             <a:extLst xmlns:a="http://schemas.openxmlformats.org/drawingml/2006/main">
               <a:ext uri="{FF2B5EF4-FFF2-40B4-BE49-F238E27FC236}">
-                <a16:creationId xmlns:a16="http://schemas.microsoft.com/office/drawing/2014/main" id="{79421E40-592E-4E3F-A1DE-1DA8E9D5BD5B}"/>
+                <a16:creationId xmlns:a16="http://schemas.microsoft.com/office/drawing/2014/main" id="{3B0A044E-1621-4A32-9F16-64DBFFE1D82F}"/>
               </a:ext>
             </a:extLst>
           </p:cNvPr>
@@ -3292,7 +3292,7 @@
     </p:spTree>
     <p:extLst>
       <p:ext uri="{BB962C8B-B14F-4D97-AF65-F5344CB8AC3E}">
-        <p14:creationId xmlns:p14="http://schemas.microsoft.com/office/powerpoint/2010/main" val="1352071150"/>
+        <p14:creationId xmlns:p14="http://schemas.microsoft.com/office/powerpoint/2010/main" val="228086595"/>
       </p:ext>
     </p:extLst>
   </p:cSld>
@@ -3316,18 +3316,18 @@
           <p:cNvPr id="12" name="DEMO 05 · 관리자">
             <a:extLst xmlns:a="http://schemas.openxmlformats.org/drawingml/2006/main">
               <a:ext uri="{FF2B5EF4-FFF2-40B4-BE49-F238E27FC236}">
-                <a16:creationId xmlns:a16="http://schemas.microsoft.com/office/drawing/2014/main" id="{23F5B4FB-29EC-4107-B0C7-5BA3E040AD2D}"/>
-              </a:ext>
-            </a:extLst>
-          </p:cNvPr>
-          <p:cNvSpPr>
-            <a:spLocks xmlns:a="http://schemas.openxmlformats.org/drawingml/2006/main" noGrp="1"/>
-          </p:cNvSpPr>
-          <p:nvPr/>
-        </p:nvSpPr>
-        <p:spPr>
-          <a:xfrm xmlns:a="http://schemas.openxmlformats.org/drawingml/2006/main">
-            <a:off x="819150" y="676275"/>
+                <a16:creationId xmlns:a16="http://schemas.microsoft.com/office/drawing/2014/main" id="{0B07A6DA-52E3-4BE3-AAC7-E01DFED774DB}"/>
+              </a:ext>
+            </a:extLst>
+          </p:cNvPr>
+          <p:cNvSpPr>
+            <a:spLocks xmlns:a="http://schemas.openxmlformats.org/drawingml/2006/main" noGrp="1"/>
+          </p:cNvSpPr>
+          <p:nvPr/>
+        </p:nvSpPr>
+        <p:spPr>
+          <a:xfrm xmlns:a="http://schemas.openxmlformats.org/drawingml/2006/main">
+            <a:off x="819150" y="400050"/>
             <a:ext cx="8096250" cy="285750"/>
           </a:xfrm>
           <a:prstGeom xmlns:a="http://schemas.openxmlformats.org/drawingml/2006/main" prst="rect">
@@ -3384,19 +3384,19 @@
           <p:cNvPr id="2" name="위험요인과 안전조치를 JSA 초안으로 정리합니다">
             <a:extLst xmlns:a="http://schemas.openxmlformats.org/drawingml/2006/main">
               <a:ext uri="{FF2B5EF4-FFF2-40B4-BE49-F238E27FC236}">
-                <a16:creationId xmlns:a16="http://schemas.microsoft.com/office/drawing/2014/main" id="{BE442F3B-57A8-48EB-898E-CD0B8991D6A8}"/>
-              </a:ext>
-            </a:extLst>
-          </p:cNvPr>
-          <p:cNvSpPr>
-            <a:spLocks xmlns:a="http://schemas.openxmlformats.org/drawingml/2006/main" noGrp="1"/>
-          </p:cNvSpPr>
-          <p:nvPr/>
-        </p:nvSpPr>
-        <p:spPr>
-          <a:xfrm xmlns:a="http://schemas.openxmlformats.org/drawingml/2006/main">
-            <a:off x="819150" y="1019175"/>
-            <a:ext cx="10668000" cy="571500"/>
+                <a16:creationId xmlns:a16="http://schemas.microsoft.com/office/drawing/2014/main" id="{58B07444-AF69-4E5D-AD7D-2069DA7691AB}"/>
+              </a:ext>
+            </a:extLst>
+          </p:cNvPr>
+          <p:cNvSpPr>
+            <a:spLocks xmlns:a="http://schemas.openxmlformats.org/drawingml/2006/main" noGrp="1"/>
+          </p:cNvSpPr>
+          <p:nvPr/>
+        </p:nvSpPr>
+        <p:spPr>
+          <a:xfrm xmlns:a="http://schemas.openxmlformats.org/drawingml/2006/main">
+            <a:off x="819150" y="723900"/>
+            <a:ext cx="10668000" cy="457200"/>
           </a:xfrm>
           <a:prstGeom xmlns:a="http://schemas.openxmlformats.org/drawingml/2006/main" prst="rect">
             <a:avLst/>
@@ -3452,19 +3452,19 @@
           <p:cNvPr id="3" name="안전반장 · TEAM 0x02">
             <a:extLst xmlns:a="http://schemas.openxmlformats.org/drawingml/2006/main">
               <a:ext uri="{FF2B5EF4-FFF2-40B4-BE49-F238E27FC236}">
-                <a16:creationId xmlns:a16="http://schemas.microsoft.com/office/drawing/2014/main" id="{2C792351-34A8-4157-80A3-141DB591C322}"/>
-              </a:ext>
-            </a:extLst>
-          </p:cNvPr>
-          <p:cNvSpPr>
-            <a:spLocks xmlns:a="http://schemas.openxmlformats.org/drawingml/2006/main" noGrp="1"/>
-          </p:cNvSpPr>
-          <p:nvPr/>
-        </p:nvSpPr>
-        <p:spPr>
-          <a:xfrm xmlns:a="http://schemas.openxmlformats.org/drawingml/2006/main">
-            <a:off x="819150" y="6334125"/>
-            <a:ext cx="6667500" cy="238125"/>
+                <a16:creationId xmlns:a16="http://schemas.microsoft.com/office/drawing/2014/main" id="{C6FBD472-83CA-4662-B82C-4E94C64ABD3E}"/>
+              </a:ext>
+            </a:extLst>
+          </p:cNvPr>
+          <p:cNvSpPr>
+            <a:spLocks xmlns:a="http://schemas.openxmlformats.org/drawingml/2006/main" noGrp="1"/>
+          </p:cNvSpPr>
+          <p:nvPr/>
+        </p:nvSpPr>
+        <p:spPr>
+          <a:xfrm xmlns:a="http://schemas.openxmlformats.org/drawingml/2006/main">
+            <a:off x="819150" y="6562725"/>
+            <a:ext cx="6667500" cy="209550"/>
           </a:xfrm>
           <a:prstGeom xmlns:a="http://schemas.openxmlformats.org/drawingml/2006/main" prst="rect">
             <a:avLst/>
@@ -3520,19 +3520,19 @@
           <p:cNvPr id="4" name="10 / 14">
             <a:extLst xmlns:a="http://schemas.openxmlformats.org/drawingml/2006/main">
               <a:ext uri="{FF2B5EF4-FFF2-40B4-BE49-F238E27FC236}">
-                <a16:creationId xmlns:a16="http://schemas.microsoft.com/office/drawing/2014/main" id="{F1073645-48C2-4653-8826-8F38790E5C5C}"/>
-              </a:ext>
-            </a:extLst>
-          </p:cNvPr>
-          <p:cNvSpPr>
-            <a:spLocks xmlns:a="http://schemas.openxmlformats.org/drawingml/2006/main" noGrp="1"/>
-          </p:cNvSpPr>
-          <p:nvPr/>
-        </p:nvSpPr>
-        <p:spPr>
-          <a:xfrm xmlns:a="http://schemas.openxmlformats.org/drawingml/2006/main">
-            <a:off x="10668000" y="6334125"/>
-            <a:ext cx="952500" cy="238125"/>
+                <a16:creationId xmlns:a16="http://schemas.microsoft.com/office/drawing/2014/main" id="{6A441072-C90D-4392-A7DD-42F5F51F65E5}"/>
+              </a:ext>
+            </a:extLst>
+          </p:cNvPr>
+          <p:cNvSpPr>
+            <a:spLocks xmlns:a="http://schemas.openxmlformats.org/drawingml/2006/main" noGrp="1"/>
+          </p:cNvSpPr>
+          <p:nvPr/>
+        </p:nvSpPr>
+        <p:spPr>
+          <a:xfrm xmlns:a="http://schemas.openxmlformats.org/drawingml/2006/main">
+            <a:off x="10668000" y="6562725"/>
+            <a:ext cx="952500" cy="209550"/>
           </a:xfrm>
           <a:prstGeom xmlns:a="http://schemas.openxmlformats.org/drawingml/2006/main" prst="rect">
             <a:avLst/>
@@ -3588,19 +3588,19 @@
           <p:cNvPr id="5" name="입력한 작업을&#10;검토 가능한 초안으로">
             <a:extLst xmlns:a="http://schemas.openxmlformats.org/drawingml/2006/main">
               <a:ext uri="{FF2B5EF4-FFF2-40B4-BE49-F238E27FC236}">
-                <a16:creationId xmlns:a16="http://schemas.microsoft.com/office/drawing/2014/main" id="{EDEBE537-AD2A-4835-8B89-E9F111956503}"/>
-              </a:ext>
-            </a:extLst>
-          </p:cNvPr>
-          <p:cNvSpPr>
-            <a:spLocks xmlns:a="http://schemas.openxmlformats.org/drawingml/2006/main" noGrp="1"/>
-          </p:cNvSpPr>
-          <p:nvPr/>
-        </p:nvSpPr>
-        <p:spPr>
-          <a:xfrm xmlns:a="http://schemas.openxmlformats.org/drawingml/2006/main">
-            <a:off x="819150" y="2133600"/>
-            <a:ext cx="5143500" cy="1238250"/>
+                <a16:creationId xmlns:a16="http://schemas.microsoft.com/office/drawing/2014/main" id="{17708A41-C896-4E45-9BA3-39DEF8C9E297}"/>
+              </a:ext>
+            </a:extLst>
+          </p:cNvPr>
+          <p:cNvSpPr>
+            <a:spLocks xmlns:a="http://schemas.openxmlformats.org/drawingml/2006/main" noGrp="1"/>
+          </p:cNvSpPr>
+          <p:nvPr/>
+        </p:nvSpPr>
+        <p:spPr>
+          <a:xfrm xmlns:a="http://schemas.openxmlformats.org/drawingml/2006/main">
+            <a:off x="819150" y="2047875"/>
+            <a:ext cx="4857750" cy="1238250"/>
           </a:xfrm>
           <a:prstGeom xmlns:a="http://schemas.openxmlformats.org/drawingml/2006/main" prst="rect">
             <a:avLst/>
@@ -3679,19 +3679,19 @@
           <p:cNvPr id="6" name="작업 내용, 위험요인, 감소 대책을&#10;한 화면에서 검토합니다">
             <a:extLst xmlns:a="http://schemas.openxmlformats.org/drawingml/2006/main">
               <a:ext uri="{FF2B5EF4-FFF2-40B4-BE49-F238E27FC236}">
-                <a16:creationId xmlns:a16="http://schemas.microsoft.com/office/drawing/2014/main" id="{689A9379-30AB-45EC-8C48-3B4348531D5B}"/>
-              </a:ext>
-            </a:extLst>
-          </p:cNvPr>
-          <p:cNvSpPr>
-            <a:spLocks xmlns:a="http://schemas.openxmlformats.org/drawingml/2006/main" noGrp="1"/>
-          </p:cNvSpPr>
-          <p:nvPr/>
-        </p:nvSpPr>
-        <p:spPr>
-          <a:xfrm xmlns:a="http://schemas.openxmlformats.org/drawingml/2006/main">
-            <a:off x="819150" y="3590925"/>
-            <a:ext cx="5095875" cy="1666875"/>
+                <a16:creationId xmlns:a16="http://schemas.microsoft.com/office/drawing/2014/main" id="{D0B3D86C-B6B2-4B64-9CA4-7631B5C89CAF}"/>
+              </a:ext>
+            </a:extLst>
+          </p:cNvPr>
+          <p:cNvSpPr>
+            <a:spLocks xmlns:a="http://schemas.openxmlformats.org/drawingml/2006/main" noGrp="1"/>
+          </p:cNvSpPr>
+          <p:nvPr/>
+        </p:nvSpPr>
+        <p:spPr>
+          <a:xfrm xmlns:a="http://schemas.openxmlformats.org/drawingml/2006/main">
+            <a:off x="819150" y="3429000"/>
+            <a:ext cx="4857750" cy="1666875"/>
           </a:xfrm>
           <a:prstGeom xmlns:a="http://schemas.openxmlformats.org/drawingml/2006/main" prst="rect">
             <a:avLst/>
@@ -3770,19 +3770,19 @@
           <p:cNvPr id="7" name="자동 작성 결과는 초안입니다.&#10;책임자의 현장 검토가 필요합">
             <a:extLst xmlns:a="http://schemas.openxmlformats.org/drawingml/2006/main">
               <a:ext uri="{FF2B5EF4-FFF2-40B4-BE49-F238E27FC236}">
-                <a16:creationId xmlns:a16="http://schemas.microsoft.com/office/drawing/2014/main" id="{96643AFB-C2A2-4DDD-A522-ABA2207CD462}"/>
-              </a:ext>
-            </a:extLst>
-          </p:cNvPr>
-          <p:cNvSpPr>
-            <a:spLocks xmlns:a="http://schemas.openxmlformats.org/drawingml/2006/main" noGrp="1"/>
-          </p:cNvSpPr>
-          <p:nvPr/>
-        </p:nvSpPr>
-        <p:spPr>
-          <a:xfrm xmlns:a="http://schemas.openxmlformats.org/drawingml/2006/main">
-            <a:off x="819150" y="5467350"/>
-            <a:ext cx="5143500" cy="619125"/>
+                <a16:creationId xmlns:a16="http://schemas.microsoft.com/office/drawing/2014/main" id="{BC115B35-D37F-4CA1-8205-4DCD463A0A25}"/>
+              </a:ext>
+            </a:extLst>
+          </p:cNvPr>
+          <p:cNvSpPr>
+            <a:spLocks xmlns:a="http://schemas.openxmlformats.org/drawingml/2006/main" noGrp="1"/>
+          </p:cNvSpPr>
+          <p:nvPr/>
+        </p:nvSpPr>
+        <p:spPr>
+          <a:xfrm xmlns:a="http://schemas.openxmlformats.org/drawingml/2006/main">
+            <a:off x="819150" y="5362575"/>
+            <a:ext cx="4857750" cy="619125"/>
           </a:xfrm>
           <a:prstGeom xmlns:a="http://schemas.openxmlformats.org/drawingml/2006/main" prst="rect">
             <a:avLst/>
@@ -3861,19 +3861,19 @@
           <p:cNvPr id="8" name="보고를 담은 초안">
             <a:extLst xmlns:a="http://schemas.openxmlformats.org/drawingml/2006/main">
               <a:ext uri="{FF2B5EF4-FFF2-40B4-BE49-F238E27FC236}">
-                <a16:creationId xmlns:a16="http://schemas.microsoft.com/office/drawing/2014/main" id="{A780C500-1B0F-4CAC-9B0C-B082F8DE1B76}"/>
-              </a:ext>
-            </a:extLst>
-          </p:cNvPr>
-          <p:cNvSpPr>
-            <a:spLocks xmlns:a="http://schemas.openxmlformats.org/drawingml/2006/main" noGrp="1"/>
-          </p:cNvSpPr>
-          <p:nvPr/>
-        </p:nvSpPr>
-        <p:spPr>
-          <a:xfrm xmlns:a="http://schemas.openxmlformats.org/drawingml/2006/main">
-            <a:off x="6524625" y="1609725"/>
-            <a:ext cx="2095500" cy="238125"/>
+                <a16:creationId xmlns:a16="http://schemas.microsoft.com/office/drawing/2014/main" id="{E4FB94BB-B985-44D3-9645-B2B2B82FCB2A}"/>
+              </a:ext>
+            </a:extLst>
+          </p:cNvPr>
+          <p:cNvSpPr>
+            <a:spLocks xmlns:a="http://schemas.openxmlformats.org/drawingml/2006/main" noGrp="1"/>
+          </p:cNvSpPr>
+          <p:nvPr/>
+        </p:nvSpPr>
+        <p:spPr>
+          <a:xfrm xmlns:a="http://schemas.openxmlformats.org/drawingml/2006/main">
+            <a:off x="6096000" y="1257300"/>
+            <a:ext cx="2245519" cy="238125"/>
           </a:xfrm>
           <a:prstGeom xmlns:a="http://schemas.openxmlformats.org/drawingml/2006/main" prst="rect">
             <a:avLst/>
@@ -3929,19 +3929,19 @@
           <p:cNvPr id="9" name="안전조치 검토">
             <a:extLst xmlns:a="http://schemas.openxmlformats.org/drawingml/2006/main">
               <a:ext uri="{FF2B5EF4-FFF2-40B4-BE49-F238E27FC236}">
-                <a16:creationId xmlns:a16="http://schemas.microsoft.com/office/drawing/2014/main" id="{23900079-3F0B-4D3E-ADD9-CC8D4DD85784}"/>
-              </a:ext>
-            </a:extLst>
-          </p:cNvPr>
-          <p:cNvSpPr>
-            <a:spLocks xmlns:a="http://schemas.openxmlformats.org/drawingml/2006/main" noGrp="1"/>
-          </p:cNvSpPr>
-          <p:nvPr/>
-        </p:nvSpPr>
-        <p:spPr>
-          <a:xfrm xmlns:a="http://schemas.openxmlformats.org/drawingml/2006/main">
-            <a:off x="9048750" y="1609725"/>
-            <a:ext cx="2095500" cy="238125"/>
+                <a16:creationId xmlns:a16="http://schemas.microsoft.com/office/drawing/2014/main" id="{5B22D2AF-03A2-4BC3-9AC1-1AF76FE516A2}"/>
+              </a:ext>
+            </a:extLst>
+          </p:cNvPr>
+          <p:cNvSpPr>
+            <a:spLocks xmlns:a="http://schemas.openxmlformats.org/drawingml/2006/main" noGrp="1"/>
+          </p:cNvSpPr>
+          <p:nvPr/>
+        </p:nvSpPr>
+        <p:spPr>
+          <a:xfrm xmlns:a="http://schemas.openxmlformats.org/drawingml/2006/main">
+            <a:off x="8858250" y="1257300"/>
+            <a:ext cx="2245519" cy="238125"/>
           </a:xfrm>
           <a:prstGeom xmlns:a="http://schemas.openxmlformats.org/drawingml/2006/main" prst="rect">
             <a:avLst/>
@@ -3997,7 +3997,7 @@
           <p:cNvPr id="10" name="">
             <a:extLst xmlns:a="http://schemas.openxmlformats.org/drawingml/2006/main">
               <a:ext uri="{FF2B5EF4-FFF2-40B4-BE49-F238E27FC236}">
-                <a16:creationId xmlns:a16="http://schemas.microsoft.com/office/drawing/2014/main" id="{B8B35060-BBD6-4749-BCFA-69E6111E2E95}"/>
+                <a16:creationId xmlns:a16="http://schemas.microsoft.com/office/drawing/2014/main" id="{B0CCA0BD-2FD1-4A75-8EDF-E19E9B55E8EC}"/>
               </a:ext>
             </a:extLst>
           </p:cNvPr>
@@ -4007,13 +4007,13 @@
           <p:nvPr/>
         </p:nvPicPr>
         <p:blipFill>
-          <a:blip xmlns:r="http://schemas.openxmlformats.org/officeDocument/2006/relationships" xmlns:a="http://schemas.openxmlformats.org/drawingml/2006/main" r:embed="R7c7e6e23fb024068"/>
+          <a:blip xmlns:r="http://schemas.openxmlformats.org/officeDocument/2006/relationships" xmlns:a="http://schemas.openxmlformats.org/drawingml/2006/main" r:embed="R2a9898acefe24668"/>
           <a:stretch xmlns:a="http://schemas.openxmlformats.org/drawingml/2006/main"/>
         </p:blipFill>
         <p:spPr>
           <a:xfrm xmlns:a="http://schemas.openxmlformats.org/drawingml/2006/main">
-            <a:off x="6524625" y="1924050"/>
-            <a:ext cx="1952625" cy="4225681"/>
+            <a:off x="6096000" y="1524000"/>
+            <a:ext cx="2245519" cy="4859533"/>
           </a:xfrm>
           <a:prstGeom xmlns:a="http://schemas.openxmlformats.org/drawingml/2006/main" prst="rect">
             <a:avLst/>
@@ -4025,7 +4025,7 @@
           <p:cNvPr id="11" name="">
             <a:extLst xmlns:a="http://schemas.openxmlformats.org/drawingml/2006/main">
               <a:ext uri="{FF2B5EF4-FFF2-40B4-BE49-F238E27FC236}">
-                <a16:creationId xmlns:a16="http://schemas.microsoft.com/office/drawing/2014/main" id="{1B287512-685A-429C-AF1A-9C0A32745BB6}"/>
+                <a16:creationId xmlns:a16="http://schemas.microsoft.com/office/drawing/2014/main" id="{2A7E7B3B-53D8-4279-89FC-2B6B4FD617DA}"/>
               </a:ext>
             </a:extLst>
           </p:cNvPr>
@@ -4035,13 +4035,13 @@
           <p:nvPr/>
         </p:nvPicPr>
         <p:blipFill>
-          <a:blip xmlns:r="http://schemas.openxmlformats.org/officeDocument/2006/relationships" xmlns:a="http://schemas.openxmlformats.org/drawingml/2006/main" r:embed="R53328cb080c54e4e"/>
+          <a:blip xmlns:r="http://schemas.openxmlformats.org/officeDocument/2006/relationships" xmlns:a="http://schemas.openxmlformats.org/drawingml/2006/main" r:embed="R8bf883e9e56545ae"/>
           <a:stretch xmlns:a="http://schemas.openxmlformats.org/drawingml/2006/main"/>
         </p:blipFill>
         <p:spPr>
           <a:xfrm xmlns:a="http://schemas.openxmlformats.org/drawingml/2006/main">
-            <a:off x="9048750" y="1924050"/>
-            <a:ext cx="1952625" cy="4225681"/>
+            <a:off x="8858250" y="1524000"/>
+            <a:ext cx="2245519" cy="4859533"/>
           </a:xfrm>
           <a:prstGeom xmlns:a="http://schemas.openxmlformats.org/drawingml/2006/main" prst="rect">
             <a:avLst/>
@@ -4051,7 +4051,7 @@
     </p:spTree>
     <p:extLst>
       <p:ext uri="{BB962C8B-B14F-4D97-AF65-F5344CB8AC3E}">
-        <p14:creationId xmlns:p14="http://schemas.microsoft.com/office/powerpoint/2010/main" val="2084690499"/>
+        <p14:creationId xmlns:p14="http://schemas.microsoft.com/office/powerpoint/2010/main" val="1064723711"/>
       </p:ext>
     </p:extLst>
   </p:cSld>
@@ -4075,7 +4075,7 @@
           <p:cNvPr id="15" name="HOW IT WORKS">
             <a:extLst xmlns:a="http://schemas.openxmlformats.org/drawingml/2006/main">
               <a:ext uri="{FF2B5EF4-FFF2-40B4-BE49-F238E27FC236}">
-                <a16:creationId xmlns:a16="http://schemas.microsoft.com/office/drawing/2014/main" id="{CAD5870D-F62F-4AA1-9540-BD9784FC91B2}"/>
+                <a16:creationId xmlns:a16="http://schemas.microsoft.com/office/drawing/2014/main" id="{E3F2B191-AA03-4A2D-A411-AD8F08554609}"/>
               </a:ext>
             </a:extLst>
           </p:cNvPr>
@@ -4143,7 +4143,7 @@
           <p:cNvPr id="2" name="AI 결과와 현장 확인을 구분합니다">
             <a:extLst xmlns:a="http://schemas.openxmlformats.org/drawingml/2006/main">
               <a:ext uri="{FF2B5EF4-FFF2-40B4-BE49-F238E27FC236}">
-                <a16:creationId xmlns:a16="http://schemas.microsoft.com/office/drawing/2014/main" id="{17FD0708-12B4-4ED0-BB8F-6692023CB9AD}"/>
+                <a16:creationId xmlns:a16="http://schemas.microsoft.com/office/drawing/2014/main" id="{CE8EBF19-365F-4780-B2F5-D3523968F0FA}"/>
               </a:ext>
             </a:extLst>
           </p:cNvPr>
@@ -4211,7 +4211,7 @@
           <p:cNvPr id="3" name="안전반장 · TEAM 0x02">
             <a:extLst xmlns:a="http://schemas.openxmlformats.org/drawingml/2006/main">
               <a:ext uri="{FF2B5EF4-FFF2-40B4-BE49-F238E27FC236}">
-                <a16:creationId xmlns:a16="http://schemas.microsoft.com/office/drawing/2014/main" id="{8845318D-DD75-472F-BF59-79E68965FEEC}"/>
+                <a16:creationId xmlns:a16="http://schemas.microsoft.com/office/drawing/2014/main" id="{02EAAAE7-7037-42C4-AFE6-2C811A995FC5}"/>
               </a:ext>
             </a:extLst>
           </p:cNvPr>
@@ -4279,7 +4279,7 @@
           <p:cNvPr id="4" name="11 / 14">
             <a:extLst xmlns:a="http://schemas.openxmlformats.org/drawingml/2006/main">
               <a:ext uri="{FF2B5EF4-FFF2-40B4-BE49-F238E27FC236}">
-                <a16:creationId xmlns:a16="http://schemas.microsoft.com/office/drawing/2014/main" id="{17D382F8-D0C6-4B2D-AFC5-C4D7A270ACCC}"/>
+                <a16:creationId xmlns:a16="http://schemas.microsoft.com/office/drawing/2014/main" id="{3AF0829E-BA45-418D-9128-CA9776931FE0}"/>
               </a:ext>
             </a:extLst>
           </p:cNvPr>
@@ -4347,7 +4347,7 @@
           <p:cNvPr id="5" name="작업 조건">
             <a:extLst xmlns:a="http://schemas.openxmlformats.org/drawingml/2006/main">
               <a:ext uri="{FF2B5EF4-FFF2-40B4-BE49-F238E27FC236}">
-                <a16:creationId xmlns:a16="http://schemas.microsoft.com/office/drawing/2014/main" id="{EB6CE13D-7F17-45F3-ACB0-BCFFB57F5020}"/>
+                <a16:creationId xmlns:a16="http://schemas.microsoft.com/office/drawing/2014/main" id="{798AC86D-85B8-4C48-82A1-B0B151C4E182}"/>
               </a:ext>
             </a:extLst>
           </p:cNvPr>
@@ -4415,7 +4415,7 @@
           <p:cNvPr id="6" name="문장에서 조건 추출">
             <a:extLst xmlns:a="http://schemas.openxmlformats.org/drawingml/2006/main">
               <a:ext uri="{FF2B5EF4-FFF2-40B4-BE49-F238E27FC236}">
-                <a16:creationId xmlns:a16="http://schemas.microsoft.com/office/drawing/2014/main" id="{08D39D2F-10EF-4824-BB43-499C0BB330D3}"/>
+                <a16:creationId xmlns:a16="http://schemas.microsoft.com/office/drawing/2014/main" id="{511049DE-B5BA-46F8-8CAE-43D6B97B29F5}"/>
               </a:ext>
             </a:extLst>
           </p:cNvPr>
@@ -4483,7 +4483,7 @@
           <p:cNvPr id="7" name="미확인 조건은 질문으로 남김&#10;규칙으로 필수·권장 수칙 구성">
             <a:extLst xmlns:a="http://schemas.openxmlformats.org/drawingml/2006/main">
               <a:ext uri="{FF2B5EF4-FFF2-40B4-BE49-F238E27FC236}">
-                <a16:creationId xmlns:a16="http://schemas.microsoft.com/office/drawing/2014/main" id="{A6F85A39-8A4C-409E-9D31-BCE07FD46219}"/>
+                <a16:creationId xmlns:a16="http://schemas.microsoft.com/office/drawing/2014/main" id="{016149F1-0E63-498A-9107-68F9337B99AF}"/>
               </a:ext>
             </a:extLst>
           </p:cNvPr>
@@ -4597,7 +4597,7 @@
           <p:cNvPr id="8" name="사진 판정">
             <a:extLst xmlns:a="http://schemas.openxmlformats.org/drawingml/2006/main">
               <a:ext uri="{FF2B5EF4-FFF2-40B4-BE49-F238E27FC236}">
-                <a16:creationId xmlns:a16="http://schemas.microsoft.com/office/drawing/2014/main" id="{8D06F03D-5BBB-4897-B6AD-892C327337E8}"/>
+                <a16:creationId xmlns:a16="http://schemas.microsoft.com/office/drawing/2014/main" id="{AAF69D4E-065B-42F5-930B-3B0EECC8E783}"/>
               </a:ext>
             </a:extLst>
           </p:cNvPr>
@@ -4665,7 +4665,7 @@
           <p:cNvPr id="9" name="확인됨 후보 추가 검증">
             <a:extLst xmlns:a="http://schemas.openxmlformats.org/drawingml/2006/main">
               <a:ext uri="{FF2B5EF4-FFF2-40B4-BE49-F238E27FC236}">
-                <a16:creationId xmlns:a16="http://schemas.microsoft.com/office/drawing/2014/main" id="{5E80FBCE-89A8-4B70-9BD1-A0D421960879}"/>
+                <a16:creationId xmlns:a16="http://schemas.microsoft.com/office/drawing/2014/main" id="{B84D71C5-0129-4F01-8C33-9BA24FFE7518}"/>
               </a:ext>
             </a:extLst>
           </p:cNvPr>
@@ -4733,7 +4733,7 @@
           <p:cNvPr id="10" name="검증이 어려우면 판단불가&#10;어두운 사진은 재촬영 안내&#10;관리자">
             <a:extLst xmlns:a="http://schemas.openxmlformats.org/drawingml/2006/main">
               <a:ext uri="{FF2B5EF4-FFF2-40B4-BE49-F238E27FC236}">
-                <a16:creationId xmlns:a16="http://schemas.microsoft.com/office/drawing/2014/main" id="{1B311A5C-4CC6-413C-A374-4D4404EEF8A0}"/>
+                <a16:creationId xmlns:a16="http://schemas.microsoft.com/office/drawing/2014/main" id="{B35D48CD-A759-4897-914C-203ABFDDA062}"/>
               </a:ext>
             </a:extLst>
           </p:cNvPr>
@@ -4847,7 +4847,7 @@
           <p:cNvPr id="11" name="TBM 점검">
             <a:extLst xmlns:a="http://schemas.openxmlformats.org/drawingml/2006/main">
               <a:ext uri="{FF2B5EF4-FFF2-40B4-BE49-F238E27FC236}">
-                <a16:creationId xmlns:a16="http://schemas.microsoft.com/office/drawing/2014/main" id="{5B5338D4-D182-4791-A83F-FA5C8480FABE}"/>
+                <a16:creationId xmlns:a16="http://schemas.microsoft.com/office/drawing/2014/main" id="{714E5745-F1C7-4790-8B19-C20CE17C2182}"/>
               </a:ext>
             </a:extLst>
           </p:cNvPr>
@@ -4915,7 +4915,7 @@
           <p:cNvPr id="12" name="필수 수칙과 발언 비교">
             <a:extLst xmlns:a="http://schemas.openxmlformats.org/drawingml/2006/main">
               <a:ext uri="{FF2B5EF4-FFF2-40B4-BE49-F238E27FC236}">
-                <a16:creationId xmlns:a16="http://schemas.microsoft.com/office/drawing/2014/main" id="{270AB63F-9FBB-498B-8A33-E7A0DA3A1EC5}"/>
+                <a16:creationId xmlns:a16="http://schemas.microsoft.com/office/drawing/2014/main" id="{2F130F26-91AF-42D4-B358-8B8587B8DA16}"/>
               </a:ext>
             </a:extLst>
           </p:cNvPr>
@@ -4983,7 +4983,7 @@
           <p:cNvPr id="13" name="현재는 규칙·표현 별칭 비교&#10;빠진 수칙을 목록으로 안내&#10;반">
             <a:extLst xmlns:a="http://schemas.openxmlformats.org/drawingml/2006/main">
               <a:ext uri="{FF2B5EF4-FFF2-40B4-BE49-F238E27FC236}">
-                <a16:creationId xmlns:a16="http://schemas.microsoft.com/office/drawing/2014/main" id="{3077D807-F766-4633-B091-684317EAF211}"/>
+                <a16:creationId xmlns:a16="http://schemas.microsoft.com/office/drawing/2014/main" id="{BDFBE061-E84C-475D-87FF-7AE43394A126}"/>
               </a:ext>
             </a:extLst>
           </p:cNvPr>
@@ -5097,7 +5097,7 @@
           <p:cNvPr id="14" name="사진 밖의 상황과 현장 전체의 안전은 사람이 확인해야 합니">
             <a:extLst xmlns:a="http://schemas.openxmlformats.org/drawingml/2006/main">
               <a:ext uri="{FF2B5EF4-FFF2-40B4-BE49-F238E27FC236}">
-                <a16:creationId xmlns:a16="http://schemas.microsoft.com/office/drawing/2014/main" id="{5434E8E5-CDC5-4E57-A73E-C5409C1A4682}"/>
+                <a16:creationId xmlns:a16="http://schemas.microsoft.com/office/drawing/2014/main" id="{7467F468-85D7-4012-867C-FC0432A7E841}"/>
               </a:ext>
             </a:extLst>
           </p:cNvPr>
@@ -5163,7 +5163,7 @@
     </p:spTree>
     <p:extLst>
       <p:ext uri="{BB962C8B-B14F-4D97-AF65-F5344CB8AC3E}">
-        <p14:creationId xmlns:p14="http://schemas.microsoft.com/office/powerpoint/2010/main" val="649114879"/>
+        <p14:creationId xmlns:p14="http://schemas.microsoft.com/office/powerpoint/2010/main" val="321415334"/>
       </p:ext>
     </p:extLst>
   </p:cSld>
@@ -5187,7 +5187,7 @@
           <p:cNvPr id="16" name="VALIDATION">
             <a:extLst xmlns:a="http://schemas.openxmlformats.org/drawingml/2006/main">
               <a:ext uri="{FF2B5EF4-FFF2-40B4-BE49-F238E27FC236}">
-                <a16:creationId xmlns:a16="http://schemas.microsoft.com/office/drawing/2014/main" id="{D8DBB30D-6945-434C-A696-1C8D503F8387}"/>
+                <a16:creationId xmlns:a16="http://schemas.microsoft.com/office/drawing/2014/main" id="{0DB8A8E9-FEFF-41F9-89B2-3003C7A76F08}"/>
               </a:ext>
             </a:extLst>
           </p:cNvPr>
@@ -5255,7 +5255,7 @@
           <p:cNvPr id="2" name="개발 실험을 확인했고, 현장 검증이 남았습니다">
             <a:extLst xmlns:a="http://schemas.openxmlformats.org/drawingml/2006/main">
               <a:ext uri="{FF2B5EF4-FFF2-40B4-BE49-F238E27FC236}">
-                <a16:creationId xmlns:a16="http://schemas.microsoft.com/office/drawing/2014/main" id="{015E8092-5923-477A-8BD6-96186A1D6011}"/>
+                <a16:creationId xmlns:a16="http://schemas.microsoft.com/office/drawing/2014/main" id="{F108C1CE-FF84-4EB1-B865-BC47CC66E97C}"/>
               </a:ext>
             </a:extLst>
           </p:cNvPr>
@@ -5323,7 +5323,7 @@
           <p:cNvPr id="3" name="안전반장 · TEAM 0x02">
             <a:extLst xmlns:a="http://schemas.openxmlformats.org/drawingml/2006/main">
               <a:ext uri="{FF2B5EF4-FFF2-40B4-BE49-F238E27FC236}">
-                <a16:creationId xmlns:a16="http://schemas.microsoft.com/office/drawing/2014/main" id="{A8F686EA-F00B-42D2-9E5A-06016E38536D}"/>
+                <a16:creationId xmlns:a16="http://schemas.microsoft.com/office/drawing/2014/main" id="{AC9870C1-6DD8-4C8D-9F27-16C3E648DC44}"/>
               </a:ext>
             </a:extLst>
           </p:cNvPr>
@@ -5391,7 +5391,7 @@
           <p:cNvPr id="4" name="12 / 14">
             <a:extLst xmlns:a="http://schemas.openxmlformats.org/drawingml/2006/main">
               <a:ext uri="{FF2B5EF4-FFF2-40B4-BE49-F238E27FC236}">
-                <a16:creationId xmlns:a16="http://schemas.microsoft.com/office/drawing/2014/main" id="{D8933DB0-F93F-4A2E-A329-CA4A10EE6C08}"/>
+                <a16:creationId xmlns:a16="http://schemas.microsoft.com/office/drawing/2014/main" id="{3F6C1DBD-3168-4B3D-B78E-80BC63DC7549}"/>
               </a:ext>
             </a:extLst>
           </p:cNvPr>
@@ -5459,7 +5459,7 @@
           <p:cNvPr id="5" name="98회">
             <a:extLst xmlns:a="http://schemas.openxmlformats.org/drawingml/2006/main">
               <a:ext uri="{FF2B5EF4-FFF2-40B4-BE49-F238E27FC236}">
-                <a16:creationId xmlns:a16="http://schemas.microsoft.com/office/drawing/2014/main" id="{1DDFD293-3E2E-4EF6-A58E-C24EA3F845B0}"/>
+                <a16:creationId xmlns:a16="http://schemas.microsoft.com/office/drawing/2014/main" id="{D7DA1DBC-6A61-47EA-8D87-F4AA4BB06646}"/>
               </a:ext>
             </a:extLst>
           </p:cNvPr>
@@ -5527,7 +5527,7 @@
           <p:cNvPr id="6" name="작업 10건 · 사진 88건">
             <a:extLst xmlns:a="http://schemas.openxmlformats.org/drawingml/2006/main">
               <a:ext uri="{FF2B5EF4-FFF2-40B4-BE49-F238E27FC236}">
-                <a16:creationId xmlns:a16="http://schemas.microsoft.com/office/drawing/2014/main" id="{CC6BD491-8D29-4A25-ACC8-2BCCF77D99F6}"/>
+                <a16:creationId xmlns:a16="http://schemas.microsoft.com/office/drawing/2014/main" id="{ECF253CF-634F-4233-BFF6-C4F5ABD1A048}"/>
               </a:ext>
             </a:extLst>
           </p:cNvPr>
@@ -5595,7 +5595,7 @@
           <p:cNvPr id="7" name="기존 실제 API 개발 실험&#10;이번 화면 캡처는 mock">
             <a:extLst xmlns:a="http://schemas.openxmlformats.org/drawingml/2006/main">
               <a:ext uri="{FF2B5EF4-FFF2-40B4-BE49-F238E27FC236}">
-                <a16:creationId xmlns:a16="http://schemas.microsoft.com/office/drawing/2014/main" id="{C822CBBE-0E0F-4281-A4CA-21E1840DC9F7}"/>
+                <a16:creationId xmlns:a16="http://schemas.microsoft.com/office/drawing/2014/main" id="{9BB22856-803D-427A-AB54-B5161732B4D3}"/>
               </a:ext>
             </a:extLst>
           </p:cNvPr>
@@ -5686,7 +5686,7 @@
           <p:cNvPr id="8" name="28 / 28">
             <a:extLst xmlns:a="http://schemas.openxmlformats.org/drawingml/2006/main">
               <a:ext uri="{FF2B5EF4-FFF2-40B4-BE49-F238E27FC236}">
-                <a16:creationId xmlns:a16="http://schemas.microsoft.com/office/drawing/2014/main" id="{336752AF-5DBB-469E-BCCC-20CC6379DBD0}"/>
+                <a16:creationId xmlns:a16="http://schemas.microsoft.com/office/drawing/2014/main" id="{F85DD314-E12A-433E-A34A-20860D5FBB2D}"/>
               </a:ext>
             </a:extLst>
           </p:cNvPr>
@@ -5754,7 +5754,7 @@
           <p:cNvPr id="9" name="작업 조건 점검 통과">
             <a:extLst xmlns:a="http://schemas.openxmlformats.org/drawingml/2006/main">
               <a:ext uri="{FF2B5EF4-FFF2-40B4-BE49-F238E27FC236}">
-                <a16:creationId xmlns:a16="http://schemas.microsoft.com/office/drawing/2014/main" id="{9487798B-5D53-4AD0-B6AE-017A583D75C9}"/>
+                <a16:creationId xmlns:a16="http://schemas.microsoft.com/office/drawing/2014/main" id="{2C8468AC-9C11-4FAD-948E-056138F3BCEA}"/>
               </a:ext>
             </a:extLst>
           </p:cNvPr>
@@ -5822,7 +5822,7 @@
           <p:cNvPr id="10" name="작업 조건 테스트 항목 결과&#10;제품 전체 정확도 아님">
             <a:extLst xmlns:a="http://schemas.openxmlformats.org/drawingml/2006/main">
               <a:ext uri="{FF2B5EF4-FFF2-40B4-BE49-F238E27FC236}">
-                <a16:creationId xmlns:a16="http://schemas.microsoft.com/office/drawing/2014/main" id="{B7ACF4B6-4370-44F1-9029-45ECF4126673}"/>
+                <a16:creationId xmlns:a16="http://schemas.microsoft.com/office/drawing/2014/main" id="{2E8C2E13-95DB-478B-81C4-D9ABCFBB97CD}"/>
               </a:ext>
             </a:extLst>
           </p:cNvPr>
@@ -5913,7 +5913,7 @@
           <p:cNvPr id="11" name="1.75초">
             <a:extLst xmlns:a="http://schemas.openxmlformats.org/drawingml/2006/main">
               <a:ext uri="{FF2B5EF4-FFF2-40B4-BE49-F238E27FC236}">
-                <a16:creationId xmlns:a16="http://schemas.microsoft.com/office/drawing/2014/main" id="{9A50B63D-9C48-4A65-B286-0F33BBC2AC4E}"/>
+                <a16:creationId xmlns:a16="http://schemas.microsoft.com/office/drawing/2014/main" id="{A9BF8D2B-BC63-475C-BA47-E9BAE69FB277}"/>
               </a:ext>
             </a:extLst>
           </p:cNvPr>
@@ -5981,7 +5981,7 @@
           <p:cNvPr id="12" name="중앙 실행 시간">
             <a:extLst xmlns:a="http://schemas.openxmlformats.org/drawingml/2006/main">
               <a:ext uri="{FF2B5EF4-FFF2-40B4-BE49-F238E27FC236}">
-                <a16:creationId xmlns:a16="http://schemas.microsoft.com/office/drawing/2014/main" id="{60475C3E-D3FA-4D2F-9CCA-6F6ED927628C}"/>
+                <a16:creationId xmlns:a16="http://schemas.microsoft.com/office/drawing/2014/main" id="{726C0CE9-3777-4402-8E85-A22571BE876D}"/>
               </a:ext>
             </a:extLst>
           </p:cNvPr>
@@ -6049,7 +6049,7 @@
           <p:cNvPr id="13" name="동일 개발 실험의 p50&#10;실제 현장 응답 보장 아님">
             <a:extLst xmlns:a="http://schemas.openxmlformats.org/drawingml/2006/main">
               <a:ext uri="{FF2B5EF4-FFF2-40B4-BE49-F238E27FC236}">
-                <a16:creationId xmlns:a16="http://schemas.microsoft.com/office/drawing/2014/main" id="{4F1010C9-36B9-4C5F-92D8-0039385BCA3D}"/>
+                <a16:creationId xmlns:a16="http://schemas.microsoft.com/office/drawing/2014/main" id="{7F85C3CD-B73B-4B17-A0F4-A7CDC906DD47}"/>
               </a:ext>
             </a:extLst>
           </p:cNvPr>
@@ -6140,7 +6140,7 @@
           <p:cNvPr id="14" name="사진 라벨은 사람 검수 전 후보입니다">
             <a:extLst xmlns:a="http://schemas.openxmlformats.org/drawingml/2006/main">
               <a:ext uri="{FF2B5EF4-FFF2-40B4-BE49-F238E27FC236}">
-                <a16:creationId xmlns:a16="http://schemas.microsoft.com/office/drawing/2014/main" id="{BC07E0A3-2912-4921-8FC3-86C487298448}"/>
+                <a16:creationId xmlns:a16="http://schemas.microsoft.com/office/drawing/2014/main" id="{7173554F-0E65-4148-B889-F2CD7137183B}"/>
               </a:ext>
             </a:extLst>
           </p:cNvPr>
@@ -6208,7 +6208,7 @@
           <p:cNvPr id="15" name="사진 판정 정확도·사고 감소 효과는 아직 입증하지 않았습니">
             <a:extLst xmlns:a="http://schemas.openxmlformats.org/drawingml/2006/main">
               <a:ext uri="{FF2B5EF4-FFF2-40B4-BE49-F238E27FC236}">
-                <a16:creationId xmlns:a16="http://schemas.microsoft.com/office/drawing/2014/main" id="{9980389A-F506-45D3-AC28-E9FC61E96C9D}"/>
+                <a16:creationId xmlns:a16="http://schemas.microsoft.com/office/drawing/2014/main" id="{5BB7A30B-1072-4C67-9592-ECCF3A38C02C}"/>
               </a:ext>
             </a:extLst>
           </p:cNvPr>
@@ -6274,7 +6274,7 @@
     </p:spTree>
     <p:extLst>
       <p:ext uri="{BB962C8B-B14F-4D97-AF65-F5344CB8AC3E}">
-        <p14:creationId xmlns:p14="http://schemas.microsoft.com/office/powerpoint/2010/main" val="176588704"/>
+        <p14:creationId xmlns:p14="http://schemas.microsoft.com/office/powerpoint/2010/main" val="1846519427"/>
       </p:ext>
     </p:extLst>
   </p:cSld>
@@ -6298,7 +6298,7 @@
           <p:cNvPr id="10" name="NEXT STEP">
             <a:extLst xmlns:a="http://schemas.openxmlformats.org/drawingml/2006/main">
               <a:ext uri="{FF2B5EF4-FFF2-40B4-BE49-F238E27FC236}">
-                <a16:creationId xmlns:a16="http://schemas.microsoft.com/office/drawing/2014/main" id="{9928B900-E55B-4C50-A9A4-A30806996C88}"/>
+                <a16:creationId xmlns:a16="http://schemas.microsoft.com/office/drawing/2014/main" id="{7365F37E-270C-4E0D-92E1-7E2BA77CA2AD}"/>
               </a:ext>
             </a:extLst>
           </p:cNvPr>
@@ -6366,7 +6366,7 @@
           <p:cNvPr id="2" name="반장 단독 도입부터 현장 파일럿으로 검증합니다">
             <a:extLst xmlns:a="http://schemas.openxmlformats.org/drawingml/2006/main">
               <a:ext uri="{FF2B5EF4-FFF2-40B4-BE49-F238E27FC236}">
-                <a16:creationId xmlns:a16="http://schemas.microsoft.com/office/drawing/2014/main" id="{6702D989-75CD-4152-9110-77873ADC4E64}"/>
+                <a16:creationId xmlns:a16="http://schemas.microsoft.com/office/drawing/2014/main" id="{F430574C-75A1-4D2B-A712-FF77C71095EE}"/>
               </a:ext>
             </a:extLst>
           </p:cNvPr>
@@ -6434,7 +6434,7 @@
           <p:cNvPr id="3" name="안전반장 · TEAM 0x02">
             <a:extLst xmlns:a="http://schemas.openxmlformats.org/drawingml/2006/main">
               <a:ext uri="{FF2B5EF4-FFF2-40B4-BE49-F238E27FC236}">
-                <a16:creationId xmlns:a16="http://schemas.microsoft.com/office/drawing/2014/main" id="{121E035C-C1E3-44F4-B847-242B84BE1587}"/>
+                <a16:creationId xmlns:a16="http://schemas.microsoft.com/office/drawing/2014/main" id="{C72ADEE7-9224-4684-902C-5A6990AD49CB}"/>
               </a:ext>
             </a:extLst>
           </p:cNvPr>
@@ -6502,7 +6502,7 @@
           <p:cNvPr id="4" name="13 / 14">
             <a:extLst xmlns:a="http://schemas.openxmlformats.org/drawingml/2006/main">
               <a:ext uri="{FF2B5EF4-FFF2-40B4-BE49-F238E27FC236}">
-                <a16:creationId xmlns:a16="http://schemas.microsoft.com/office/drawing/2014/main" id="{90EB9A67-F8E3-4D41-8433-17DF1628A2D9}"/>
+                <a16:creationId xmlns:a16="http://schemas.microsoft.com/office/drawing/2014/main" id="{1F8F7A12-562F-42A0-A32D-AF8D30566689}"/>
               </a:ext>
             </a:extLst>
           </p:cNvPr>
@@ -6570,7 +6570,7 @@
           <p:cNvPr id="5" name="먼저 검증할 사용 흐름">
             <a:extLst xmlns:a="http://schemas.openxmlformats.org/drawingml/2006/main">
               <a:ext uri="{FF2B5EF4-FFF2-40B4-BE49-F238E27FC236}">
-                <a16:creationId xmlns:a16="http://schemas.microsoft.com/office/drawing/2014/main" id="{C6C04BDD-2799-47B3-BC62-B8C6AF3E5D90}"/>
+                <a16:creationId xmlns:a16="http://schemas.microsoft.com/office/drawing/2014/main" id="{E1ABC026-E31F-46FF-827D-3DD063B625DF}"/>
               </a:ext>
             </a:extLst>
           </p:cNvPr>
@@ -6638,7 +6638,7 @@
           <p:cNvPr id="6" name="반장 단독으로 작업 등록·기록 확인&#10;&#10;근로자 참여 후 사진">
             <a:extLst xmlns:a="http://schemas.openxmlformats.org/drawingml/2006/main">
               <a:ext uri="{FF2B5EF4-FFF2-40B4-BE49-F238E27FC236}">
-                <a16:creationId xmlns:a16="http://schemas.microsoft.com/office/drawing/2014/main" id="{E55AE44E-D6ED-4FF6-BB53-436EE1DD19D6}"/>
+                <a16:creationId xmlns:a16="http://schemas.microsoft.com/office/drawing/2014/main" id="{89ACC9B5-6054-45F9-922C-77020FBF080B}"/>
               </a:ext>
             </a:extLst>
           </p:cNvPr>
@@ -6762,7 +6762,7 @@
           <p:cNvPr id="7" name="파일럿에서 측정할 항목">
             <a:extLst xmlns:a="http://schemas.openxmlformats.org/drawingml/2006/main">
               <a:ext uri="{FF2B5EF4-FFF2-40B4-BE49-F238E27FC236}">
-                <a16:creationId xmlns:a16="http://schemas.microsoft.com/office/drawing/2014/main" id="{F278F1F0-8FB0-477C-AD3E-2D0195A7AA58}"/>
+                <a16:creationId xmlns:a16="http://schemas.microsoft.com/office/drawing/2014/main" id="{87239F6D-8CED-49B9-8FB2-44D4A183BFFC}"/>
               </a:ext>
             </a:extLst>
           </p:cNvPr>
@@ -6830,7 +6830,7 @@
           <p:cNvPr id="8" name="작업 등록과 증빙 확인에 걸리는 시간&#10;&#10;누락 조치의 보완·">
             <a:extLst xmlns:a="http://schemas.openxmlformats.org/drawingml/2006/main">
               <a:ext uri="{FF2B5EF4-FFF2-40B4-BE49-F238E27FC236}">
-                <a16:creationId xmlns:a16="http://schemas.microsoft.com/office/drawing/2014/main" id="{B75BA52E-DAAA-46A8-8E08-994C3EFCE7A6}"/>
+                <a16:creationId xmlns:a16="http://schemas.microsoft.com/office/drawing/2014/main" id="{BB41E8A6-477A-4856-8024-26CD619152C1}"/>
               </a:ext>
             </a:extLst>
           </p:cNvPr>
@@ -6954,7 +6954,7 @@
           <p:cNvPr id="9" name="도입 계획입니다. 고객 수·절감률·사고 감소 효과는 아직 ">
             <a:extLst xmlns:a="http://schemas.openxmlformats.org/drawingml/2006/main">
               <a:ext uri="{FF2B5EF4-FFF2-40B4-BE49-F238E27FC236}">
-                <a16:creationId xmlns:a16="http://schemas.microsoft.com/office/drawing/2014/main" id="{41D33C7C-0FE4-491F-B23B-D0E8B87484B7}"/>
+                <a16:creationId xmlns:a16="http://schemas.microsoft.com/office/drawing/2014/main" id="{3102C5AD-3FA9-4BC1-A4CC-2163AC304643}"/>
               </a:ext>
             </a:extLst>
           </p:cNvPr>
@@ -7020,7 +7020,7 @@
     </p:spTree>
     <p:extLst>
       <p:ext uri="{BB962C8B-B14F-4D97-AF65-F5344CB8AC3E}">
-        <p14:creationId xmlns:p14="http://schemas.microsoft.com/office/powerpoint/2010/main" val="1532168430"/>
+        <p14:creationId xmlns:p14="http://schemas.microsoft.com/office/powerpoint/2010/main" val="1675643708"/>
       </p:ext>
     </p:extLst>
   </p:cSld>
@@ -7044,7 +7044,7 @@
           <p:cNvPr id="8" name="안전반장">
             <a:extLst xmlns:a="http://schemas.openxmlformats.org/drawingml/2006/main">
               <a:ext uri="{FF2B5EF4-FFF2-40B4-BE49-F238E27FC236}">
-                <a16:creationId xmlns:a16="http://schemas.microsoft.com/office/drawing/2014/main" id="{4F0BE1CB-3801-4E37-AEE6-AE3F0AEFCA79}"/>
+                <a16:creationId xmlns:a16="http://schemas.microsoft.com/office/drawing/2014/main" id="{70C1EF07-E672-4F8D-B375-0141FC5AFE59}"/>
               </a:ext>
             </a:extLst>
           </p:cNvPr>
@@ -7112,7 +7112,7 @@
           <p:cNvPr id="2" name="작업 전 공유부터 조치 기록까지">
             <a:extLst xmlns:a="http://schemas.openxmlformats.org/drawingml/2006/main">
               <a:ext uri="{FF2B5EF4-FFF2-40B4-BE49-F238E27FC236}">
-                <a16:creationId xmlns:a16="http://schemas.microsoft.com/office/drawing/2014/main" id="{25770FAD-2CC1-4763-875A-FFCCBB49839A}"/>
+                <a16:creationId xmlns:a16="http://schemas.microsoft.com/office/drawing/2014/main" id="{765D26EA-7FF1-452D-82BC-513C8B32AE80}"/>
               </a:ext>
             </a:extLst>
           </p:cNvPr>
@@ -7180,7 +7180,7 @@
           <p:cNvPr id="3" name="안전반장 · TEAM 0x02">
             <a:extLst xmlns:a="http://schemas.openxmlformats.org/drawingml/2006/main">
               <a:ext uri="{FF2B5EF4-FFF2-40B4-BE49-F238E27FC236}">
-                <a16:creationId xmlns:a16="http://schemas.microsoft.com/office/drawing/2014/main" id="{9B212DD4-43F8-47AF-B76C-348BFEFD9393}"/>
+                <a16:creationId xmlns:a16="http://schemas.microsoft.com/office/drawing/2014/main" id="{F6BAC04F-6B44-44CB-ABBF-14F9111B91BC}"/>
               </a:ext>
             </a:extLst>
           </p:cNvPr>
@@ -7248,7 +7248,7 @@
           <p:cNvPr id="4" name="14 / 14">
             <a:extLst xmlns:a="http://schemas.openxmlformats.org/drawingml/2006/main">
               <a:ext uri="{FF2B5EF4-FFF2-40B4-BE49-F238E27FC236}">
-                <a16:creationId xmlns:a16="http://schemas.microsoft.com/office/drawing/2014/main" id="{7BF749C4-D535-42F1-9B5F-7E5DD1DD7391}"/>
+                <a16:creationId xmlns:a16="http://schemas.microsoft.com/office/drawing/2014/main" id="{9A1C57A0-0AC1-4283-AEBB-6226F4E4E541}"/>
               </a:ext>
             </a:extLst>
           </p:cNvPr>
@@ -7316,7 +7316,7 @@
           <p:cNvPr id="5" name="작업 전에 함께 확인하고,&#10;작업 뒤에 조치를 남깁니다">
             <a:extLst xmlns:a="http://schemas.openxmlformats.org/drawingml/2006/main">
               <a:ext uri="{FF2B5EF4-FFF2-40B4-BE49-F238E27FC236}">
-                <a16:creationId xmlns:a16="http://schemas.microsoft.com/office/drawing/2014/main" id="{9A9BE0F0-7FB0-4188-9BA1-57DED5EFF673}"/>
+                <a16:creationId xmlns:a16="http://schemas.microsoft.com/office/drawing/2014/main" id="{4BD4624F-C946-48F6-A765-E83FE1A81BF1}"/>
               </a:ext>
             </a:extLst>
           </p:cNvPr>
@@ -7407,7 +7407,7 @@
           <p:cNvPr id="6" name="작은 현장의 반장과 근로자를 잇는 안전 관리 앱">
             <a:extLst xmlns:a="http://schemas.openxmlformats.org/drawingml/2006/main">
               <a:ext uri="{FF2B5EF4-FFF2-40B4-BE49-F238E27FC236}">
-                <a16:creationId xmlns:a16="http://schemas.microsoft.com/office/drawing/2014/main" id="{36F3001D-AF56-4D0D-A530-239620629C14}"/>
+                <a16:creationId xmlns:a16="http://schemas.microsoft.com/office/drawing/2014/main" id="{528C0424-3535-4B00-BE68-7A33E146747A}"/>
               </a:ext>
             </a:extLst>
           </p:cNvPr>
@@ -7475,7 +7475,7 @@
           <p:cNvPr id="7" name="사진에 보이는 조치 확인을 돕고,&#10;확인이 어려우면 관리자에">
             <a:extLst xmlns:a="http://schemas.openxmlformats.org/drawingml/2006/main">
               <a:ext uri="{FF2B5EF4-FFF2-40B4-BE49-F238E27FC236}">
-                <a16:creationId xmlns:a16="http://schemas.microsoft.com/office/drawing/2014/main" id="{4388C817-F06E-414A-8C41-A51682A366A8}"/>
+                <a16:creationId xmlns:a16="http://schemas.microsoft.com/office/drawing/2014/main" id="{31770B89-7E48-47BD-9A50-517CEB8526E1}"/>
               </a:ext>
             </a:extLst>
           </p:cNvPr>
@@ -7564,7 +7564,7 @@
     </p:spTree>
     <p:extLst>
       <p:ext uri="{BB962C8B-B14F-4D97-AF65-F5344CB8AC3E}">
-        <p14:creationId xmlns:p14="http://schemas.microsoft.com/office/powerpoint/2010/main" val="593257444"/>
+        <p14:creationId xmlns:p14="http://schemas.microsoft.com/office/powerpoint/2010/main" val="1642524887"/>
       </p:ext>
     </p:extLst>
   </p:cSld>
@@ -7588,7 +7588,7 @@
           <p:cNvPr id="2" name="Shape 0">
             <a:extLst xmlns:a="http://schemas.openxmlformats.org/drawingml/2006/main">
               <a:ext uri="{FF2B5EF4-FFF2-40B4-BE49-F238E27FC236}">
-                <a16:creationId xmlns:a16="http://schemas.microsoft.com/office/drawing/2014/main" id="{CE33908C-1E4D-40B6-9FAC-8171AB38BBB4}"/>
+                <a16:creationId xmlns:a16="http://schemas.microsoft.com/office/drawing/2014/main" id="{0272FADD-C36E-444B-8AB8-8CCB8D1E0DA7}"/>
               </a:ext>
             </a:extLst>
           </p:cNvPr>
@@ -7617,7 +7617,7 @@
           <p:cNvPr id="3" name="Text 1">
             <a:extLst xmlns:a="http://schemas.openxmlformats.org/drawingml/2006/main">
               <a:ext uri="{FF2B5EF4-FFF2-40B4-BE49-F238E27FC236}">
-                <a16:creationId xmlns:a16="http://schemas.microsoft.com/office/drawing/2014/main" id="{4AC35D76-4AA3-47AA-88A6-CC53CB048AD9}"/>
+                <a16:creationId xmlns:a16="http://schemas.microsoft.com/office/drawing/2014/main" id="{4822E4D7-F48B-49C1-BDC2-1638AE30647B}"/>
               </a:ext>
             </a:extLst>
           </p:cNvPr>
@@ -7668,7 +7668,7 @@
           <p:cNvPr id="4" name="Text 2">
             <a:extLst xmlns:a="http://schemas.openxmlformats.org/drawingml/2006/main">
               <a:ext uri="{FF2B5EF4-FFF2-40B4-BE49-F238E27FC236}">
-                <a16:creationId xmlns:a16="http://schemas.microsoft.com/office/drawing/2014/main" id="{678B90C9-0E5D-4AB8-B7DE-7BF6D472A20A}"/>
+                <a16:creationId xmlns:a16="http://schemas.microsoft.com/office/drawing/2014/main" id="{EAD77BB1-CBA5-4B5B-992F-303C5292B021}"/>
               </a:ext>
             </a:extLst>
           </p:cNvPr>
@@ -7721,7 +7721,7 @@
           <p:cNvPr id="5" name="Shape 3">
             <a:extLst xmlns:a="http://schemas.openxmlformats.org/drawingml/2006/main">
               <a:ext uri="{FF2B5EF4-FFF2-40B4-BE49-F238E27FC236}">
-                <a16:creationId xmlns:a16="http://schemas.microsoft.com/office/drawing/2014/main" id="{8C58E62C-F67F-41F2-BB72-ADAB8799A75B}"/>
+                <a16:creationId xmlns:a16="http://schemas.microsoft.com/office/drawing/2014/main" id="{17AB6DD8-DC3B-4B15-9518-1365C5B598EB}"/>
               </a:ext>
             </a:extLst>
           </p:cNvPr>
@@ -7763,7 +7763,7 @@
           <p:cNvPr id="6" name="Text 4">
             <a:extLst xmlns:a="http://schemas.openxmlformats.org/drawingml/2006/main">
               <a:ext uri="{FF2B5EF4-FFF2-40B4-BE49-F238E27FC236}">
-                <a16:creationId xmlns:a16="http://schemas.microsoft.com/office/drawing/2014/main" id="{A0BAA8E9-7029-40DA-9BB5-A78B2964696E}"/>
+                <a16:creationId xmlns:a16="http://schemas.microsoft.com/office/drawing/2014/main" id="{8A4A2034-6344-4E59-8F64-45A9B0529796}"/>
               </a:ext>
             </a:extLst>
           </p:cNvPr>
@@ -7814,7 +7814,7 @@
           <p:cNvPr id="7" name="Shape 5">
             <a:extLst xmlns:a="http://schemas.openxmlformats.org/drawingml/2006/main">
               <a:ext uri="{FF2B5EF4-FFF2-40B4-BE49-F238E27FC236}">
-                <a16:creationId xmlns:a16="http://schemas.microsoft.com/office/drawing/2014/main" id="{E81A7B94-9462-4E1B-B810-3248B02CDFF7}"/>
+                <a16:creationId xmlns:a16="http://schemas.microsoft.com/office/drawing/2014/main" id="{36641C77-18FB-49D5-A43C-8125F830022D}"/>
               </a:ext>
             </a:extLst>
           </p:cNvPr>
@@ -7841,7 +7841,7 @@
           <p:cNvPr id="8" name="Text 6">
             <a:extLst xmlns:a="http://schemas.openxmlformats.org/drawingml/2006/main">
               <a:ext uri="{FF2B5EF4-FFF2-40B4-BE49-F238E27FC236}">
-                <a16:creationId xmlns:a16="http://schemas.microsoft.com/office/drawing/2014/main" id="{D04B325F-11A8-4450-A2A9-EFEE04EA28F5}"/>
+                <a16:creationId xmlns:a16="http://schemas.microsoft.com/office/drawing/2014/main" id="{AB42C0F2-F491-4332-BBB8-24CC04059EDC}"/>
               </a:ext>
             </a:extLst>
           </p:cNvPr>
@@ -7911,7 +7911,7 @@
           <p:cNvPr id="9" name="Text 7">
             <a:extLst xmlns:a="http://schemas.openxmlformats.org/drawingml/2006/main">
               <a:ext uri="{FF2B5EF4-FFF2-40B4-BE49-F238E27FC236}">
-                <a16:creationId xmlns:a16="http://schemas.microsoft.com/office/drawing/2014/main" id="{840CE66B-65D4-465C-9FD6-527C58A1A2E7}"/>
+                <a16:creationId xmlns:a16="http://schemas.microsoft.com/office/drawing/2014/main" id="{FCD67409-84BA-4C5E-AC0D-2ECA334AB8E5}"/>
               </a:ext>
             </a:extLst>
           </p:cNvPr>
@@ -7962,7 +7962,7 @@
           <p:cNvPr id="10" name="Shape 8">
             <a:extLst xmlns:a="http://schemas.openxmlformats.org/drawingml/2006/main">
               <a:ext uri="{FF2B5EF4-FFF2-40B4-BE49-F238E27FC236}">
-                <a16:creationId xmlns:a16="http://schemas.microsoft.com/office/drawing/2014/main" id="{C2C8F211-BA08-49B8-8F5E-C266EA6501E2}"/>
+                <a16:creationId xmlns:a16="http://schemas.microsoft.com/office/drawing/2014/main" id="{0697F931-E15E-4435-84D0-EF2FFA2AAA81}"/>
               </a:ext>
             </a:extLst>
           </p:cNvPr>
@@ -8004,7 +8004,7 @@
           <p:cNvPr id="11" name="Text 9">
             <a:extLst xmlns:a="http://schemas.openxmlformats.org/drawingml/2006/main">
               <a:ext uri="{FF2B5EF4-FFF2-40B4-BE49-F238E27FC236}">
-                <a16:creationId xmlns:a16="http://schemas.microsoft.com/office/drawing/2014/main" id="{318E6A07-F57F-4BA5-AB91-4CE0C95F797C}"/>
+                <a16:creationId xmlns:a16="http://schemas.microsoft.com/office/drawing/2014/main" id="{F059E79C-4A28-4B08-B116-217CA4E0F384}"/>
               </a:ext>
             </a:extLst>
           </p:cNvPr>
@@ -8055,7 +8055,7 @@
           <p:cNvPr id="12" name="Text 10">
             <a:extLst xmlns:a="http://schemas.openxmlformats.org/drawingml/2006/main">
               <a:ext uri="{FF2B5EF4-FFF2-40B4-BE49-F238E27FC236}">
-                <a16:creationId xmlns:a16="http://schemas.microsoft.com/office/drawing/2014/main" id="{1CB45D6B-9489-4482-B39C-A26489ED219B}"/>
+                <a16:creationId xmlns:a16="http://schemas.microsoft.com/office/drawing/2014/main" id="{C50D0907-C63C-4835-BDAF-C8A7C7AD2BB8}"/>
               </a:ext>
             </a:extLst>
           </p:cNvPr>
@@ -8106,7 +8106,7 @@
           <p:cNvPr id="13" name="Text 11">
             <a:extLst xmlns:a="http://schemas.openxmlformats.org/drawingml/2006/main">
               <a:ext uri="{FF2B5EF4-FFF2-40B4-BE49-F238E27FC236}">
-                <a16:creationId xmlns:a16="http://schemas.microsoft.com/office/drawing/2014/main" id="{95A93FE5-7585-4F45-9B5A-3213C992D52C}"/>
+                <a16:creationId xmlns:a16="http://schemas.microsoft.com/office/drawing/2014/main" id="{8A949CB9-F54F-47E9-8492-6794ED420EB5}"/>
               </a:ext>
             </a:extLst>
           </p:cNvPr>
@@ -8157,7 +8157,7 @@
           <p:cNvPr id="14" name="Shape 12">
             <a:extLst xmlns:a="http://schemas.openxmlformats.org/drawingml/2006/main">
               <a:ext uri="{FF2B5EF4-FFF2-40B4-BE49-F238E27FC236}">
-                <a16:creationId xmlns:a16="http://schemas.microsoft.com/office/drawing/2014/main" id="{55187B3F-A592-460A-A969-835576B2A8C6}"/>
+                <a16:creationId xmlns:a16="http://schemas.microsoft.com/office/drawing/2014/main" id="{5459F6C2-9CAB-4D50-93A9-A9A62B730A60}"/>
               </a:ext>
             </a:extLst>
           </p:cNvPr>
@@ -8188,7 +8188,7 @@
           <p:cNvPr id="15" name="Text 13">
             <a:extLst xmlns:a="http://schemas.openxmlformats.org/drawingml/2006/main">
               <a:ext uri="{FF2B5EF4-FFF2-40B4-BE49-F238E27FC236}">
-                <a16:creationId xmlns:a16="http://schemas.microsoft.com/office/drawing/2014/main" id="{5ED519C8-EC85-4705-BF01-8458FA8634C5}"/>
+                <a16:creationId xmlns:a16="http://schemas.microsoft.com/office/drawing/2014/main" id="{83C76A90-F13E-4A69-8C2D-68131DA351AF}"/>
               </a:ext>
             </a:extLst>
           </p:cNvPr>
@@ -8239,7 +8239,7 @@
           <p:cNvPr id="16" name="Text 14">
             <a:extLst xmlns:a="http://schemas.openxmlformats.org/drawingml/2006/main">
               <a:ext uri="{FF2B5EF4-FFF2-40B4-BE49-F238E27FC236}">
-                <a16:creationId xmlns:a16="http://schemas.microsoft.com/office/drawing/2014/main" id="{65A22155-F4C1-45E4-85B6-1E3B53ADD90C}"/>
+                <a16:creationId xmlns:a16="http://schemas.microsoft.com/office/drawing/2014/main" id="{5B2702CA-0019-4B2D-8BDC-4E7A83648217}"/>
               </a:ext>
             </a:extLst>
           </p:cNvPr>
@@ -8290,7 +8290,7 @@
           <p:cNvPr id="17" name="Text 15">
             <a:extLst xmlns:a="http://schemas.openxmlformats.org/drawingml/2006/main">
               <a:ext uri="{FF2B5EF4-FFF2-40B4-BE49-F238E27FC236}">
-                <a16:creationId xmlns:a16="http://schemas.microsoft.com/office/drawing/2014/main" id="{B34085DF-02AB-48F1-B9C4-75F9ABC5C953}"/>
+                <a16:creationId xmlns:a16="http://schemas.microsoft.com/office/drawing/2014/main" id="{E5E64F18-C73B-41D1-94CE-BCBFD3AB6C22}"/>
               </a:ext>
             </a:extLst>
           </p:cNvPr>
@@ -8341,7 +8341,7 @@
           <p:cNvPr id="18" name="Shape 16">
             <a:extLst xmlns:a="http://schemas.openxmlformats.org/drawingml/2006/main">
               <a:ext uri="{FF2B5EF4-FFF2-40B4-BE49-F238E27FC236}">
-                <a16:creationId xmlns:a16="http://schemas.microsoft.com/office/drawing/2014/main" id="{43A25459-D561-4581-A79F-99199735D1FB}"/>
+                <a16:creationId xmlns:a16="http://schemas.microsoft.com/office/drawing/2014/main" id="{74A05FDF-3248-4913-A118-3273C241DD9D}"/>
               </a:ext>
             </a:extLst>
           </p:cNvPr>
@@ -8372,7 +8372,7 @@
           <p:cNvPr id="19" name="Text 17">
             <a:extLst xmlns:a="http://schemas.openxmlformats.org/drawingml/2006/main">
               <a:ext uri="{FF2B5EF4-FFF2-40B4-BE49-F238E27FC236}">
-                <a16:creationId xmlns:a16="http://schemas.microsoft.com/office/drawing/2014/main" id="{FFFB4BEF-3D11-41AE-BE93-21697CFCA86D}"/>
+                <a16:creationId xmlns:a16="http://schemas.microsoft.com/office/drawing/2014/main" id="{9812B33E-D637-4F74-8AE5-9536B3F9BFFE}"/>
               </a:ext>
             </a:extLst>
           </p:cNvPr>
@@ -8423,7 +8423,7 @@
           <p:cNvPr id="20" name="Text 18">
             <a:extLst xmlns:a="http://schemas.openxmlformats.org/drawingml/2006/main">
               <a:ext uri="{FF2B5EF4-FFF2-40B4-BE49-F238E27FC236}">
-                <a16:creationId xmlns:a16="http://schemas.microsoft.com/office/drawing/2014/main" id="{B5DB8577-78B3-40F0-A443-5B863CB85F94}"/>
+                <a16:creationId xmlns:a16="http://schemas.microsoft.com/office/drawing/2014/main" id="{D66237FE-3618-4B58-B07A-D41D739B119E}"/>
               </a:ext>
             </a:extLst>
           </p:cNvPr>
@@ -8474,7 +8474,7 @@
           <p:cNvPr id="21" name="Text 19">
             <a:extLst xmlns:a="http://schemas.openxmlformats.org/drawingml/2006/main">
               <a:ext uri="{FF2B5EF4-FFF2-40B4-BE49-F238E27FC236}">
-                <a16:creationId xmlns:a16="http://schemas.microsoft.com/office/drawing/2014/main" id="{F19E1433-29B3-4967-9959-038E58871418}"/>
+                <a16:creationId xmlns:a16="http://schemas.microsoft.com/office/drawing/2014/main" id="{E3647493-E417-48EF-8A96-E5E6FFEF4A1C}"/>
               </a:ext>
             </a:extLst>
           </p:cNvPr>
@@ -8525,7 +8525,7 @@
           <p:cNvPr id="22" name="Shape 20">
             <a:extLst xmlns:a="http://schemas.openxmlformats.org/drawingml/2006/main">
               <a:ext uri="{FF2B5EF4-FFF2-40B4-BE49-F238E27FC236}">
-                <a16:creationId xmlns:a16="http://schemas.microsoft.com/office/drawing/2014/main" id="{BFF422E0-7184-44A4-BE9B-4A84361826DD}"/>
+                <a16:creationId xmlns:a16="http://schemas.microsoft.com/office/drawing/2014/main" id="{FCFD4D8E-A30C-4460-8402-5229C53BCCB9}"/>
               </a:ext>
             </a:extLst>
           </p:cNvPr>
@@ -8554,7 +8554,7 @@
           <p:cNvPr id="23" name="Text 21">
             <a:extLst xmlns:a="http://schemas.openxmlformats.org/drawingml/2006/main">
               <a:ext uri="{FF2B5EF4-FFF2-40B4-BE49-F238E27FC236}">
-                <a16:creationId xmlns:a16="http://schemas.microsoft.com/office/drawing/2014/main" id="{E38F7283-4705-4305-8455-5D66B6056538}"/>
+                <a16:creationId xmlns:a16="http://schemas.microsoft.com/office/drawing/2014/main" id="{B17C863C-A0CB-4EA8-A2C2-F0FE10FBF762}"/>
               </a:ext>
             </a:extLst>
           </p:cNvPr>
@@ -8609,7 +8609,7 @@
           <p:cNvPr id="24" name="Text 22">
             <a:extLst xmlns:a="http://schemas.openxmlformats.org/drawingml/2006/main">
               <a:ext uri="{FF2B5EF4-FFF2-40B4-BE49-F238E27FC236}">
-                <a16:creationId xmlns:a16="http://schemas.microsoft.com/office/drawing/2014/main" id="{0E3B52A7-6006-4B03-9AD0-61522B3A91EB}"/>
+                <a16:creationId xmlns:a16="http://schemas.microsoft.com/office/drawing/2014/main" id="{293D9597-7CF8-4786-B052-CA2BB4D744D7}"/>
               </a:ext>
             </a:extLst>
           </p:cNvPr>
@@ -8660,7 +8660,7 @@
           <p:cNvPr id="25" name="Text 23">
             <a:extLst xmlns:a="http://schemas.openxmlformats.org/drawingml/2006/main">
               <a:ext uri="{FF2B5EF4-FFF2-40B4-BE49-F238E27FC236}">
-                <a16:creationId xmlns:a16="http://schemas.microsoft.com/office/drawing/2014/main" id="{14A3FEC1-B78A-4916-ACCD-80E0F52D4630}"/>
+                <a16:creationId xmlns:a16="http://schemas.microsoft.com/office/drawing/2014/main" id="{BEF21062-666C-4451-BCB6-4CBEF4EC5CBE}"/>
               </a:ext>
             </a:extLst>
           </p:cNvPr>
@@ -8711,7 +8711,7 @@
           <p:cNvPr id="26" name="Text 24">
             <a:extLst xmlns:a="http://schemas.openxmlformats.org/drawingml/2006/main">
               <a:ext uri="{FF2B5EF4-FFF2-40B4-BE49-F238E27FC236}">
-                <a16:creationId xmlns:a16="http://schemas.microsoft.com/office/drawing/2014/main" id="{1F42830A-1BA6-4990-95F1-757BD254A531}"/>
+                <a16:creationId xmlns:a16="http://schemas.microsoft.com/office/drawing/2014/main" id="{5A86B786-21FF-409E-B5AA-E25125128A6D}"/>
               </a:ext>
             </a:extLst>
           </p:cNvPr>
@@ -8760,7 +8760,7 @@
     </p:spTree>
     <p:extLst>
       <p:ext uri="{BB962C8B-B14F-4D97-AF65-F5344CB8AC3E}">
-        <p14:creationId xmlns:p14="http://schemas.microsoft.com/office/powerpoint/2010/main" val="1889959410"/>
+        <p14:creationId xmlns:p14="http://schemas.microsoft.com/office/powerpoint/2010/main" val="1469549630"/>
       </p:ext>
     </p:extLst>
   </p:cSld>
@@ -8784,7 +8784,7 @@
           <p:cNvPr id="2" name="Shape 0">
             <a:extLst xmlns:a="http://schemas.openxmlformats.org/drawingml/2006/main">
               <a:ext uri="{FF2B5EF4-FFF2-40B4-BE49-F238E27FC236}">
-                <a16:creationId xmlns:a16="http://schemas.microsoft.com/office/drawing/2014/main" id="{B04ABE32-367B-49D2-BB3F-A288779A679D}"/>
+                <a16:creationId xmlns:a16="http://schemas.microsoft.com/office/drawing/2014/main" id="{6979DF80-EF5C-4145-91CE-8A445E3632F8}"/>
               </a:ext>
             </a:extLst>
           </p:cNvPr>
@@ -8813,7 +8813,7 @@
           <p:cNvPr id="3" name="Text 1">
             <a:extLst xmlns:a="http://schemas.openxmlformats.org/drawingml/2006/main">
               <a:ext uri="{FF2B5EF4-FFF2-40B4-BE49-F238E27FC236}">
-                <a16:creationId xmlns:a16="http://schemas.microsoft.com/office/drawing/2014/main" id="{021B0FB7-C097-4218-9656-DAAC1C8A5C52}"/>
+                <a16:creationId xmlns:a16="http://schemas.microsoft.com/office/drawing/2014/main" id="{00008C3A-0CC8-479B-801B-7F1336EDA8BF}"/>
               </a:ext>
             </a:extLst>
           </p:cNvPr>
@@ -8864,7 +8864,7 @@
           <p:cNvPr id="4" name="Text 2">
             <a:extLst xmlns:a="http://schemas.openxmlformats.org/drawingml/2006/main">
               <a:ext uri="{FF2B5EF4-FFF2-40B4-BE49-F238E27FC236}">
-                <a16:creationId xmlns:a16="http://schemas.microsoft.com/office/drawing/2014/main" id="{689E606F-5BBA-4753-9431-EDAA9ECB2B46}"/>
+                <a16:creationId xmlns:a16="http://schemas.microsoft.com/office/drawing/2014/main" id="{20C77136-F83B-4ECF-B6A8-FB8986D78504}"/>
               </a:ext>
             </a:extLst>
           </p:cNvPr>
@@ -8917,7 +8917,7 @@
           <p:cNvPr id="5" name="Shape 3">
             <a:extLst xmlns:a="http://schemas.openxmlformats.org/drawingml/2006/main">
               <a:ext uri="{FF2B5EF4-FFF2-40B4-BE49-F238E27FC236}">
-                <a16:creationId xmlns:a16="http://schemas.microsoft.com/office/drawing/2014/main" id="{B4B6F323-E681-4727-A1DE-C0FC9B456798}"/>
+                <a16:creationId xmlns:a16="http://schemas.microsoft.com/office/drawing/2014/main" id="{6784DFB3-25D3-43C5-B64F-1558231A9310}"/>
               </a:ext>
             </a:extLst>
           </p:cNvPr>
@@ -8959,7 +8959,7 @@
           <p:cNvPr id="6" name="Text 4">
             <a:extLst xmlns:a="http://schemas.openxmlformats.org/drawingml/2006/main">
               <a:ext uri="{FF2B5EF4-FFF2-40B4-BE49-F238E27FC236}">
-                <a16:creationId xmlns:a16="http://schemas.microsoft.com/office/drawing/2014/main" id="{464F34B6-B841-4419-9B48-48366B92E01E}"/>
+                <a16:creationId xmlns:a16="http://schemas.microsoft.com/office/drawing/2014/main" id="{2DD91A0A-D3F6-4276-9AA7-5F440C6E0BBB}"/>
               </a:ext>
             </a:extLst>
           </p:cNvPr>
@@ -9014,7 +9014,7 @@
           <p:cNvPr id="7" name="Text 5">
             <a:extLst xmlns:a="http://schemas.openxmlformats.org/drawingml/2006/main">
               <a:ext uri="{FF2B5EF4-FFF2-40B4-BE49-F238E27FC236}">
-                <a16:creationId xmlns:a16="http://schemas.microsoft.com/office/drawing/2014/main" id="{42948164-B41A-44CF-B349-CD4AFA0E4EA0}"/>
+                <a16:creationId xmlns:a16="http://schemas.microsoft.com/office/drawing/2014/main" id="{31344ED5-5059-4177-BF94-2E2B332B5FCC}"/>
               </a:ext>
             </a:extLst>
           </p:cNvPr>
@@ -9065,7 +9065,7 @@
           <p:cNvPr id="8" name="Text 6">
             <a:extLst xmlns:a="http://schemas.openxmlformats.org/drawingml/2006/main">
               <a:ext uri="{FF2B5EF4-FFF2-40B4-BE49-F238E27FC236}">
-                <a16:creationId xmlns:a16="http://schemas.microsoft.com/office/drawing/2014/main" id="{CF8E1668-98FA-4F68-A4F5-8C983542E92C}"/>
+                <a16:creationId xmlns:a16="http://schemas.microsoft.com/office/drawing/2014/main" id="{5AAF3A8D-6E90-468F-9ECD-1A13DF758023}"/>
               </a:ext>
             </a:extLst>
           </p:cNvPr>
@@ -9136,7 +9136,7 @@
           <p:cNvPr id="9" name="Shape 7">
             <a:extLst xmlns:a="http://schemas.openxmlformats.org/drawingml/2006/main">
               <a:ext uri="{FF2B5EF4-FFF2-40B4-BE49-F238E27FC236}">
-                <a16:creationId xmlns:a16="http://schemas.microsoft.com/office/drawing/2014/main" id="{284D4441-B0BA-448E-A68E-DB596ACD66C7}"/>
+                <a16:creationId xmlns:a16="http://schemas.microsoft.com/office/drawing/2014/main" id="{B419F31C-C46E-4CD9-AACA-9053240A84EB}"/>
               </a:ext>
             </a:extLst>
           </p:cNvPr>
@@ -9167,7 +9167,7 @@
           <p:cNvPr id="10" name="Text 8">
             <a:extLst xmlns:a="http://schemas.openxmlformats.org/drawingml/2006/main">
               <a:ext uri="{FF2B5EF4-FFF2-40B4-BE49-F238E27FC236}">
-                <a16:creationId xmlns:a16="http://schemas.microsoft.com/office/drawing/2014/main" id="{9E9CFA00-F9A7-4DD5-B64F-8EE8F1C6F08E}"/>
+                <a16:creationId xmlns:a16="http://schemas.microsoft.com/office/drawing/2014/main" id="{A933BD71-EC0C-41C8-810C-2B207439074F}"/>
               </a:ext>
             </a:extLst>
           </p:cNvPr>
@@ -9218,7 +9218,7 @@
           <p:cNvPr id="11" name="Shape 9">
             <a:extLst xmlns:a="http://schemas.openxmlformats.org/drawingml/2006/main">
               <a:ext uri="{FF2B5EF4-FFF2-40B4-BE49-F238E27FC236}">
-                <a16:creationId xmlns:a16="http://schemas.microsoft.com/office/drawing/2014/main" id="{5959539D-4302-4800-938D-090513AEBB50}"/>
+                <a16:creationId xmlns:a16="http://schemas.microsoft.com/office/drawing/2014/main" id="{CD685F57-AE99-4811-86F7-CDD413A9508C}"/>
               </a:ext>
             </a:extLst>
           </p:cNvPr>
@@ -9260,7 +9260,7 @@
           <p:cNvPr id="12" name="Text 10">
             <a:extLst xmlns:a="http://schemas.openxmlformats.org/drawingml/2006/main">
               <a:ext uri="{FF2B5EF4-FFF2-40B4-BE49-F238E27FC236}">
-                <a16:creationId xmlns:a16="http://schemas.microsoft.com/office/drawing/2014/main" id="{27B7E06F-4A26-49E4-931F-932551C1502B}"/>
+                <a16:creationId xmlns:a16="http://schemas.microsoft.com/office/drawing/2014/main" id="{81044B42-C185-426D-9915-52A37E169534}"/>
               </a:ext>
             </a:extLst>
           </p:cNvPr>
@@ -9315,7 +9315,7 @@
           <p:cNvPr id="13" name="Text 11">
             <a:extLst xmlns:a="http://schemas.openxmlformats.org/drawingml/2006/main">
               <a:ext uri="{FF2B5EF4-FFF2-40B4-BE49-F238E27FC236}">
-                <a16:creationId xmlns:a16="http://schemas.microsoft.com/office/drawing/2014/main" id="{E93CF8CD-BA14-4226-9229-282C3BA0F7BC}"/>
+                <a16:creationId xmlns:a16="http://schemas.microsoft.com/office/drawing/2014/main" id="{CBD99F48-5968-431B-BDFD-10BC0C41B728}"/>
               </a:ext>
             </a:extLst>
           </p:cNvPr>
@@ -9366,7 +9366,7 @@
           <p:cNvPr id="14" name="Text 12">
             <a:extLst xmlns:a="http://schemas.openxmlformats.org/drawingml/2006/main">
               <a:ext uri="{FF2B5EF4-FFF2-40B4-BE49-F238E27FC236}">
-                <a16:creationId xmlns:a16="http://schemas.microsoft.com/office/drawing/2014/main" id="{3E32E5B0-83DD-4609-85D3-D22C3055D9FA}"/>
+                <a16:creationId xmlns:a16="http://schemas.microsoft.com/office/drawing/2014/main" id="{FB987DAB-35B7-4FE8-9337-ECCD89733E6D}"/>
               </a:ext>
             </a:extLst>
           </p:cNvPr>
@@ -9437,7 +9437,7 @@
           <p:cNvPr id="15" name="Shape 13">
             <a:extLst xmlns:a="http://schemas.openxmlformats.org/drawingml/2006/main">
               <a:ext uri="{FF2B5EF4-FFF2-40B4-BE49-F238E27FC236}">
-                <a16:creationId xmlns:a16="http://schemas.microsoft.com/office/drawing/2014/main" id="{A2D061E4-DFA0-4D79-98E9-54D55EDACBDA}"/>
+                <a16:creationId xmlns:a16="http://schemas.microsoft.com/office/drawing/2014/main" id="{C09A4C28-588F-40C3-ABF0-A7F9E3A07563}"/>
               </a:ext>
             </a:extLst>
           </p:cNvPr>
@@ -9468,7 +9468,7 @@
           <p:cNvPr id="16" name="Text 14">
             <a:extLst xmlns:a="http://schemas.openxmlformats.org/drawingml/2006/main">
               <a:ext uri="{FF2B5EF4-FFF2-40B4-BE49-F238E27FC236}">
-                <a16:creationId xmlns:a16="http://schemas.microsoft.com/office/drawing/2014/main" id="{FB564381-6961-4F29-B62F-A4CBC861E499}"/>
+                <a16:creationId xmlns:a16="http://schemas.microsoft.com/office/drawing/2014/main" id="{A2139007-2967-45B8-8BA9-3D14E2CD3637}"/>
               </a:ext>
             </a:extLst>
           </p:cNvPr>
@@ -9519,7 +9519,7 @@
           <p:cNvPr id="17" name="Shape 15">
             <a:extLst xmlns:a="http://schemas.openxmlformats.org/drawingml/2006/main">
               <a:ext uri="{FF2B5EF4-FFF2-40B4-BE49-F238E27FC236}">
-                <a16:creationId xmlns:a16="http://schemas.microsoft.com/office/drawing/2014/main" id="{23196560-A108-4E57-B206-59FD6681345B}"/>
+                <a16:creationId xmlns:a16="http://schemas.microsoft.com/office/drawing/2014/main" id="{59B75123-D0FF-44BA-A07A-86C860C697D4}"/>
               </a:ext>
             </a:extLst>
           </p:cNvPr>
@@ -9548,7 +9548,7 @@
           <p:cNvPr id="18" name="Text 16">
             <a:extLst xmlns:a="http://schemas.openxmlformats.org/drawingml/2006/main">
               <a:ext uri="{FF2B5EF4-FFF2-40B4-BE49-F238E27FC236}">
-                <a16:creationId xmlns:a16="http://schemas.microsoft.com/office/drawing/2014/main" id="{99978779-EA0F-437D-879D-E0897B8E027D}"/>
+                <a16:creationId xmlns:a16="http://schemas.microsoft.com/office/drawing/2014/main" id="{C89FB891-9846-45F1-9AB1-4D164539963A}"/>
               </a:ext>
             </a:extLst>
           </p:cNvPr>
@@ -9599,7 +9599,7 @@
           <p:cNvPr id="19" name="Text 17">
             <a:extLst xmlns:a="http://schemas.openxmlformats.org/drawingml/2006/main">
               <a:ext uri="{FF2B5EF4-FFF2-40B4-BE49-F238E27FC236}">
-                <a16:creationId xmlns:a16="http://schemas.microsoft.com/office/drawing/2014/main" id="{2925485B-C0FA-4A9C-AFE8-EB104BFE986D}"/>
+                <a16:creationId xmlns:a16="http://schemas.microsoft.com/office/drawing/2014/main" id="{8800DC2D-EF45-47BC-9EC5-792CEF793101}"/>
               </a:ext>
             </a:extLst>
           </p:cNvPr>
@@ -9669,7 +9669,7 @@
           <p:cNvPr id="20" name="Text 18">
             <a:extLst xmlns:a="http://schemas.openxmlformats.org/drawingml/2006/main">
               <a:ext uri="{FF2B5EF4-FFF2-40B4-BE49-F238E27FC236}">
-                <a16:creationId xmlns:a16="http://schemas.microsoft.com/office/drawing/2014/main" id="{95BB19BF-5B6F-4945-AFF6-92678D0BA452}"/>
+                <a16:creationId xmlns:a16="http://schemas.microsoft.com/office/drawing/2014/main" id="{50DDE0E4-2E4A-47C7-B8E5-376305D999A6}"/>
               </a:ext>
             </a:extLst>
           </p:cNvPr>
@@ -9720,7 +9720,7 @@
           <p:cNvPr id="21" name="Text 19">
             <a:extLst xmlns:a="http://schemas.openxmlformats.org/drawingml/2006/main">
               <a:ext uri="{FF2B5EF4-FFF2-40B4-BE49-F238E27FC236}">
-                <a16:creationId xmlns:a16="http://schemas.microsoft.com/office/drawing/2014/main" id="{322C126D-9D60-48F2-9AD5-AEE86EA49483}"/>
+                <a16:creationId xmlns:a16="http://schemas.microsoft.com/office/drawing/2014/main" id="{B1368ED0-0577-453E-8332-7BD547981935}"/>
               </a:ext>
             </a:extLst>
           </p:cNvPr>
@@ -9769,7 +9769,7 @@
     </p:spTree>
     <p:extLst>
       <p:ext uri="{BB962C8B-B14F-4D97-AF65-F5344CB8AC3E}">
-        <p14:creationId xmlns:p14="http://schemas.microsoft.com/office/powerpoint/2010/main" val="1629876865"/>
+        <p14:creationId xmlns:p14="http://schemas.microsoft.com/office/powerpoint/2010/main" val="1026672334"/>
       </p:ext>
     </p:extLst>
   </p:cSld>
@@ -9793,7 +9793,7 @@
           <p:cNvPr id="2" name="Shape 0">
             <a:extLst xmlns:a="http://schemas.openxmlformats.org/drawingml/2006/main">
               <a:ext uri="{FF2B5EF4-FFF2-40B4-BE49-F238E27FC236}">
-                <a16:creationId xmlns:a16="http://schemas.microsoft.com/office/drawing/2014/main" id="{C9F7B7C9-A0FC-4B65-81A6-720B2D8233FB}"/>
+                <a16:creationId xmlns:a16="http://schemas.microsoft.com/office/drawing/2014/main" id="{583A4002-0994-4632-90AD-7070388E6CDF}"/>
               </a:ext>
             </a:extLst>
           </p:cNvPr>
@@ -9822,7 +9822,7 @@
           <p:cNvPr id="3" name="Text 1">
             <a:extLst xmlns:a="http://schemas.openxmlformats.org/drawingml/2006/main">
               <a:ext uri="{FF2B5EF4-FFF2-40B4-BE49-F238E27FC236}">
-                <a16:creationId xmlns:a16="http://schemas.microsoft.com/office/drawing/2014/main" id="{98A30108-91D6-4F98-8C92-0C1547EADE4F}"/>
+                <a16:creationId xmlns:a16="http://schemas.microsoft.com/office/drawing/2014/main" id="{E19439D1-62A5-4346-8546-5C55606A7007}"/>
               </a:ext>
             </a:extLst>
           </p:cNvPr>
@@ -9873,7 +9873,7 @@
           <p:cNvPr id="4" name="Text 2">
             <a:extLst xmlns:a="http://schemas.openxmlformats.org/drawingml/2006/main">
               <a:ext uri="{FF2B5EF4-FFF2-40B4-BE49-F238E27FC236}">
-                <a16:creationId xmlns:a16="http://schemas.microsoft.com/office/drawing/2014/main" id="{9EFB6EA0-67BF-45C2-92E8-BC9B130FBBC2}"/>
+                <a16:creationId xmlns:a16="http://schemas.microsoft.com/office/drawing/2014/main" id="{2DE9DC49-C287-4515-82E7-E0EF32524DB2}"/>
               </a:ext>
             </a:extLst>
           </p:cNvPr>
@@ -9926,7 +9926,7 @@
           <p:cNvPr id="5" name="Shape 3">
             <a:extLst xmlns:a="http://schemas.openxmlformats.org/drawingml/2006/main">
               <a:ext uri="{FF2B5EF4-FFF2-40B4-BE49-F238E27FC236}">
-                <a16:creationId xmlns:a16="http://schemas.microsoft.com/office/drawing/2014/main" id="{2E179EBE-47E6-4C5C-8D00-3053679386EB}"/>
+                <a16:creationId xmlns:a16="http://schemas.microsoft.com/office/drawing/2014/main" id="{135F0169-FC42-4B39-8DC2-034B8A162825}"/>
               </a:ext>
             </a:extLst>
           </p:cNvPr>
@@ -9968,7 +9968,7 @@
           <p:cNvPr id="6" name="Shape 4">
             <a:extLst xmlns:a="http://schemas.openxmlformats.org/drawingml/2006/main">
               <a:ext uri="{FF2B5EF4-FFF2-40B4-BE49-F238E27FC236}">
-                <a16:creationId xmlns:a16="http://schemas.microsoft.com/office/drawing/2014/main" id="{D188F3E9-175A-467B-AEA2-B14E0AA3C1AB}"/>
+                <a16:creationId xmlns:a16="http://schemas.microsoft.com/office/drawing/2014/main" id="{6F0A26C6-18C1-4E68-84EF-666E0C737E63}"/>
               </a:ext>
             </a:extLst>
           </p:cNvPr>
@@ -10015,7 +10015,7 @@
           <p:cNvPr id="7" name="Text 5">
             <a:extLst xmlns:a="http://schemas.openxmlformats.org/drawingml/2006/main">
               <a:ext uri="{FF2B5EF4-FFF2-40B4-BE49-F238E27FC236}">
-                <a16:creationId xmlns:a16="http://schemas.microsoft.com/office/drawing/2014/main" id="{0A0744D8-389C-44D9-970C-B204ACD0F70A}"/>
+                <a16:creationId xmlns:a16="http://schemas.microsoft.com/office/drawing/2014/main" id="{FC23DE39-76B5-4C97-9E52-D98E82F85E63}"/>
               </a:ext>
             </a:extLst>
           </p:cNvPr>
@@ -10066,7 +10066,7 @@
           <p:cNvPr id="8" name="Text 6">
             <a:extLst xmlns:a="http://schemas.openxmlformats.org/drawingml/2006/main">
               <a:ext uri="{FF2B5EF4-FFF2-40B4-BE49-F238E27FC236}">
-                <a16:creationId xmlns:a16="http://schemas.microsoft.com/office/drawing/2014/main" id="{3ACA7D5F-ED25-4B66-81ED-A4D02E7E9CB3}"/>
+                <a16:creationId xmlns:a16="http://schemas.microsoft.com/office/drawing/2014/main" id="{D538A4B8-FC52-48A1-A398-33A2F1E72B56}"/>
               </a:ext>
             </a:extLst>
           </p:cNvPr>
@@ -10119,7 +10119,7 @@
           <p:cNvPr id="9" name="Shape 7">
             <a:extLst xmlns:a="http://schemas.openxmlformats.org/drawingml/2006/main">
               <a:ext uri="{FF2B5EF4-FFF2-40B4-BE49-F238E27FC236}">
-                <a16:creationId xmlns:a16="http://schemas.microsoft.com/office/drawing/2014/main" id="{1497FDE6-FD67-4665-9F4A-C34B3CD40103}"/>
+                <a16:creationId xmlns:a16="http://schemas.microsoft.com/office/drawing/2014/main" id="{9811E1A8-023F-4C4D-8041-4A20F5D8E180}"/>
               </a:ext>
             </a:extLst>
           </p:cNvPr>
@@ -10150,7 +10150,7 @@
           <p:cNvPr id="10" name="Text 8">
             <a:extLst xmlns:a="http://schemas.openxmlformats.org/drawingml/2006/main">
               <a:ext uri="{FF2B5EF4-FFF2-40B4-BE49-F238E27FC236}">
-                <a16:creationId xmlns:a16="http://schemas.microsoft.com/office/drawing/2014/main" id="{911270B6-7CB3-4063-B017-22B134AE1F45}"/>
+                <a16:creationId xmlns:a16="http://schemas.microsoft.com/office/drawing/2014/main" id="{F6C8B902-68BE-43E8-A7C5-A636D06428C3}"/>
               </a:ext>
             </a:extLst>
           </p:cNvPr>
@@ -10201,7 +10201,7 @@
           <p:cNvPr id="11" name="Text 9">
             <a:extLst xmlns:a="http://schemas.openxmlformats.org/drawingml/2006/main">
               <a:ext uri="{FF2B5EF4-FFF2-40B4-BE49-F238E27FC236}">
-                <a16:creationId xmlns:a16="http://schemas.microsoft.com/office/drawing/2014/main" id="{8CA21E50-50CE-4C2B-BE79-92F45BA25975}"/>
+                <a16:creationId xmlns:a16="http://schemas.microsoft.com/office/drawing/2014/main" id="{CA3B49DB-E612-4CAF-83D7-C3FEFDA42591}"/>
               </a:ext>
             </a:extLst>
           </p:cNvPr>
@@ -10252,7 +10252,7 @@
           <p:cNvPr id="12" name="Shape 10">
             <a:extLst xmlns:a="http://schemas.openxmlformats.org/drawingml/2006/main">
               <a:ext uri="{FF2B5EF4-FFF2-40B4-BE49-F238E27FC236}">
-                <a16:creationId xmlns:a16="http://schemas.microsoft.com/office/drawing/2014/main" id="{4BDB77C4-45BA-476C-9E0C-0F2825AB2C4A}"/>
+                <a16:creationId xmlns:a16="http://schemas.microsoft.com/office/drawing/2014/main" id="{40C28816-78AF-4A21-9B07-585B1E195715}"/>
               </a:ext>
             </a:extLst>
           </p:cNvPr>
@@ -10283,7 +10283,7 @@
           <p:cNvPr id="13" name="Text 11">
             <a:extLst xmlns:a="http://schemas.openxmlformats.org/drawingml/2006/main">
               <a:ext uri="{FF2B5EF4-FFF2-40B4-BE49-F238E27FC236}">
-                <a16:creationId xmlns:a16="http://schemas.microsoft.com/office/drawing/2014/main" id="{BA3219EA-C5BF-4840-ADA7-DC2D57767BC7}"/>
+                <a16:creationId xmlns:a16="http://schemas.microsoft.com/office/drawing/2014/main" id="{F0CDFC15-3E44-4155-BB38-22641B1ED1F4}"/>
               </a:ext>
             </a:extLst>
           </p:cNvPr>
@@ -10334,7 +10334,7 @@
           <p:cNvPr id="14" name="Text 12">
             <a:extLst xmlns:a="http://schemas.openxmlformats.org/drawingml/2006/main">
               <a:ext uri="{FF2B5EF4-FFF2-40B4-BE49-F238E27FC236}">
-                <a16:creationId xmlns:a16="http://schemas.microsoft.com/office/drawing/2014/main" id="{1F2D5D74-9591-49E7-B1FC-A666CF526512}"/>
+                <a16:creationId xmlns:a16="http://schemas.microsoft.com/office/drawing/2014/main" id="{A58AA8C3-14AD-4282-9A2C-2980F08FD097}"/>
               </a:ext>
             </a:extLst>
           </p:cNvPr>
@@ -10385,7 +10385,7 @@
           <p:cNvPr id="15" name="Shape 13">
             <a:extLst xmlns:a="http://schemas.openxmlformats.org/drawingml/2006/main">
               <a:ext uri="{FF2B5EF4-FFF2-40B4-BE49-F238E27FC236}">
-                <a16:creationId xmlns:a16="http://schemas.microsoft.com/office/drawing/2014/main" id="{A8243686-730A-4A7B-B4EB-C2A6BCF7FEF2}"/>
+                <a16:creationId xmlns:a16="http://schemas.microsoft.com/office/drawing/2014/main" id="{89852D73-28E9-49B0-8446-3AE2CF13CCCC}"/>
               </a:ext>
             </a:extLst>
           </p:cNvPr>
@@ -10432,7 +10432,7 @@
           <p:cNvPr id="16" name="Text 14">
             <a:extLst xmlns:a="http://schemas.openxmlformats.org/drawingml/2006/main">
               <a:ext uri="{FF2B5EF4-FFF2-40B4-BE49-F238E27FC236}">
-                <a16:creationId xmlns:a16="http://schemas.microsoft.com/office/drawing/2014/main" id="{BF667B7D-AB1B-40DB-8468-F5ED12B55F35}"/>
+                <a16:creationId xmlns:a16="http://schemas.microsoft.com/office/drawing/2014/main" id="{F42AECBD-296A-47D0-98F0-604B21EC0311}"/>
               </a:ext>
             </a:extLst>
           </p:cNvPr>
@@ -10483,7 +10483,7 @@
           <p:cNvPr id="17" name="Text 15">
             <a:extLst xmlns:a="http://schemas.openxmlformats.org/drawingml/2006/main">
               <a:ext uri="{FF2B5EF4-FFF2-40B4-BE49-F238E27FC236}">
-                <a16:creationId xmlns:a16="http://schemas.microsoft.com/office/drawing/2014/main" id="{B6975795-C3C8-43D0-B7F6-9CB1D8E66004}"/>
+                <a16:creationId xmlns:a16="http://schemas.microsoft.com/office/drawing/2014/main" id="{AD112FF9-FEF1-41C4-BB63-76C7B24589FF}"/>
               </a:ext>
             </a:extLst>
           </p:cNvPr>
@@ -10534,7 +10534,7 @@
           <p:cNvPr id="18" name="Shape 16">
             <a:extLst xmlns:a="http://schemas.openxmlformats.org/drawingml/2006/main">
               <a:ext uri="{FF2B5EF4-FFF2-40B4-BE49-F238E27FC236}">
-                <a16:creationId xmlns:a16="http://schemas.microsoft.com/office/drawing/2014/main" id="{C73C93AA-A98A-41A8-A9B8-F1D985C81D81}"/>
+                <a16:creationId xmlns:a16="http://schemas.microsoft.com/office/drawing/2014/main" id="{4EB3CF96-BC24-468E-9785-98D954345F13}"/>
               </a:ext>
             </a:extLst>
           </p:cNvPr>
@@ -10565,7 +10565,7 @@
           <p:cNvPr id="19" name="Text 17">
             <a:extLst xmlns:a="http://schemas.openxmlformats.org/drawingml/2006/main">
               <a:ext uri="{FF2B5EF4-FFF2-40B4-BE49-F238E27FC236}">
-                <a16:creationId xmlns:a16="http://schemas.microsoft.com/office/drawing/2014/main" id="{B6A9DB89-7753-484D-B38A-825FF4A11EBB}"/>
+                <a16:creationId xmlns:a16="http://schemas.microsoft.com/office/drawing/2014/main" id="{27805154-E021-4C2D-97E4-84966A9FC7D4}"/>
               </a:ext>
             </a:extLst>
           </p:cNvPr>
@@ -10616,7 +10616,7 @@
           <p:cNvPr id="20" name="Text 18">
             <a:extLst xmlns:a="http://schemas.openxmlformats.org/drawingml/2006/main">
               <a:ext uri="{FF2B5EF4-FFF2-40B4-BE49-F238E27FC236}">
-                <a16:creationId xmlns:a16="http://schemas.microsoft.com/office/drawing/2014/main" id="{B87C0FAF-9A29-4348-A7AC-DC60EF4575B0}"/>
+                <a16:creationId xmlns:a16="http://schemas.microsoft.com/office/drawing/2014/main" id="{43EC01FF-7C2B-43D1-8097-475E48314834}"/>
               </a:ext>
             </a:extLst>
           </p:cNvPr>
@@ -10667,7 +10667,7 @@
           <p:cNvPr id="21" name="Shape 19">
             <a:extLst xmlns:a="http://schemas.openxmlformats.org/drawingml/2006/main">
               <a:ext uri="{FF2B5EF4-FFF2-40B4-BE49-F238E27FC236}">
-                <a16:creationId xmlns:a16="http://schemas.microsoft.com/office/drawing/2014/main" id="{3AE576D9-D14B-4B9A-9109-331CC8C777E6}"/>
+                <a16:creationId xmlns:a16="http://schemas.microsoft.com/office/drawing/2014/main" id="{1FBA43B5-1009-41DC-A1CD-733FC3892D08}"/>
               </a:ext>
             </a:extLst>
           </p:cNvPr>
@@ -10694,7 +10694,7 @@
           <p:cNvPr id="22" name="Image 0">
             <a:extLst xmlns:a="http://schemas.openxmlformats.org/drawingml/2006/main">
               <a:ext uri="{FF2B5EF4-FFF2-40B4-BE49-F238E27FC236}">
-                <a16:creationId xmlns:a16="http://schemas.microsoft.com/office/drawing/2014/main" id="{B8F7AC64-09C0-433D-816C-6CD6F680D622}"/>
+                <a16:creationId xmlns:a16="http://schemas.microsoft.com/office/drawing/2014/main" id="{6C1A9660-0B4B-464D-B0DD-9FC0E237FFBC}"/>
               </a:ext>
             </a:extLst>
           </p:cNvPr>
@@ -10704,7 +10704,7 @@
           <p:nvPr/>
         </p:nvPicPr>
         <p:blipFill>
-          <a:blip xmlns:r="http://schemas.openxmlformats.org/officeDocument/2006/relationships" xmlns:a="http://schemas.openxmlformats.org/drawingml/2006/main" r:embed="Rafa298a562a746eb"/>
+          <a:blip xmlns:r="http://schemas.openxmlformats.org/officeDocument/2006/relationships" xmlns:a="http://schemas.openxmlformats.org/drawingml/2006/main" r:embed="Rd04ccd20f7bb4dbc"/>
           <a:srcRect xmlns:a="http://schemas.openxmlformats.org/drawingml/2006/main" l="0" t="0" r="0" b="0"/>
           <a:stretch xmlns:a="http://schemas.openxmlformats.org/drawingml/2006/main"/>
         </p:blipFill>
@@ -10723,7 +10723,7 @@
           <p:cNvPr id="23" name="Shape 20">
             <a:extLst xmlns:a="http://schemas.openxmlformats.org/drawingml/2006/main">
               <a:ext uri="{FF2B5EF4-FFF2-40B4-BE49-F238E27FC236}">
-                <a16:creationId xmlns:a16="http://schemas.microsoft.com/office/drawing/2014/main" id="{0C12A77C-99CF-42D6-9F35-DAB6777B6058}"/>
+                <a16:creationId xmlns:a16="http://schemas.microsoft.com/office/drawing/2014/main" id="{F183B16E-147F-4B8D-8384-6592FF24A14D}"/>
               </a:ext>
             </a:extLst>
           </p:cNvPr>
@@ -10754,7 +10754,7 @@
           <p:cNvPr id="24" name="Text 21">
             <a:extLst xmlns:a="http://schemas.openxmlformats.org/drawingml/2006/main">
               <a:ext uri="{FF2B5EF4-FFF2-40B4-BE49-F238E27FC236}">
-                <a16:creationId xmlns:a16="http://schemas.microsoft.com/office/drawing/2014/main" id="{50AA400A-EBE4-4175-83CA-859EF5CF7CC4}"/>
+                <a16:creationId xmlns:a16="http://schemas.microsoft.com/office/drawing/2014/main" id="{77103F71-775A-4A12-AE22-84828E649ADE}"/>
               </a:ext>
             </a:extLst>
           </p:cNvPr>
@@ -10805,7 +10805,7 @@
           <p:cNvPr id="25" name="Shape 22">
             <a:extLst xmlns:a="http://schemas.openxmlformats.org/drawingml/2006/main">
               <a:ext uri="{FF2B5EF4-FFF2-40B4-BE49-F238E27FC236}">
-                <a16:creationId xmlns:a16="http://schemas.microsoft.com/office/drawing/2014/main" id="{6551C214-BBFD-49F0-9038-DA662FD2FF24}"/>
+                <a16:creationId xmlns:a16="http://schemas.microsoft.com/office/drawing/2014/main" id="{FF03C5CE-7DB7-4DBC-B089-9F4B6D60F616}"/>
               </a:ext>
             </a:extLst>
           </p:cNvPr>
@@ -10836,7 +10836,7 @@
           <p:cNvPr id="26" name="Text 23">
             <a:extLst xmlns:a="http://schemas.openxmlformats.org/drawingml/2006/main">
               <a:ext uri="{FF2B5EF4-FFF2-40B4-BE49-F238E27FC236}">
-                <a16:creationId xmlns:a16="http://schemas.microsoft.com/office/drawing/2014/main" id="{B4F3EC3A-41E3-4881-A166-34DE810B34C7}"/>
+                <a16:creationId xmlns:a16="http://schemas.microsoft.com/office/drawing/2014/main" id="{FDE545FF-B26C-4A7B-A1A3-40E81CABC10B}"/>
               </a:ext>
             </a:extLst>
           </p:cNvPr>
@@ -10887,7 +10887,7 @@
           <p:cNvPr id="27" name="Shape 24">
             <a:extLst xmlns:a="http://schemas.openxmlformats.org/drawingml/2006/main">
               <a:ext uri="{FF2B5EF4-FFF2-40B4-BE49-F238E27FC236}">
-                <a16:creationId xmlns:a16="http://schemas.microsoft.com/office/drawing/2014/main" id="{94C5A90F-1FA2-4941-A1AF-D24520D88CE8}"/>
+                <a16:creationId xmlns:a16="http://schemas.microsoft.com/office/drawing/2014/main" id="{65B15799-47EF-42C6-9461-4A63077E6E70}"/>
               </a:ext>
             </a:extLst>
           </p:cNvPr>
@@ -10918,7 +10918,7 @@
           <p:cNvPr id="28" name="Text 25">
             <a:extLst xmlns:a="http://schemas.openxmlformats.org/drawingml/2006/main">
               <a:ext uri="{FF2B5EF4-FFF2-40B4-BE49-F238E27FC236}">
-                <a16:creationId xmlns:a16="http://schemas.microsoft.com/office/drawing/2014/main" id="{B7BC9BA6-FF0D-49CD-B65E-664BC5B81703}"/>
+                <a16:creationId xmlns:a16="http://schemas.microsoft.com/office/drawing/2014/main" id="{7E164C35-14EE-4EB1-9DE4-7D13A4BA65B8}"/>
               </a:ext>
             </a:extLst>
           </p:cNvPr>
@@ -10969,7 +10969,7 @@
           <p:cNvPr id="29" name="Shape 26">
             <a:extLst xmlns:a="http://schemas.openxmlformats.org/drawingml/2006/main">
               <a:ext uri="{FF2B5EF4-FFF2-40B4-BE49-F238E27FC236}">
-                <a16:creationId xmlns:a16="http://schemas.microsoft.com/office/drawing/2014/main" id="{4F9011AB-4550-4B19-B64A-7F76C8092C43}"/>
+                <a16:creationId xmlns:a16="http://schemas.microsoft.com/office/drawing/2014/main" id="{E2FD9AC5-AA82-4024-89E9-38C5DF804A9D}"/>
               </a:ext>
             </a:extLst>
           </p:cNvPr>
@@ -11000,7 +11000,7 @@
           <p:cNvPr id="30" name="Text 27">
             <a:extLst xmlns:a="http://schemas.openxmlformats.org/drawingml/2006/main">
               <a:ext uri="{FF2B5EF4-FFF2-40B4-BE49-F238E27FC236}">
-                <a16:creationId xmlns:a16="http://schemas.microsoft.com/office/drawing/2014/main" id="{C4FD08A6-C082-4760-ABF8-5F66FAA1F547}"/>
+                <a16:creationId xmlns:a16="http://schemas.microsoft.com/office/drawing/2014/main" id="{0C3CB9F8-DCC2-46FA-A619-D7152ECDD224}"/>
               </a:ext>
             </a:extLst>
           </p:cNvPr>
@@ -11051,7 +11051,7 @@
           <p:cNvPr id="31" name="Text 28">
             <a:extLst xmlns:a="http://schemas.openxmlformats.org/drawingml/2006/main">
               <a:ext uri="{FF2B5EF4-FFF2-40B4-BE49-F238E27FC236}">
-                <a16:creationId xmlns:a16="http://schemas.microsoft.com/office/drawing/2014/main" id="{3F4D6415-D17E-4EFB-B9C5-295588BE6CB1}"/>
+                <a16:creationId xmlns:a16="http://schemas.microsoft.com/office/drawing/2014/main" id="{4D9818BB-1D19-4F38-AB8A-75BF23E70DBC}"/>
               </a:ext>
             </a:extLst>
           </p:cNvPr>
@@ -11102,7 +11102,7 @@
           <p:cNvPr id="32" name="Shape 29">
             <a:extLst xmlns:a="http://schemas.openxmlformats.org/drawingml/2006/main">
               <a:ext uri="{FF2B5EF4-FFF2-40B4-BE49-F238E27FC236}">
-                <a16:creationId xmlns:a16="http://schemas.microsoft.com/office/drawing/2014/main" id="{16A2CD03-1A84-421A-ACCE-95AB72D47761}"/>
+                <a16:creationId xmlns:a16="http://schemas.microsoft.com/office/drawing/2014/main" id="{0764C7CA-FC82-4269-B0BA-9F5C02B4BD9F}"/>
               </a:ext>
             </a:extLst>
           </p:cNvPr>
@@ -11129,7 +11129,7 @@
           <p:cNvPr id="33" name="Image 1">
             <a:extLst xmlns:a="http://schemas.openxmlformats.org/drawingml/2006/main">
               <a:ext uri="{FF2B5EF4-FFF2-40B4-BE49-F238E27FC236}">
-                <a16:creationId xmlns:a16="http://schemas.microsoft.com/office/drawing/2014/main" id="{8CBEDE8D-9766-4ADA-912A-2E61120E6433}"/>
+                <a16:creationId xmlns:a16="http://schemas.microsoft.com/office/drawing/2014/main" id="{C1BF3188-E826-48AB-AB52-78BCE2A931F4}"/>
               </a:ext>
             </a:extLst>
           </p:cNvPr>
@@ -11139,7 +11139,7 @@
           <p:nvPr/>
         </p:nvPicPr>
         <p:blipFill>
-          <a:blip xmlns:r="http://schemas.openxmlformats.org/officeDocument/2006/relationships" xmlns:a="http://schemas.openxmlformats.org/drawingml/2006/main" r:embed="Rfbb63fa6848449d1"/>
+          <a:blip xmlns:r="http://schemas.openxmlformats.org/officeDocument/2006/relationships" xmlns:a="http://schemas.openxmlformats.org/drawingml/2006/main" r:embed="Rae07c6f894f64a7f"/>
           <a:srcRect xmlns:a="http://schemas.openxmlformats.org/drawingml/2006/main" l="0" t="0" r="0" b="0"/>
           <a:stretch xmlns:a="http://schemas.openxmlformats.org/drawingml/2006/main"/>
         </p:blipFill>
@@ -11158,7 +11158,7 @@
           <p:cNvPr id="34" name="Shape 30">
             <a:extLst xmlns:a="http://schemas.openxmlformats.org/drawingml/2006/main">
               <a:ext uri="{FF2B5EF4-FFF2-40B4-BE49-F238E27FC236}">
-                <a16:creationId xmlns:a16="http://schemas.microsoft.com/office/drawing/2014/main" id="{6B697C8D-443E-406F-B5F2-801C199C6C82}"/>
+                <a16:creationId xmlns:a16="http://schemas.microsoft.com/office/drawing/2014/main" id="{B81DB57A-01A5-4AC9-AF15-1A78EEA5B8D7}"/>
               </a:ext>
             </a:extLst>
           </p:cNvPr>
@@ -11189,7 +11189,7 @@
           <p:cNvPr id="35" name="Text 31">
             <a:extLst xmlns:a="http://schemas.openxmlformats.org/drawingml/2006/main">
               <a:ext uri="{FF2B5EF4-FFF2-40B4-BE49-F238E27FC236}">
-                <a16:creationId xmlns:a16="http://schemas.microsoft.com/office/drawing/2014/main" id="{F8529AF6-1B19-4EBE-831E-C47EAE4F210C}"/>
+                <a16:creationId xmlns:a16="http://schemas.microsoft.com/office/drawing/2014/main" id="{B6F01319-5BBD-48A9-92FE-DA1F82877A45}"/>
               </a:ext>
             </a:extLst>
           </p:cNvPr>
@@ -11240,7 +11240,7 @@
           <p:cNvPr id="36" name="Shape 32">
             <a:extLst xmlns:a="http://schemas.openxmlformats.org/drawingml/2006/main">
               <a:ext uri="{FF2B5EF4-FFF2-40B4-BE49-F238E27FC236}">
-                <a16:creationId xmlns:a16="http://schemas.microsoft.com/office/drawing/2014/main" id="{F49C1B7C-C924-45EB-B288-9F7ED2F5ECC8}"/>
+                <a16:creationId xmlns:a16="http://schemas.microsoft.com/office/drawing/2014/main" id="{1348F002-4A97-44CE-9B79-98CDE9628F97}"/>
               </a:ext>
             </a:extLst>
           </p:cNvPr>
@@ -11271,7 +11271,7 @@
           <p:cNvPr id="37" name="Text 33">
             <a:extLst xmlns:a="http://schemas.openxmlformats.org/drawingml/2006/main">
               <a:ext uri="{FF2B5EF4-FFF2-40B4-BE49-F238E27FC236}">
-                <a16:creationId xmlns:a16="http://schemas.microsoft.com/office/drawing/2014/main" id="{50FAD04E-736F-447D-A8DC-5DA074234826}"/>
+                <a16:creationId xmlns:a16="http://schemas.microsoft.com/office/drawing/2014/main" id="{0D607E25-BE9B-4A13-AC58-7DCF5B15266C}"/>
               </a:ext>
             </a:extLst>
           </p:cNvPr>
@@ -11322,7 +11322,7 @@
           <p:cNvPr id="38" name="Shape 34">
             <a:extLst xmlns:a="http://schemas.openxmlformats.org/drawingml/2006/main">
               <a:ext uri="{FF2B5EF4-FFF2-40B4-BE49-F238E27FC236}">
-                <a16:creationId xmlns:a16="http://schemas.microsoft.com/office/drawing/2014/main" id="{63C00BEB-73B0-436F-BB98-2A4BA73DD5CD}"/>
+                <a16:creationId xmlns:a16="http://schemas.microsoft.com/office/drawing/2014/main" id="{7007DC8F-CCC3-4CE1-946C-8E0F7430E195}"/>
               </a:ext>
             </a:extLst>
           </p:cNvPr>
@@ -11353,7 +11353,7 @@
           <p:cNvPr id="39" name="Text 35">
             <a:extLst xmlns:a="http://schemas.openxmlformats.org/drawingml/2006/main">
               <a:ext uri="{FF2B5EF4-FFF2-40B4-BE49-F238E27FC236}">
-                <a16:creationId xmlns:a16="http://schemas.microsoft.com/office/drawing/2014/main" id="{9DA70F7E-E1C9-436E-AF65-49B6BF0F0958}"/>
+                <a16:creationId xmlns:a16="http://schemas.microsoft.com/office/drawing/2014/main" id="{DC93CD6E-7A13-4FF3-8045-7F3D7CA2D8C4}"/>
               </a:ext>
             </a:extLst>
           </p:cNvPr>
@@ -11404,7 +11404,7 @@
           <p:cNvPr id="40" name="Text 36">
             <a:extLst xmlns:a="http://schemas.openxmlformats.org/drawingml/2006/main">
               <a:ext uri="{FF2B5EF4-FFF2-40B4-BE49-F238E27FC236}">
-                <a16:creationId xmlns:a16="http://schemas.microsoft.com/office/drawing/2014/main" id="{B5395C14-6846-44E8-876E-A3BC56B1B36A}"/>
+                <a16:creationId xmlns:a16="http://schemas.microsoft.com/office/drawing/2014/main" id="{800B6378-3D35-4642-A403-1F92A8802D39}"/>
               </a:ext>
             </a:extLst>
           </p:cNvPr>
@@ -11455,7 +11455,7 @@
           <p:cNvPr id="41" name="Text 37">
             <a:extLst xmlns:a="http://schemas.openxmlformats.org/drawingml/2006/main">
               <a:ext uri="{FF2B5EF4-FFF2-40B4-BE49-F238E27FC236}">
-                <a16:creationId xmlns:a16="http://schemas.microsoft.com/office/drawing/2014/main" id="{95587091-58EF-40E9-A3AA-0B9BAA04B739}"/>
+                <a16:creationId xmlns:a16="http://schemas.microsoft.com/office/drawing/2014/main" id="{609191AB-1421-44A0-8939-F4D38CB2431F}"/>
               </a:ext>
             </a:extLst>
           </p:cNvPr>
@@ -11506,7 +11506,7 @@
           <p:cNvPr id="42" name="Shape 38">
             <a:extLst xmlns:a="http://schemas.openxmlformats.org/drawingml/2006/main">
               <a:ext uri="{FF2B5EF4-FFF2-40B4-BE49-F238E27FC236}">
-                <a16:creationId xmlns:a16="http://schemas.microsoft.com/office/drawing/2014/main" id="{1FA3EBC8-8C1D-4941-9EA5-B80534FB09F2}"/>
+                <a16:creationId xmlns:a16="http://schemas.microsoft.com/office/drawing/2014/main" id="{71132061-CEC9-47DD-A6FA-6D700FE28964}"/>
               </a:ext>
             </a:extLst>
           </p:cNvPr>
@@ -11533,7 +11533,7 @@
           <p:cNvPr id="43" name="Image 2">
             <a:extLst xmlns:a="http://schemas.openxmlformats.org/drawingml/2006/main">
               <a:ext uri="{FF2B5EF4-FFF2-40B4-BE49-F238E27FC236}">
-                <a16:creationId xmlns:a16="http://schemas.microsoft.com/office/drawing/2014/main" id="{DCBA978B-2AEE-492F-83EE-0189339EC1DC}"/>
+                <a16:creationId xmlns:a16="http://schemas.microsoft.com/office/drawing/2014/main" id="{1A381DD2-B287-4142-8EFF-7AEC078DA4AA}"/>
               </a:ext>
             </a:extLst>
           </p:cNvPr>
@@ -11543,7 +11543,7 @@
           <p:nvPr/>
         </p:nvPicPr>
         <p:blipFill>
-          <a:blip xmlns:r="http://schemas.openxmlformats.org/officeDocument/2006/relationships" xmlns:a="http://schemas.openxmlformats.org/drawingml/2006/main" r:embed="R0ee2dbb10bb94791"/>
+          <a:blip xmlns:r="http://schemas.openxmlformats.org/officeDocument/2006/relationships" xmlns:a="http://schemas.openxmlformats.org/drawingml/2006/main" r:embed="R443ca094643a4a25"/>
           <a:srcRect xmlns:a="http://schemas.openxmlformats.org/drawingml/2006/main" l="0" t="0" r="0" b="0"/>
           <a:stretch xmlns:a="http://schemas.openxmlformats.org/drawingml/2006/main"/>
         </p:blipFill>
@@ -11562,7 +11562,7 @@
           <p:cNvPr id="44" name="Shape 39">
             <a:extLst xmlns:a="http://schemas.openxmlformats.org/drawingml/2006/main">
               <a:ext uri="{FF2B5EF4-FFF2-40B4-BE49-F238E27FC236}">
-                <a16:creationId xmlns:a16="http://schemas.microsoft.com/office/drawing/2014/main" id="{D00C716B-E822-4657-AA19-BD28E2A00506}"/>
+                <a16:creationId xmlns:a16="http://schemas.microsoft.com/office/drawing/2014/main" id="{29412DC6-4B13-4704-81C0-390995ED1F77}"/>
               </a:ext>
             </a:extLst>
           </p:cNvPr>
@@ -11593,7 +11593,7 @@
           <p:cNvPr id="45" name="Text 40">
             <a:extLst xmlns:a="http://schemas.openxmlformats.org/drawingml/2006/main">
               <a:ext uri="{FF2B5EF4-FFF2-40B4-BE49-F238E27FC236}">
-                <a16:creationId xmlns:a16="http://schemas.microsoft.com/office/drawing/2014/main" id="{9B35B39E-1448-43A8-AF26-98F2DEF9A9E4}"/>
+                <a16:creationId xmlns:a16="http://schemas.microsoft.com/office/drawing/2014/main" id="{4595022B-561E-48B1-AFE6-FDAB8263F429}"/>
               </a:ext>
             </a:extLst>
           </p:cNvPr>
@@ -11644,7 +11644,7 @@
           <p:cNvPr id="46" name="Shape 41">
             <a:extLst xmlns:a="http://schemas.openxmlformats.org/drawingml/2006/main">
               <a:ext uri="{FF2B5EF4-FFF2-40B4-BE49-F238E27FC236}">
-                <a16:creationId xmlns:a16="http://schemas.microsoft.com/office/drawing/2014/main" id="{67CB88AF-5CDE-4886-8A9E-CB56CF96A9A1}"/>
+                <a16:creationId xmlns:a16="http://schemas.microsoft.com/office/drawing/2014/main" id="{5D100024-7336-470D-9184-C92DA82EB89E}"/>
               </a:ext>
             </a:extLst>
           </p:cNvPr>
@@ -11675,7 +11675,7 @@
           <p:cNvPr id="47" name="Text 42">
             <a:extLst xmlns:a="http://schemas.openxmlformats.org/drawingml/2006/main">
               <a:ext uri="{FF2B5EF4-FFF2-40B4-BE49-F238E27FC236}">
-                <a16:creationId xmlns:a16="http://schemas.microsoft.com/office/drawing/2014/main" id="{6BB5401B-F98C-411E-BCD1-B6521ECF63E1}"/>
+                <a16:creationId xmlns:a16="http://schemas.microsoft.com/office/drawing/2014/main" id="{81AA7A90-0920-428E-A7C1-9FD9412A7A0B}"/>
               </a:ext>
             </a:extLst>
           </p:cNvPr>
@@ -11726,7 +11726,7 @@
           <p:cNvPr id="48" name="Shape 43">
             <a:extLst xmlns:a="http://schemas.openxmlformats.org/drawingml/2006/main">
               <a:ext uri="{FF2B5EF4-FFF2-40B4-BE49-F238E27FC236}">
-                <a16:creationId xmlns:a16="http://schemas.microsoft.com/office/drawing/2014/main" id="{7AC3B27D-6C07-4605-B9CD-E9F474DBFAEA}"/>
+                <a16:creationId xmlns:a16="http://schemas.microsoft.com/office/drawing/2014/main" id="{CEE0E7F9-7DB9-45C5-9EF6-3AADEE34C9A5}"/>
               </a:ext>
             </a:extLst>
           </p:cNvPr>
@@ -11773,7 +11773,7 @@
           <p:cNvPr id="49" name="Text 44">
             <a:extLst xmlns:a="http://schemas.openxmlformats.org/drawingml/2006/main">
               <a:ext uri="{FF2B5EF4-FFF2-40B4-BE49-F238E27FC236}">
-                <a16:creationId xmlns:a16="http://schemas.microsoft.com/office/drawing/2014/main" id="{5068C019-F4F5-4034-A443-481C4BE286E9}"/>
+                <a16:creationId xmlns:a16="http://schemas.microsoft.com/office/drawing/2014/main" id="{ADB9648E-7CC6-4058-9995-C90C1D57B2E0}"/>
               </a:ext>
             </a:extLst>
           </p:cNvPr>
@@ -11824,7 +11824,7 @@
           <p:cNvPr id="50" name="Text 45">
             <a:extLst xmlns:a="http://schemas.openxmlformats.org/drawingml/2006/main">
               <a:ext uri="{FF2B5EF4-FFF2-40B4-BE49-F238E27FC236}">
-                <a16:creationId xmlns:a16="http://schemas.microsoft.com/office/drawing/2014/main" id="{A10EFB93-170A-400D-9555-1CBED48F4F34}"/>
+                <a16:creationId xmlns:a16="http://schemas.microsoft.com/office/drawing/2014/main" id="{72085598-18A6-4236-A474-832B42223CBD}"/>
               </a:ext>
             </a:extLst>
           </p:cNvPr>
@@ -11879,7 +11879,7 @@
           <p:cNvPr id="51" name="Shape 46">
             <a:extLst xmlns:a="http://schemas.openxmlformats.org/drawingml/2006/main">
               <a:ext uri="{FF2B5EF4-FFF2-40B4-BE49-F238E27FC236}">
-                <a16:creationId xmlns:a16="http://schemas.microsoft.com/office/drawing/2014/main" id="{53B6124D-8D46-45FC-8932-E796767876E6}"/>
+                <a16:creationId xmlns:a16="http://schemas.microsoft.com/office/drawing/2014/main" id="{EA712A84-6508-4459-9DDC-E4E353541D61}"/>
               </a:ext>
             </a:extLst>
           </p:cNvPr>
@@ -11912,7 +11912,7 @@
           <p:cNvPr id="52" name="Text 47">
             <a:extLst xmlns:a="http://schemas.openxmlformats.org/drawingml/2006/main">
               <a:ext uri="{FF2B5EF4-FFF2-40B4-BE49-F238E27FC236}">
-                <a16:creationId xmlns:a16="http://schemas.microsoft.com/office/drawing/2014/main" id="{3FDB0D47-C972-4415-8864-489DE0B2D33A}"/>
+                <a16:creationId xmlns:a16="http://schemas.microsoft.com/office/drawing/2014/main" id="{C64EFC64-F329-4601-A3FF-41A800751836}"/>
               </a:ext>
             </a:extLst>
           </p:cNvPr>
@@ -11967,7 +11967,7 @@
           <p:cNvPr id="53" name="Text 48">
             <a:extLst xmlns:a="http://schemas.openxmlformats.org/drawingml/2006/main">
               <a:ext uri="{FF2B5EF4-FFF2-40B4-BE49-F238E27FC236}">
-                <a16:creationId xmlns:a16="http://schemas.microsoft.com/office/drawing/2014/main" id="{657E2F19-EF17-4C8C-86A3-FB6421EBD336}"/>
+                <a16:creationId xmlns:a16="http://schemas.microsoft.com/office/drawing/2014/main" id="{8E2BDF21-552E-4499-936F-98CE8EC9F9BC}"/>
               </a:ext>
             </a:extLst>
           </p:cNvPr>
@@ -12018,7 +12018,7 @@
           <p:cNvPr id="54" name="Text 49">
             <a:extLst xmlns:a="http://schemas.openxmlformats.org/drawingml/2006/main">
               <a:ext uri="{FF2B5EF4-FFF2-40B4-BE49-F238E27FC236}">
-                <a16:creationId xmlns:a16="http://schemas.microsoft.com/office/drawing/2014/main" id="{86081FE1-5DA6-4210-BD98-EA6827808CAE}"/>
+                <a16:creationId xmlns:a16="http://schemas.microsoft.com/office/drawing/2014/main" id="{B8C6A191-1C6E-4801-AC0B-66003BE15DB5}"/>
               </a:ext>
             </a:extLst>
           </p:cNvPr>
@@ -12069,7 +12069,7 @@
           <p:cNvPr id="55" name="Text 50">
             <a:extLst xmlns:a="http://schemas.openxmlformats.org/drawingml/2006/main">
               <a:ext uri="{FF2B5EF4-FFF2-40B4-BE49-F238E27FC236}">
-                <a16:creationId xmlns:a16="http://schemas.microsoft.com/office/drawing/2014/main" id="{67C824EB-6D1A-4413-BBDA-0636EFF77380}"/>
+                <a16:creationId xmlns:a16="http://schemas.microsoft.com/office/drawing/2014/main" id="{1E363827-317B-455E-9739-844614DF1351}"/>
               </a:ext>
             </a:extLst>
           </p:cNvPr>
@@ -12118,7 +12118,7 @@
     </p:spTree>
     <p:extLst>
       <p:ext uri="{BB962C8B-B14F-4D97-AF65-F5344CB8AC3E}">
-        <p14:creationId xmlns:p14="http://schemas.microsoft.com/office/powerpoint/2010/main" val="1702248681"/>
+        <p14:creationId xmlns:p14="http://schemas.microsoft.com/office/powerpoint/2010/main" val="1404663409"/>
       </p:ext>
     </p:extLst>
   </p:cSld>
@@ -12142,7 +12142,7 @@
           <p:cNvPr id="2" name="Shape 0">
             <a:extLst xmlns:a="http://schemas.openxmlformats.org/drawingml/2006/main">
               <a:ext uri="{FF2B5EF4-FFF2-40B4-BE49-F238E27FC236}">
-                <a16:creationId xmlns:a16="http://schemas.microsoft.com/office/drawing/2014/main" id="{E90B7C4A-7D81-4536-B359-3CF22859BAFC}"/>
+                <a16:creationId xmlns:a16="http://schemas.microsoft.com/office/drawing/2014/main" id="{60CAE032-A5F5-4572-8A7F-486E55B27159}"/>
               </a:ext>
             </a:extLst>
           </p:cNvPr>
@@ -12171,7 +12171,7 @@
           <p:cNvPr id="3" name="Text 1">
             <a:extLst xmlns:a="http://schemas.openxmlformats.org/drawingml/2006/main">
               <a:ext uri="{FF2B5EF4-FFF2-40B4-BE49-F238E27FC236}">
-                <a16:creationId xmlns:a16="http://schemas.microsoft.com/office/drawing/2014/main" id="{D6584887-C655-44E9-A656-42A1F056209C}"/>
+                <a16:creationId xmlns:a16="http://schemas.microsoft.com/office/drawing/2014/main" id="{2FA9964F-0384-4063-96F3-35B8CC4C1F83}"/>
               </a:ext>
             </a:extLst>
           </p:cNvPr>
@@ -12222,7 +12222,7 @@
           <p:cNvPr id="4" name="Text 2">
             <a:extLst xmlns:a="http://schemas.openxmlformats.org/drawingml/2006/main">
               <a:ext uri="{FF2B5EF4-FFF2-40B4-BE49-F238E27FC236}">
-                <a16:creationId xmlns:a16="http://schemas.microsoft.com/office/drawing/2014/main" id="{819325DF-20BB-4694-9858-2669FD24A798}"/>
+                <a16:creationId xmlns:a16="http://schemas.microsoft.com/office/drawing/2014/main" id="{472F4C8B-250F-4ABC-AD57-4B0883C94287}"/>
               </a:ext>
             </a:extLst>
           </p:cNvPr>
@@ -12275,7 +12275,7 @@
           <p:cNvPr id="5" name="Shape 3">
             <a:extLst xmlns:a="http://schemas.openxmlformats.org/drawingml/2006/main">
               <a:ext uri="{FF2B5EF4-FFF2-40B4-BE49-F238E27FC236}">
-                <a16:creationId xmlns:a16="http://schemas.microsoft.com/office/drawing/2014/main" id="{5063C131-E042-46DF-ACA9-969F0C21C930}"/>
+                <a16:creationId xmlns:a16="http://schemas.microsoft.com/office/drawing/2014/main" id="{A2008AB5-4074-4688-8D4A-E634DD53FFCF}"/>
               </a:ext>
             </a:extLst>
           </p:cNvPr>
@@ -12317,7 +12317,7 @@
           <p:cNvPr id="6" name="Text 4">
             <a:extLst xmlns:a="http://schemas.openxmlformats.org/drawingml/2006/main">
               <a:ext uri="{FF2B5EF4-FFF2-40B4-BE49-F238E27FC236}">
-                <a16:creationId xmlns:a16="http://schemas.microsoft.com/office/drawing/2014/main" id="{8A5FA544-223B-4ACF-BB08-4BAEBAE7FE2A}"/>
+                <a16:creationId xmlns:a16="http://schemas.microsoft.com/office/drawing/2014/main" id="{649E1C53-9577-4D6B-80C7-559D9286995D}"/>
               </a:ext>
             </a:extLst>
           </p:cNvPr>
@@ -12368,7 +12368,7 @@
           <p:cNvPr id="7" name="Text 5">
             <a:extLst xmlns:a="http://schemas.openxmlformats.org/drawingml/2006/main">
               <a:ext uri="{FF2B5EF4-FFF2-40B4-BE49-F238E27FC236}">
-                <a16:creationId xmlns:a16="http://schemas.microsoft.com/office/drawing/2014/main" id="{5F5662BB-4BFE-417B-810E-453675A6AECF}"/>
+                <a16:creationId xmlns:a16="http://schemas.microsoft.com/office/drawing/2014/main" id="{9752CCC1-7BCC-492F-8D54-D0698BCFE717}"/>
               </a:ext>
             </a:extLst>
           </p:cNvPr>
@@ -12419,7 +12419,7 @@
           <p:cNvPr id="8" name="Shape 6">
             <a:extLst xmlns:a="http://schemas.openxmlformats.org/drawingml/2006/main">
               <a:ext uri="{FF2B5EF4-FFF2-40B4-BE49-F238E27FC236}">
-                <a16:creationId xmlns:a16="http://schemas.microsoft.com/office/drawing/2014/main" id="{8040C37A-74C0-44FF-B850-DB8C9A5FF933}"/>
+                <a16:creationId xmlns:a16="http://schemas.microsoft.com/office/drawing/2014/main" id="{FEA777B7-7F7F-49C6-8F82-7787433E1FD7}"/>
               </a:ext>
             </a:extLst>
           </p:cNvPr>
@@ -12450,7 +12450,7 @@
           <p:cNvPr id="9" name="Text 7">
             <a:extLst xmlns:a="http://schemas.openxmlformats.org/drawingml/2006/main">
               <a:ext uri="{FF2B5EF4-FFF2-40B4-BE49-F238E27FC236}">
-                <a16:creationId xmlns:a16="http://schemas.microsoft.com/office/drawing/2014/main" id="{929B89AD-4EC0-426A-B2A1-504530B5A403}"/>
+                <a16:creationId xmlns:a16="http://schemas.microsoft.com/office/drawing/2014/main" id="{908812C3-193E-425E-8B96-F043D9A46C09}"/>
               </a:ext>
             </a:extLst>
           </p:cNvPr>
@@ -12501,7 +12501,7 @@
           <p:cNvPr id="10" name="Text 8">
             <a:extLst xmlns:a="http://schemas.openxmlformats.org/drawingml/2006/main">
               <a:ext uri="{FF2B5EF4-FFF2-40B4-BE49-F238E27FC236}">
-                <a16:creationId xmlns:a16="http://schemas.microsoft.com/office/drawing/2014/main" id="{0C29C7AD-0180-44A6-9C71-6BB75C3DA134}"/>
+                <a16:creationId xmlns:a16="http://schemas.microsoft.com/office/drawing/2014/main" id="{CCE9EC20-8E26-4ACF-A541-D3420242830D}"/>
               </a:ext>
             </a:extLst>
           </p:cNvPr>
@@ -12552,7 +12552,7 @@
           <p:cNvPr id="11" name="Shape 9">
             <a:extLst xmlns:a="http://schemas.openxmlformats.org/drawingml/2006/main">
               <a:ext uri="{FF2B5EF4-FFF2-40B4-BE49-F238E27FC236}">
-                <a16:creationId xmlns:a16="http://schemas.microsoft.com/office/drawing/2014/main" id="{F05730CC-920A-4AEC-B8BC-C134331C05A4}"/>
+                <a16:creationId xmlns:a16="http://schemas.microsoft.com/office/drawing/2014/main" id="{B2FC5C9E-1A05-484B-A43B-C76E5AEB30D0}"/>
               </a:ext>
             </a:extLst>
           </p:cNvPr>
@@ -12583,7 +12583,7 @@
           <p:cNvPr id="12" name="Text 10">
             <a:extLst xmlns:a="http://schemas.openxmlformats.org/drawingml/2006/main">
               <a:ext uri="{FF2B5EF4-FFF2-40B4-BE49-F238E27FC236}">
-                <a16:creationId xmlns:a16="http://schemas.microsoft.com/office/drawing/2014/main" id="{6351B2B0-97E2-4216-B6DA-084F85B551AC}"/>
+                <a16:creationId xmlns:a16="http://schemas.microsoft.com/office/drawing/2014/main" id="{7341CD22-4D45-4562-90EB-120ECD48B648}"/>
               </a:ext>
             </a:extLst>
           </p:cNvPr>
@@ -12634,7 +12634,7 @@
           <p:cNvPr id="13" name="Text 11">
             <a:extLst xmlns:a="http://schemas.openxmlformats.org/drawingml/2006/main">
               <a:ext uri="{FF2B5EF4-FFF2-40B4-BE49-F238E27FC236}">
-                <a16:creationId xmlns:a16="http://schemas.microsoft.com/office/drawing/2014/main" id="{71F555FD-57FE-4915-B08E-95DD612F56E9}"/>
+                <a16:creationId xmlns:a16="http://schemas.microsoft.com/office/drawing/2014/main" id="{9E2AA116-D9B2-444A-981F-8AF95604ABC2}"/>
               </a:ext>
             </a:extLst>
           </p:cNvPr>
@@ -12685,7 +12685,7 @@
           <p:cNvPr id="14" name="Shape 12">
             <a:extLst xmlns:a="http://schemas.openxmlformats.org/drawingml/2006/main">
               <a:ext uri="{FF2B5EF4-FFF2-40B4-BE49-F238E27FC236}">
-                <a16:creationId xmlns:a16="http://schemas.microsoft.com/office/drawing/2014/main" id="{A800CA53-AE87-48A3-B3CB-9C4C68156396}"/>
+                <a16:creationId xmlns:a16="http://schemas.microsoft.com/office/drawing/2014/main" id="{6DB8C2B7-7101-45DF-BC4A-FC9316249EFB}"/>
               </a:ext>
             </a:extLst>
           </p:cNvPr>
@@ -12716,7 +12716,7 @@
           <p:cNvPr id="15" name="Text 13">
             <a:extLst xmlns:a="http://schemas.openxmlformats.org/drawingml/2006/main">
               <a:ext uri="{FF2B5EF4-FFF2-40B4-BE49-F238E27FC236}">
-                <a16:creationId xmlns:a16="http://schemas.microsoft.com/office/drawing/2014/main" id="{8945A81E-761B-4729-A106-06F9B5603149}"/>
+                <a16:creationId xmlns:a16="http://schemas.microsoft.com/office/drawing/2014/main" id="{4C94BCAC-6A79-48C8-B3AD-F7DB8322E436}"/>
               </a:ext>
             </a:extLst>
           </p:cNvPr>
@@ -12767,7 +12767,7 @@
           <p:cNvPr id="16" name="Text 14">
             <a:extLst xmlns:a="http://schemas.openxmlformats.org/drawingml/2006/main">
               <a:ext uri="{FF2B5EF4-FFF2-40B4-BE49-F238E27FC236}">
-                <a16:creationId xmlns:a16="http://schemas.microsoft.com/office/drawing/2014/main" id="{A5B78E40-084F-4EC9-8103-B0DDD8294C4B}"/>
+                <a16:creationId xmlns:a16="http://schemas.microsoft.com/office/drawing/2014/main" id="{257FA37B-571E-4E68-B96A-DAF7832BF07C}"/>
               </a:ext>
             </a:extLst>
           </p:cNvPr>
@@ -12818,7 +12818,7 @@
           <p:cNvPr id="17" name="Text 15">
             <a:extLst xmlns:a="http://schemas.openxmlformats.org/drawingml/2006/main">
               <a:ext uri="{FF2B5EF4-FFF2-40B4-BE49-F238E27FC236}">
-                <a16:creationId xmlns:a16="http://schemas.microsoft.com/office/drawing/2014/main" id="{B313BF3F-0A7D-4D5A-AC2E-A87C2B06D42B}"/>
+                <a16:creationId xmlns:a16="http://schemas.microsoft.com/office/drawing/2014/main" id="{E5044A61-3F82-4458-B398-28CA879D6095}"/>
               </a:ext>
             </a:extLst>
           </p:cNvPr>
@@ -12869,7 +12869,7 @@
           <p:cNvPr id="18" name="Image 0">
             <a:extLst xmlns:a="http://schemas.openxmlformats.org/drawingml/2006/main">
               <a:ext uri="{FF2B5EF4-FFF2-40B4-BE49-F238E27FC236}">
-                <a16:creationId xmlns:a16="http://schemas.microsoft.com/office/drawing/2014/main" id="{56061B0E-72B6-41E0-BD19-4FC49F3575F2}"/>
+                <a16:creationId xmlns:a16="http://schemas.microsoft.com/office/drawing/2014/main" id="{18182ABE-3D4A-4F8E-A99B-255660E3805F}"/>
               </a:ext>
             </a:extLst>
           </p:cNvPr>
@@ -12879,7 +12879,7 @@
           <p:nvPr/>
         </p:nvPicPr>
         <p:blipFill>
-          <a:blip xmlns:r="http://schemas.openxmlformats.org/officeDocument/2006/relationships" xmlns:a="http://schemas.openxmlformats.org/drawingml/2006/main" r:embed="R7b3614ce88244f92"/>
+          <a:blip xmlns:r="http://schemas.openxmlformats.org/officeDocument/2006/relationships" xmlns:a="http://schemas.openxmlformats.org/drawingml/2006/main" r:embed="Re02d9d1dfc7b4642"/>
           <a:srcRect xmlns:a="http://schemas.openxmlformats.org/drawingml/2006/main" l="-11" t="0" r="-11" b="0"/>
           <a:stretch xmlns:a="http://schemas.openxmlformats.org/drawingml/2006/main"/>
         </p:blipFill>
@@ -12898,7 +12898,7 @@
           <p:cNvPr id="19" name="Image 1">
             <a:extLst xmlns:a="http://schemas.openxmlformats.org/drawingml/2006/main">
               <a:ext uri="{FF2B5EF4-FFF2-40B4-BE49-F238E27FC236}">
-                <a16:creationId xmlns:a16="http://schemas.microsoft.com/office/drawing/2014/main" id="{6FC91573-F39D-43BA-BE84-7C33BCD10995}"/>
+                <a16:creationId xmlns:a16="http://schemas.microsoft.com/office/drawing/2014/main" id="{E9EAF7D6-2646-4A36-A644-01827252CF7E}"/>
               </a:ext>
             </a:extLst>
           </p:cNvPr>
@@ -12908,7 +12908,7 @@
           <p:nvPr/>
         </p:nvPicPr>
         <p:blipFill>
-          <a:blip xmlns:r="http://schemas.openxmlformats.org/officeDocument/2006/relationships" xmlns:a="http://schemas.openxmlformats.org/drawingml/2006/main" r:embed="Rc7d26f5dc8a44063"/>
+          <a:blip xmlns:r="http://schemas.openxmlformats.org/officeDocument/2006/relationships" xmlns:a="http://schemas.openxmlformats.org/drawingml/2006/main" r:embed="Rc7b809548f854037"/>
           <a:srcRect xmlns:a="http://schemas.openxmlformats.org/drawingml/2006/main" l="-11" t="0" r="-11" b="0"/>
           <a:stretch xmlns:a="http://schemas.openxmlformats.org/drawingml/2006/main"/>
         </p:blipFill>
@@ -12927,7 +12927,7 @@
           <p:cNvPr id="20" name="Text 16">
             <a:extLst xmlns:a="http://schemas.openxmlformats.org/drawingml/2006/main">
               <a:ext uri="{FF2B5EF4-FFF2-40B4-BE49-F238E27FC236}">
-                <a16:creationId xmlns:a16="http://schemas.microsoft.com/office/drawing/2014/main" id="{AFED5578-9509-46CC-951A-B70148BE553D}"/>
+                <a16:creationId xmlns:a16="http://schemas.microsoft.com/office/drawing/2014/main" id="{79AB736D-254F-4E4C-8CFF-2682D3EC132B}"/>
               </a:ext>
             </a:extLst>
           </p:cNvPr>
@@ -12978,7 +12978,7 @@
           <p:cNvPr id="21" name="Shape 17">
             <a:extLst xmlns:a="http://schemas.openxmlformats.org/drawingml/2006/main">
               <a:ext uri="{FF2B5EF4-FFF2-40B4-BE49-F238E27FC236}">
-                <a16:creationId xmlns:a16="http://schemas.microsoft.com/office/drawing/2014/main" id="{DA1097DD-3E2D-4120-8467-8AD116D048C9}"/>
+                <a16:creationId xmlns:a16="http://schemas.microsoft.com/office/drawing/2014/main" id="{45AB4836-541C-47AD-BB24-01E3F2E42B34}"/>
               </a:ext>
             </a:extLst>
           </p:cNvPr>
@@ -13020,7 +13020,7 @@
           <p:cNvPr id="22" name="Text 18">
             <a:extLst xmlns:a="http://schemas.openxmlformats.org/drawingml/2006/main">
               <a:ext uri="{FF2B5EF4-FFF2-40B4-BE49-F238E27FC236}">
-                <a16:creationId xmlns:a16="http://schemas.microsoft.com/office/drawing/2014/main" id="{76CAACBF-952C-4127-9CC9-9A682175CFE1}"/>
+                <a16:creationId xmlns:a16="http://schemas.microsoft.com/office/drawing/2014/main" id="{3F74F5FD-8AAB-4457-BB81-05BAA9AAC733}"/>
               </a:ext>
             </a:extLst>
           </p:cNvPr>
@@ -13071,7 +13071,7 @@
           <p:cNvPr id="23" name="Text 19">
             <a:extLst xmlns:a="http://schemas.openxmlformats.org/drawingml/2006/main">
               <a:ext uri="{FF2B5EF4-FFF2-40B4-BE49-F238E27FC236}">
-                <a16:creationId xmlns:a16="http://schemas.microsoft.com/office/drawing/2014/main" id="{2EEE8C16-52D4-438C-808F-A3F50D4ABF5A}"/>
+                <a16:creationId xmlns:a16="http://schemas.microsoft.com/office/drawing/2014/main" id="{39685AAA-271C-4D4B-B1F8-777907BFBDD1}"/>
               </a:ext>
             </a:extLst>
           </p:cNvPr>
@@ -13122,7 +13122,7 @@
           <p:cNvPr id="24" name="Shape 20">
             <a:extLst xmlns:a="http://schemas.openxmlformats.org/drawingml/2006/main">
               <a:ext uri="{FF2B5EF4-FFF2-40B4-BE49-F238E27FC236}">
-                <a16:creationId xmlns:a16="http://schemas.microsoft.com/office/drawing/2014/main" id="{DDDCC40A-7845-474B-9220-D698268F24A8}"/>
+                <a16:creationId xmlns:a16="http://schemas.microsoft.com/office/drawing/2014/main" id="{36A9678E-DB9C-4651-9F6C-2491CBEB3860}"/>
               </a:ext>
             </a:extLst>
           </p:cNvPr>
@@ -13153,7 +13153,7 @@
           <p:cNvPr id="25" name="Text 21">
             <a:extLst xmlns:a="http://schemas.openxmlformats.org/drawingml/2006/main">
               <a:ext uri="{FF2B5EF4-FFF2-40B4-BE49-F238E27FC236}">
-                <a16:creationId xmlns:a16="http://schemas.microsoft.com/office/drawing/2014/main" id="{C047780C-11EF-41C6-9810-0FF9F5D86C93}"/>
+                <a16:creationId xmlns:a16="http://schemas.microsoft.com/office/drawing/2014/main" id="{5AD5BD6D-B02D-45D9-AE94-757D11440607}"/>
               </a:ext>
             </a:extLst>
           </p:cNvPr>
@@ -13204,7 +13204,7 @@
           <p:cNvPr id="26" name="Text 22">
             <a:extLst xmlns:a="http://schemas.openxmlformats.org/drawingml/2006/main">
               <a:ext uri="{FF2B5EF4-FFF2-40B4-BE49-F238E27FC236}">
-                <a16:creationId xmlns:a16="http://schemas.microsoft.com/office/drawing/2014/main" id="{7FF0A2F0-4472-4B8F-B2AD-E7F9ECEDB60F}"/>
+                <a16:creationId xmlns:a16="http://schemas.microsoft.com/office/drawing/2014/main" id="{46C2579B-EC09-4BB7-85E6-D92CF0406D50}"/>
               </a:ext>
             </a:extLst>
           </p:cNvPr>
@@ -13255,7 +13255,7 @@
           <p:cNvPr id="27" name="Shape 23">
             <a:extLst xmlns:a="http://schemas.openxmlformats.org/drawingml/2006/main">
               <a:ext uri="{FF2B5EF4-FFF2-40B4-BE49-F238E27FC236}">
-                <a16:creationId xmlns:a16="http://schemas.microsoft.com/office/drawing/2014/main" id="{42B82494-B500-4BD9-9150-A19CF8E7AF23}"/>
+                <a16:creationId xmlns:a16="http://schemas.microsoft.com/office/drawing/2014/main" id="{BF6D8E49-5DDE-469E-8EEC-639DB88E8D90}"/>
               </a:ext>
             </a:extLst>
           </p:cNvPr>
@@ -13286,7 +13286,7 @@
           <p:cNvPr id="28" name="Text 24">
             <a:extLst xmlns:a="http://schemas.openxmlformats.org/drawingml/2006/main">
               <a:ext uri="{FF2B5EF4-FFF2-40B4-BE49-F238E27FC236}">
-                <a16:creationId xmlns:a16="http://schemas.microsoft.com/office/drawing/2014/main" id="{A96C7253-FBE9-42C2-899D-2C28CF39DDC3}"/>
+                <a16:creationId xmlns:a16="http://schemas.microsoft.com/office/drawing/2014/main" id="{EF3BB00F-A31D-4633-B182-9705A6B3DECF}"/>
               </a:ext>
             </a:extLst>
           </p:cNvPr>
@@ -13337,7 +13337,7 @@
           <p:cNvPr id="29" name="Text 25">
             <a:extLst xmlns:a="http://schemas.openxmlformats.org/drawingml/2006/main">
               <a:ext uri="{FF2B5EF4-FFF2-40B4-BE49-F238E27FC236}">
-                <a16:creationId xmlns:a16="http://schemas.microsoft.com/office/drawing/2014/main" id="{5FE7CD66-9999-4ECC-9F5D-80228C595592}"/>
+                <a16:creationId xmlns:a16="http://schemas.microsoft.com/office/drawing/2014/main" id="{13D2E362-D4D3-4008-8B4B-AD62A5A1CF27}"/>
               </a:ext>
             </a:extLst>
           </p:cNvPr>
@@ -13432,7 +13432,7 @@
           <p:cNvPr id="30" name="Shape 26">
             <a:extLst xmlns:a="http://schemas.openxmlformats.org/drawingml/2006/main">
               <a:ext uri="{FF2B5EF4-FFF2-40B4-BE49-F238E27FC236}">
-                <a16:creationId xmlns:a16="http://schemas.microsoft.com/office/drawing/2014/main" id="{5280F108-27CB-48CF-9977-88953B007385}"/>
+                <a16:creationId xmlns:a16="http://schemas.microsoft.com/office/drawing/2014/main" id="{9B462A92-00A2-4262-91F7-191B3C91D101}"/>
               </a:ext>
             </a:extLst>
           </p:cNvPr>
@@ -13463,7 +13463,7 @@
           <p:cNvPr id="31" name="Text 27">
             <a:extLst xmlns:a="http://schemas.openxmlformats.org/drawingml/2006/main">
               <a:ext uri="{FF2B5EF4-FFF2-40B4-BE49-F238E27FC236}">
-                <a16:creationId xmlns:a16="http://schemas.microsoft.com/office/drawing/2014/main" id="{FA916505-8FF4-47C2-A567-498315B5408F}"/>
+                <a16:creationId xmlns:a16="http://schemas.microsoft.com/office/drawing/2014/main" id="{C4ACFE68-2D2D-424F-A954-246C7D49E381}"/>
               </a:ext>
             </a:extLst>
           </p:cNvPr>
@@ -13514,7 +13514,7 @@
           <p:cNvPr id="32" name="Text 28">
             <a:extLst xmlns:a="http://schemas.openxmlformats.org/drawingml/2006/main">
               <a:ext uri="{FF2B5EF4-FFF2-40B4-BE49-F238E27FC236}">
-                <a16:creationId xmlns:a16="http://schemas.microsoft.com/office/drawing/2014/main" id="{2D62E306-636D-4CB2-83CA-89A6F0649E22}"/>
+                <a16:creationId xmlns:a16="http://schemas.microsoft.com/office/drawing/2014/main" id="{F7767D7B-7935-47C9-8B65-504EE3AED96E}"/>
               </a:ext>
             </a:extLst>
           </p:cNvPr>
@@ -13565,7 +13565,7 @@
           <p:cNvPr id="33" name="Shape 29">
             <a:extLst xmlns:a="http://schemas.openxmlformats.org/drawingml/2006/main">
               <a:ext uri="{FF2B5EF4-FFF2-40B4-BE49-F238E27FC236}">
-                <a16:creationId xmlns:a16="http://schemas.microsoft.com/office/drawing/2014/main" id="{653995E2-8647-4DD0-B649-15A63507E869}"/>
+                <a16:creationId xmlns:a16="http://schemas.microsoft.com/office/drawing/2014/main" id="{A54048C0-9773-4334-820C-680358E658AB}"/>
               </a:ext>
             </a:extLst>
           </p:cNvPr>
@@ -13594,7 +13594,7 @@
           <p:cNvPr id="34" name="Text 30">
             <a:extLst xmlns:a="http://schemas.openxmlformats.org/drawingml/2006/main">
               <a:ext uri="{FF2B5EF4-FFF2-40B4-BE49-F238E27FC236}">
-                <a16:creationId xmlns:a16="http://schemas.microsoft.com/office/drawing/2014/main" id="{EB69FD63-FDD9-4C12-BE66-0F2872F0D527}"/>
+                <a16:creationId xmlns:a16="http://schemas.microsoft.com/office/drawing/2014/main" id="{013FF271-FDBA-4F70-9FED-F53498C3F478}"/>
               </a:ext>
             </a:extLst>
           </p:cNvPr>
@@ -13649,7 +13649,7 @@
           <p:cNvPr id="35" name="Text 31">
             <a:extLst xmlns:a="http://schemas.openxmlformats.org/drawingml/2006/main">
               <a:ext uri="{FF2B5EF4-FFF2-40B4-BE49-F238E27FC236}">
-                <a16:creationId xmlns:a16="http://schemas.microsoft.com/office/drawing/2014/main" id="{6A3645EA-8A5B-4267-A89F-1499497AEB6E}"/>
+                <a16:creationId xmlns:a16="http://schemas.microsoft.com/office/drawing/2014/main" id="{12E98946-5B4C-4F10-A474-74E557FC3F01}"/>
               </a:ext>
             </a:extLst>
           </p:cNvPr>
@@ -13711,7 +13711,7 @@
           <p:cNvPr id="36" name="Text 32">
             <a:extLst xmlns:a="http://schemas.openxmlformats.org/drawingml/2006/main">
               <a:ext uri="{FF2B5EF4-FFF2-40B4-BE49-F238E27FC236}">
-                <a16:creationId xmlns:a16="http://schemas.microsoft.com/office/drawing/2014/main" id="{FAB426A9-1A27-4EAF-ADA5-84B72635102E}"/>
+                <a16:creationId xmlns:a16="http://schemas.microsoft.com/office/drawing/2014/main" id="{8E18CC81-409E-4375-847F-CECA4B8CD890}"/>
               </a:ext>
             </a:extLst>
           </p:cNvPr>
@@ -13773,7 +13773,7 @@
           <p:cNvPr id="37" name="Text 33">
             <a:extLst xmlns:a="http://schemas.openxmlformats.org/drawingml/2006/main">
               <a:ext uri="{FF2B5EF4-FFF2-40B4-BE49-F238E27FC236}">
-                <a16:creationId xmlns:a16="http://schemas.microsoft.com/office/drawing/2014/main" id="{319E501E-6A32-499C-8D3F-DEC22BED578B}"/>
+                <a16:creationId xmlns:a16="http://schemas.microsoft.com/office/drawing/2014/main" id="{5C99F9C6-9C7A-4D0B-96EF-8E89F87FFB41}"/>
               </a:ext>
             </a:extLst>
           </p:cNvPr>
@@ -13824,7 +13824,7 @@
           <p:cNvPr id="38" name="Text 34">
             <a:extLst xmlns:a="http://schemas.openxmlformats.org/drawingml/2006/main">
               <a:ext uri="{FF2B5EF4-FFF2-40B4-BE49-F238E27FC236}">
-                <a16:creationId xmlns:a16="http://schemas.microsoft.com/office/drawing/2014/main" id="{6E33A758-5695-4203-976F-16813FEBBFD7}"/>
+                <a16:creationId xmlns:a16="http://schemas.microsoft.com/office/drawing/2014/main" id="{9361DC47-0ECE-47E5-98CA-7192854746F5}"/>
               </a:ext>
             </a:extLst>
           </p:cNvPr>
@@ -13873,7 +13873,7 @@
     </p:spTree>
     <p:extLst>
       <p:ext uri="{BB962C8B-B14F-4D97-AF65-F5344CB8AC3E}">
-        <p14:creationId xmlns:p14="http://schemas.microsoft.com/office/powerpoint/2010/main" val="575955275"/>
+        <p14:creationId xmlns:p14="http://schemas.microsoft.com/office/powerpoint/2010/main" val="1576243046"/>
       </p:ext>
     </p:extLst>
   </p:cSld>
@@ -13897,18 +13897,18 @@
           <p:cNvPr id="12" name="DEMO 01 · 관리자">
             <a:extLst xmlns:a="http://schemas.openxmlformats.org/drawingml/2006/main">
               <a:ext uri="{FF2B5EF4-FFF2-40B4-BE49-F238E27FC236}">
-                <a16:creationId xmlns:a16="http://schemas.microsoft.com/office/drawing/2014/main" id="{67CE9AD3-9FE2-48D4-8BBF-EFCB23B451E1}"/>
-              </a:ext>
-            </a:extLst>
-          </p:cNvPr>
-          <p:cNvSpPr>
-            <a:spLocks xmlns:a="http://schemas.openxmlformats.org/drawingml/2006/main" noGrp="1"/>
-          </p:cNvSpPr>
-          <p:nvPr/>
-        </p:nvSpPr>
-        <p:spPr>
-          <a:xfrm xmlns:a="http://schemas.openxmlformats.org/drawingml/2006/main">
-            <a:off x="819150" y="676275"/>
+                <a16:creationId xmlns:a16="http://schemas.microsoft.com/office/drawing/2014/main" id="{7BEA15B3-4EB2-4F7C-AF36-0C9A19F8A83D}"/>
+              </a:ext>
+            </a:extLst>
+          </p:cNvPr>
+          <p:cNvSpPr>
+            <a:spLocks xmlns:a="http://schemas.openxmlformats.org/drawingml/2006/main" noGrp="1"/>
+          </p:cNvSpPr>
+          <p:nvPr/>
+        </p:nvSpPr>
+        <p:spPr>
+          <a:xfrm xmlns:a="http://schemas.openxmlformats.org/drawingml/2006/main">
+            <a:off x="819150" y="400050"/>
             <a:ext cx="8096250" cy="285750"/>
           </a:xfrm>
           <a:prstGeom xmlns:a="http://schemas.openxmlformats.org/drawingml/2006/main" prst="rect">
@@ -13965,19 +13965,19 @@
           <p:cNvPr id="2" name="작업 한 문장에서 안전 수칙까지">
             <a:extLst xmlns:a="http://schemas.openxmlformats.org/drawingml/2006/main">
               <a:ext uri="{FF2B5EF4-FFF2-40B4-BE49-F238E27FC236}">
-                <a16:creationId xmlns:a16="http://schemas.microsoft.com/office/drawing/2014/main" id="{F7F743EE-3C67-43B4-AD21-15DD25231055}"/>
-              </a:ext>
-            </a:extLst>
-          </p:cNvPr>
-          <p:cNvSpPr>
-            <a:spLocks xmlns:a="http://schemas.openxmlformats.org/drawingml/2006/main" noGrp="1"/>
-          </p:cNvSpPr>
-          <p:nvPr/>
-        </p:nvSpPr>
-        <p:spPr>
-          <a:xfrm xmlns:a="http://schemas.openxmlformats.org/drawingml/2006/main">
-            <a:off x="819150" y="1019175"/>
-            <a:ext cx="10668000" cy="571500"/>
+                <a16:creationId xmlns:a16="http://schemas.microsoft.com/office/drawing/2014/main" id="{BB84F8D4-C06A-4338-B2FE-36EBA53BDCC0}"/>
+              </a:ext>
+            </a:extLst>
+          </p:cNvPr>
+          <p:cNvSpPr>
+            <a:spLocks xmlns:a="http://schemas.openxmlformats.org/drawingml/2006/main" noGrp="1"/>
+          </p:cNvSpPr>
+          <p:nvPr/>
+        </p:nvSpPr>
+        <p:spPr>
+          <a:xfrm xmlns:a="http://schemas.openxmlformats.org/drawingml/2006/main">
+            <a:off x="819150" y="723900"/>
+            <a:ext cx="10668000" cy="457200"/>
           </a:xfrm>
           <a:prstGeom xmlns:a="http://schemas.openxmlformats.org/drawingml/2006/main" prst="rect">
             <a:avLst/>
@@ -14033,19 +14033,19 @@
           <p:cNvPr id="3" name="안전반장 · TEAM 0x02">
             <a:extLst xmlns:a="http://schemas.openxmlformats.org/drawingml/2006/main">
               <a:ext uri="{FF2B5EF4-FFF2-40B4-BE49-F238E27FC236}">
-                <a16:creationId xmlns:a16="http://schemas.microsoft.com/office/drawing/2014/main" id="{B91CE5F7-9678-401E-B294-0C094AA72B99}"/>
-              </a:ext>
-            </a:extLst>
-          </p:cNvPr>
-          <p:cNvSpPr>
-            <a:spLocks xmlns:a="http://schemas.openxmlformats.org/drawingml/2006/main" noGrp="1"/>
-          </p:cNvSpPr>
-          <p:nvPr/>
-        </p:nvSpPr>
-        <p:spPr>
-          <a:xfrm xmlns:a="http://schemas.openxmlformats.org/drawingml/2006/main">
-            <a:off x="819150" y="6334125"/>
-            <a:ext cx="6667500" cy="238125"/>
+                <a16:creationId xmlns:a16="http://schemas.microsoft.com/office/drawing/2014/main" id="{81E758C5-E2DA-4B06-9D89-1B070BDBFF89}"/>
+              </a:ext>
+            </a:extLst>
+          </p:cNvPr>
+          <p:cNvSpPr>
+            <a:spLocks xmlns:a="http://schemas.openxmlformats.org/drawingml/2006/main" noGrp="1"/>
+          </p:cNvSpPr>
+          <p:nvPr/>
+        </p:nvSpPr>
+        <p:spPr>
+          <a:xfrm xmlns:a="http://schemas.openxmlformats.org/drawingml/2006/main">
+            <a:off x="819150" y="6562725"/>
+            <a:ext cx="6667500" cy="209550"/>
           </a:xfrm>
           <a:prstGeom xmlns:a="http://schemas.openxmlformats.org/drawingml/2006/main" prst="rect">
             <a:avLst/>
@@ -14101,19 +14101,19 @@
           <p:cNvPr id="4" name="06 / 14">
             <a:extLst xmlns:a="http://schemas.openxmlformats.org/drawingml/2006/main">
               <a:ext uri="{FF2B5EF4-FFF2-40B4-BE49-F238E27FC236}">
-                <a16:creationId xmlns:a16="http://schemas.microsoft.com/office/drawing/2014/main" id="{3D952845-7AEF-42E5-96C1-326CA1FB5EA1}"/>
-              </a:ext>
-            </a:extLst>
-          </p:cNvPr>
-          <p:cNvSpPr>
-            <a:spLocks xmlns:a="http://schemas.openxmlformats.org/drawingml/2006/main" noGrp="1"/>
-          </p:cNvSpPr>
-          <p:nvPr/>
-        </p:nvSpPr>
-        <p:spPr>
-          <a:xfrm xmlns:a="http://schemas.openxmlformats.org/drawingml/2006/main">
-            <a:off x="10668000" y="6334125"/>
-            <a:ext cx="952500" cy="238125"/>
+                <a16:creationId xmlns:a16="http://schemas.microsoft.com/office/drawing/2014/main" id="{DA832F36-8297-4235-AED3-83952B65164C}"/>
+              </a:ext>
+            </a:extLst>
+          </p:cNvPr>
+          <p:cNvSpPr>
+            <a:spLocks xmlns:a="http://schemas.openxmlformats.org/drawingml/2006/main" noGrp="1"/>
+          </p:cNvSpPr>
+          <p:nvPr/>
+        </p:nvSpPr>
+        <p:spPr>
+          <a:xfrm xmlns:a="http://schemas.openxmlformats.org/drawingml/2006/main">
+            <a:off x="10668000" y="6562725"/>
+            <a:ext cx="952500" cy="209550"/>
           </a:xfrm>
           <a:prstGeom xmlns:a="http://schemas.openxmlformats.org/drawingml/2006/main" prst="rect">
             <a:avLst/>
@@ -14169,19 +14169,19 @@
           <p:cNvPr id="5" name="“2층 각파이프 용접,&#10;옆에 합판”">
             <a:extLst xmlns:a="http://schemas.openxmlformats.org/drawingml/2006/main">
               <a:ext uri="{FF2B5EF4-FFF2-40B4-BE49-F238E27FC236}">
-                <a16:creationId xmlns:a16="http://schemas.microsoft.com/office/drawing/2014/main" id="{12992AA3-0F7F-4F15-97C0-9F3C1B13A8A1}"/>
-              </a:ext>
-            </a:extLst>
-          </p:cNvPr>
-          <p:cNvSpPr>
-            <a:spLocks xmlns:a="http://schemas.openxmlformats.org/drawingml/2006/main" noGrp="1"/>
-          </p:cNvSpPr>
-          <p:nvPr/>
-        </p:nvSpPr>
-        <p:spPr>
-          <a:xfrm xmlns:a="http://schemas.openxmlformats.org/drawingml/2006/main">
-            <a:off x="819150" y="2133600"/>
-            <a:ext cx="5143500" cy="1238250"/>
+                <a16:creationId xmlns:a16="http://schemas.microsoft.com/office/drawing/2014/main" id="{09D25BE3-BF23-436C-A1F1-2A547FAF666F}"/>
+              </a:ext>
+            </a:extLst>
+          </p:cNvPr>
+          <p:cNvSpPr>
+            <a:spLocks xmlns:a="http://schemas.openxmlformats.org/drawingml/2006/main" noGrp="1"/>
+          </p:cNvSpPr>
+          <p:nvPr/>
+        </p:nvSpPr>
+        <p:spPr>
+          <a:xfrm xmlns:a="http://schemas.openxmlformats.org/drawingml/2006/main">
+            <a:off x="819150" y="2047875"/>
+            <a:ext cx="4857750" cy="1238250"/>
           </a:xfrm>
           <a:prstGeom xmlns:a="http://schemas.openxmlformats.org/drawingml/2006/main" prst="rect">
             <a:avLst/>
@@ -14260,19 +14260,19 @@
           <p:cNvPr id="6" name="현장 조건을 확인한 뒤&#10;필수·권장 수칙과 근거를 봅니다.">
             <a:extLst xmlns:a="http://schemas.openxmlformats.org/drawingml/2006/main">
               <a:ext uri="{FF2B5EF4-FFF2-40B4-BE49-F238E27FC236}">
-                <a16:creationId xmlns:a16="http://schemas.microsoft.com/office/drawing/2014/main" id="{829FFCB3-A083-4B76-AD2B-24779C9FB83C}"/>
-              </a:ext>
-            </a:extLst>
-          </p:cNvPr>
-          <p:cNvSpPr>
-            <a:spLocks xmlns:a="http://schemas.openxmlformats.org/drawingml/2006/main" noGrp="1"/>
-          </p:cNvSpPr>
-          <p:nvPr/>
-        </p:nvSpPr>
-        <p:spPr>
-          <a:xfrm xmlns:a="http://schemas.openxmlformats.org/drawingml/2006/main">
-            <a:off x="819150" y="3590925"/>
-            <a:ext cx="5095875" cy="1666875"/>
+                <a16:creationId xmlns:a16="http://schemas.microsoft.com/office/drawing/2014/main" id="{0EF2C9BA-4AEC-40D6-8AA8-A78BC246E5C0}"/>
+              </a:ext>
+            </a:extLst>
+          </p:cNvPr>
+          <p:cNvSpPr>
+            <a:spLocks xmlns:a="http://schemas.openxmlformats.org/drawingml/2006/main" noGrp="1"/>
+          </p:cNvSpPr>
+          <p:nvPr/>
+        </p:nvSpPr>
+        <p:spPr>
+          <a:xfrm xmlns:a="http://schemas.openxmlformats.org/drawingml/2006/main">
+            <a:off x="819150" y="3429000"/>
+            <a:ext cx="4857750" cy="1666875"/>
           </a:xfrm>
           <a:prstGeom xmlns:a="http://schemas.openxmlformats.org/drawingml/2006/main" prst="rect">
             <a:avLst/>
@@ -14351,19 +14351,19 @@
           <p:cNvPr id="7" name="입력한 조건과 현장 상황을&#10;반장이 다시 확인합니다.">
             <a:extLst xmlns:a="http://schemas.openxmlformats.org/drawingml/2006/main">
               <a:ext uri="{FF2B5EF4-FFF2-40B4-BE49-F238E27FC236}">
-                <a16:creationId xmlns:a16="http://schemas.microsoft.com/office/drawing/2014/main" id="{4C9E24B5-A0F1-4FB7-A952-403899405241}"/>
-              </a:ext>
-            </a:extLst>
-          </p:cNvPr>
-          <p:cNvSpPr>
-            <a:spLocks xmlns:a="http://schemas.openxmlformats.org/drawingml/2006/main" noGrp="1"/>
-          </p:cNvSpPr>
-          <p:nvPr/>
-        </p:nvSpPr>
-        <p:spPr>
-          <a:xfrm xmlns:a="http://schemas.openxmlformats.org/drawingml/2006/main">
-            <a:off x="819150" y="5467350"/>
-            <a:ext cx="5143500" cy="619125"/>
+                <a16:creationId xmlns:a16="http://schemas.microsoft.com/office/drawing/2014/main" id="{7DBA5E58-F350-4896-8D62-A2EB4A4F4955}"/>
+              </a:ext>
+            </a:extLst>
+          </p:cNvPr>
+          <p:cNvSpPr>
+            <a:spLocks xmlns:a="http://schemas.openxmlformats.org/drawingml/2006/main" noGrp="1"/>
+          </p:cNvSpPr>
+          <p:nvPr/>
+        </p:nvSpPr>
+        <p:spPr>
+          <a:xfrm xmlns:a="http://schemas.openxmlformats.org/drawingml/2006/main">
+            <a:off x="819150" y="5362575"/>
+            <a:ext cx="4857750" cy="619125"/>
           </a:xfrm>
           <a:prstGeom xmlns:a="http://schemas.openxmlformats.org/drawingml/2006/main" prst="rect">
             <a:avLst/>
@@ -14442,19 +14442,19 @@
           <p:cNvPr id="8" name="작업 입력">
             <a:extLst xmlns:a="http://schemas.openxmlformats.org/drawingml/2006/main">
               <a:ext uri="{FF2B5EF4-FFF2-40B4-BE49-F238E27FC236}">
-                <a16:creationId xmlns:a16="http://schemas.microsoft.com/office/drawing/2014/main" id="{F0F7186F-D1EC-4533-8A7F-133523C5D285}"/>
-              </a:ext>
-            </a:extLst>
-          </p:cNvPr>
-          <p:cNvSpPr>
-            <a:spLocks xmlns:a="http://schemas.openxmlformats.org/drawingml/2006/main" noGrp="1"/>
-          </p:cNvSpPr>
-          <p:nvPr/>
-        </p:nvSpPr>
-        <p:spPr>
-          <a:xfrm xmlns:a="http://schemas.openxmlformats.org/drawingml/2006/main">
-            <a:off x="6524625" y="1609725"/>
-            <a:ext cx="2095500" cy="238125"/>
+                <a16:creationId xmlns:a16="http://schemas.microsoft.com/office/drawing/2014/main" id="{80AEFF71-A5BF-48AF-8F11-F8C568024048}"/>
+              </a:ext>
+            </a:extLst>
+          </p:cNvPr>
+          <p:cNvSpPr>
+            <a:spLocks xmlns:a="http://schemas.openxmlformats.org/drawingml/2006/main" noGrp="1"/>
+          </p:cNvSpPr>
+          <p:nvPr/>
+        </p:nvSpPr>
+        <p:spPr>
+          <a:xfrm xmlns:a="http://schemas.openxmlformats.org/drawingml/2006/main">
+            <a:off x="6096000" y="1257300"/>
+            <a:ext cx="2245519" cy="238125"/>
           </a:xfrm>
           <a:prstGeom xmlns:a="http://schemas.openxmlformats.org/drawingml/2006/main" prst="rect">
             <a:avLst/>
@@ -14510,19 +14510,19 @@
           <p:cNvPr id="9" name="체크리스트">
             <a:extLst xmlns:a="http://schemas.openxmlformats.org/drawingml/2006/main">
               <a:ext uri="{FF2B5EF4-FFF2-40B4-BE49-F238E27FC236}">
-                <a16:creationId xmlns:a16="http://schemas.microsoft.com/office/drawing/2014/main" id="{3DD02E70-B148-4F22-9FD0-E5B7E6B70306}"/>
-              </a:ext>
-            </a:extLst>
-          </p:cNvPr>
-          <p:cNvSpPr>
-            <a:spLocks xmlns:a="http://schemas.openxmlformats.org/drawingml/2006/main" noGrp="1"/>
-          </p:cNvSpPr>
-          <p:nvPr/>
-        </p:nvSpPr>
-        <p:spPr>
-          <a:xfrm xmlns:a="http://schemas.openxmlformats.org/drawingml/2006/main">
-            <a:off x="9048750" y="1609725"/>
-            <a:ext cx="2095500" cy="238125"/>
+                <a16:creationId xmlns:a16="http://schemas.microsoft.com/office/drawing/2014/main" id="{747C8587-3EAF-4BED-BC8B-77F077D9DD9B}"/>
+              </a:ext>
+            </a:extLst>
+          </p:cNvPr>
+          <p:cNvSpPr>
+            <a:spLocks xmlns:a="http://schemas.openxmlformats.org/drawingml/2006/main" noGrp="1"/>
+          </p:cNvSpPr>
+          <p:nvPr/>
+        </p:nvSpPr>
+        <p:spPr>
+          <a:xfrm xmlns:a="http://schemas.openxmlformats.org/drawingml/2006/main">
+            <a:off x="8858250" y="1257300"/>
+            <a:ext cx="2245519" cy="238125"/>
           </a:xfrm>
           <a:prstGeom xmlns:a="http://schemas.openxmlformats.org/drawingml/2006/main" prst="rect">
             <a:avLst/>
@@ -14578,7 +14578,7 @@
           <p:cNvPr id="10" name="">
             <a:extLst xmlns:a="http://schemas.openxmlformats.org/drawingml/2006/main">
               <a:ext uri="{FF2B5EF4-FFF2-40B4-BE49-F238E27FC236}">
-                <a16:creationId xmlns:a16="http://schemas.microsoft.com/office/drawing/2014/main" id="{DCD77180-7F25-49F9-8B91-3F122CB21A29}"/>
+                <a16:creationId xmlns:a16="http://schemas.microsoft.com/office/drawing/2014/main" id="{6C42077E-D6BD-4E59-9D29-BD60844D9FC6}"/>
               </a:ext>
             </a:extLst>
           </p:cNvPr>
@@ -14588,13 +14588,13 @@
           <p:nvPr/>
         </p:nvPicPr>
         <p:blipFill>
-          <a:blip xmlns:r="http://schemas.openxmlformats.org/officeDocument/2006/relationships" xmlns:a="http://schemas.openxmlformats.org/drawingml/2006/main" r:embed="Reac5dd80cd564ecc"/>
+          <a:blip xmlns:r="http://schemas.openxmlformats.org/officeDocument/2006/relationships" xmlns:a="http://schemas.openxmlformats.org/drawingml/2006/main" r:embed="Reb6b71535ba74ad5"/>
           <a:stretch xmlns:a="http://schemas.openxmlformats.org/drawingml/2006/main"/>
         </p:blipFill>
         <p:spPr>
           <a:xfrm xmlns:a="http://schemas.openxmlformats.org/drawingml/2006/main">
-            <a:off x="6524625" y="1924050"/>
-            <a:ext cx="1952625" cy="4225681"/>
+            <a:off x="6096000" y="1524000"/>
+            <a:ext cx="2245519" cy="4859533"/>
           </a:xfrm>
           <a:prstGeom xmlns:a="http://schemas.openxmlformats.org/drawingml/2006/main" prst="rect">
             <a:avLst/>
@@ -14606,7 +14606,7 @@
           <p:cNvPr id="11" name="">
             <a:extLst xmlns:a="http://schemas.openxmlformats.org/drawingml/2006/main">
               <a:ext uri="{FF2B5EF4-FFF2-40B4-BE49-F238E27FC236}">
-                <a16:creationId xmlns:a16="http://schemas.microsoft.com/office/drawing/2014/main" id="{44EB8D9D-7C9F-4D67-8FE4-78267073052B}"/>
+                <a16:creationId xmlns:a16="http://schemas.microsoft.com/office/drawing/2014/main" id="{47BC4C45-4D40-4FCC-AEE5-6254011F8800}"/>
               </a:ext>
             </a:extLst>
           </p:cNvPr>
@@ -14616,13 +14616,13 @@
           <p:nvPr/>
         </p:nvPicPr>
         <p:blipFill>
-          <a:blip xmlns:r="http://schemas.openxmlformats.org/officeDocument/2006/relationships" xmlns:a="http://schemas.openxmlformats.org/drawingml/2006/main" r:embed="Rc7355fa870e44087"/>
+          <a:blip xmlns:r="http://schemas.openxmlformats.org/officeDocument/2006/relationships" xmlns:a="http://schemas.openxmlformats.org/drawingml/2006/main" r:embed="R13e42d370d94463d"/>
           <a:stretch xmlns:a="http://schemas.openxmlformats.org/drawingml/2006/main"/>
         </p:blipFill>
         <p:spPr>
           <a:xfrm xmlns:a="http://schemas.openxmlformats.org/drawingml/2006/main">
-            <a:off x="9048750" y="1924050"/>
-            <a:ext cx="1952625" cy="4225681"/>
+            <a:off x="8858250" y="1524000"/>
+            <a:ext cx="2245519" cy="4859533"/>
           </a:xfrm>
           <a:prstGeom xmlns:a="http://schemas.openxmlformats.org/drawingml/2006/main" prst="rect">
             <a:avLst/>
@@ -14632,7 +14632,7 @@
     </p:spTree>
     <p:extLst>
       <p:ext uri="{BB962C8B-B14F-4D97-AF65-F5344CB8AC3E}">
-        <p14:creationId xmlns:p14="http://schemas.microsoft.com/office/powerpoint/2010/main" val="1747154781"/>
+        <p14:creationId xmlns:p14="http://schemas.microsoft.com/office/powerpoint/2010/main" val="415221549"/>
       </p:ext>
     </p:extLst>
   </p:cSld>
@@ -14656,18 +14656,18 @@
           <p:cNvPr id="9" name="DEMO 02 · 관리자">
             <a:extLst xmlns:a="http://schemas.openxmlformats.org/drawingml/2006/main">
               <a:ext uri="{FF2B5EF4-FFF2-40B4-BE49-F238E27FC236}">
-                <a16:creationId xmlns:a16="http://schemas.microsoft.com/office/drawing/2014/main" id="{0012B5D4-5B2A-4F22-B6DF-3B42C5C6CD57}"/>
-              </a:ext>
-            </a:extLst>
-          </p:cNvPr>
-          <p:cNvSpPr>
-            <a:spLocks xmlns:a="http://schemas.openxmlformats.org/drawingml/2006/main" noGrp="1"/>
-          </p:cNvSpPr>
-          <p:nvPr/>
-        </p:nvSpPr>
-        <p:spPr>
-          <a:xfrm xmlns:a="http://schemas.openxmlformats.org/drawingml/2006/main">
-            <a:off x="819150" y="676275"/>
+                <a16:creationId xmlns:a16="http://schemas.microsoft.com/office/drawing/2014/main" id="{ED9DD8D6-58FB-42D2-A9FD-F3FAE22CD717}"/>
+              </a:ext>
+            </a:extLst>
+          </p:cNvPr>
+          <p:cNvSpPr>
+            <a:spLocks xmlns:a="http://schemas.openxmlformats.org/drawingml/2006/main" noGrp="1"/>
+          </p:cNvSpPr>
+          <p:nvPr/>
+        </p:nvSpPr>
+        <p:spPr>
+          <a:xfrm xmlns:a="http://schemas.openxmlformats.org/drawingml/2006/main">
+            <a:off x="819150" y="400050"/>
             <a:ext cx="8096250" cy="285750"/>
           </a:xfrm>
           <a:prstGeom xmlns:a="http://schemas.openxmlformats.org/drawingml/2006/main" prst="rect">
@@ -14724,19 +14724,19 @@
           <p:cNvPr id="2" name="TBM에서 빠진 필수 수칙을 다시 확인합니다">
             <a:extLst xmlns:a="http://schemas.openxmlformats.org/drawingml/2006/main">
               <a:ext uri="{FF2B5EF4-FFF2-40B4-BE49-F238E27FC236}">
-                <a16:creationId xmlns:a16="http://schemas.microsoft.com/office/drawing/2014/main" id="{0E6F33C8-70F4-4A8A-9F67-D5F2A4F53E22}"/>
-              </a:ext>
-            </a:extLst>
-          </p:cNvPr>
-          <p:cNvSpPr>
-            <a:spLocks xmlns:a="http://schemas.openxmlformats.org/drawingml/2006/main" noGrp="1"/>
-          </p:cNvSpPr>
-          <p:nvPr/>
-        </p:nvSpPr>
-        <p:spPr>
-          <a:xfrm xmlns:a="http://schemas.openxmlformats.org/drawingml/2006/main">
-            <a:off x="819150" y="1019175"/>
-            <a:ext cx="10668000" cy="571500"/>
+                <a16:creationId xmlns:a16="http://schemas.microsoft.com/office/drawing/2014/main" id="{4E671979-0E2C-4543-A226-DA2A0471DE5B}"/>
+              </a:ext>
+            </a:extLst>
+          </p:cNvPr>
+          <p:cNvSpPr>
+            <a:spLocks xmlns:a="http://schemas.openxmlformats.org/drawingml/2006/main" noGrp="1"/>
+          </p:cNvSpPr>
+          <p:nvPr/>
+        </p:nvSpPr>
+        <p:spPr>
+          <a:xfrm xmlns:a="http://schemas.openxmlformats.org/drawingml/2006/main">
+            <a:off x="819150" y="723900"/>
+            <a:ext cx="10668000" cy="457200"/>
           </a:xfrm>
           <a:prstGeom xmlns:a="http://schemas.openxmlformats.org/drawingml/2006/main" prst="rect">
             <a:avLst/>
@@ -14792,19 +14792,19 @@
           <p:cNvPr id="3" name="안전반장 · TEAM 0x02">
             <a:extLst xmlns:a="http://schemas.openxmlformats.org/drawingml/2006/main">
               <a:ext uri="{FF2B5EF4-FFF2-40B4-BE49-F238E27FC236}">
-                <a16:creationId xmlns:a16="http://schemas.microsoft.com/office/drawing/2014/main" id="{73930189-6437-4D3B-A380-3BD680C3AC38}"/>
-              </a:ext>
-            </a:extLst>
-          </p:cNvPr>
-          <p:cNvSpPr>
-            <a:spLocks xmlns:a="http://schemas.openxmlformats.org/drawingml/2006/main" noGrp="1"/>
-          </p:cNvSpPr>
-          <p:nvPr/>
-        </p:nvSpPr>
-        <p:spPr>
-          <a:xfrm xmlns:a="http://schemas.openxmlformats.org/drawingml/2006/main">
-            <a:off x="819150" y="6334125"/>
-            <a:ext cx="6667500" cy="238125"/>
+                <a16:creationId xmlns:a16="http://schemas.microsoft.com/office/drawing/2014/main" id="{D049A963-174F-4B2E-9114-5C81B11B2D32}"/>
+              </a:ext>
+            </a:extLst>
+          </p:cNvPr>
+          <p:cNvSpPr>
+            <a:spLocks xmlns:a="http://schemas.openxmlformats.org/drawingml/2006/main" noGrp="1"/>
+          </p:cNvSpPr>
+          <p:nvPr/>
+        </p:nvSpPr>
+        <p:spPr>
+          <a:xfrm xmlns:a="http://schemas.openxmlformats.org/drawingml/2006/main">
+            <a:off x="819150" y="6562725"/>
+            <a:ext cx="6667500" cy="209550"/>
           </a:xfrm>
           <a:prstGeom xmlns:a="http://schemas.openxmlformats.org/drawingml/2006/main" prst="rect">
             <a:avLst/>
@@ -14860,19 +14860,19 @@
           <p:cNvPr id="4" name="07 / 14">
             <a:extLst xmlns:a="http://schemas.openxmlformats.org/drawingml/2006/main">
               <a:ext uri="{FF2B5EF4-FFF2-40B4-BE49-F238E27FC236}">
-                <a16:creationId xmlns:a16="http://schemas.microsoft.com/office/drawing/2014/main" id="{EB92228A-C266-4CD3-9454-C00A32120AFD}"/>
-              </a:ext>
-            </a:extLst>
-          </p:cNvPr>
-          <p:cNvSpPr>
-            <a:spLocks xmlns:a="http://schemas.openxmlformats.org/drawingml/2006/main" noGrp="1"/>
-          </p:cNvSpPr>
-          <p:nvPr/>
-        </p:nvSpPr>
-        <p:spPr>
-          <a:xfrm xmlns:a="http://schemas.openxmlformats.org/drawingml/2006/main">
-            <a:off x="10668000" y="6334125"/>
-            <a:ext cx="952500" cy="238125"/>
+                <a16:creationId xmlns:a16="http://schemas.microsoft.com/office/drawing/2014/main" id="{1FB42B84-B7C1-4C7C-8D54-8AF02E57A022}"/>
+              </a:ext>
+            </a:extLst>
+          </p:cNvPr>
+          <p:cNvSpPr>
+            <a:spLocks xmlns:a="http://schemas.openxmlformats.org/drawingml/2006/main" noGrp="1"/>
+          </p:cNvSpPr>
+          <p:nvPr/>
+        </p:nvSpPr>
+        <p:spPr>
+          <a:xfrm xmlns:a="http://schemas.openxmlformats.org/drawingml/2006/main">
+            <a:off x="10668000" y="6562725"/>
+            <a:ext cx="952500" cy="209550"/>
           </a:xfrm>
           <a:prstGeom xmlns:a="http://schemas.openxmlformats.org/drawingml/2006/main" prst="rect">
             <a:avLst/>
@@ -14928,19 +14928,19 @@
           <p:cNvPr id="5" name="회의 기록을&#10;필수 수칙과 비교">
             <a:extLst xmlns:a="http://schemas.openxmlformats.org/drawingml/2006/main">
               <a:ext uri="{FF2B5EF4-FFF2-40B4-BE49-F238E27FC236}">
-                <a16:creationId xmlns:a16="http://schemas.microsoft.com/office/drawing/2014/main" id="{8451692C-3239-4F47-901B-D3620229EB69}"/>
-              </a:ext>
-            </a:extLst>
-          </p:cNvPr>
-          <p:cNvSpPr>
-            <a:spLocks xmlns:a="http://schemas.openxmlformats.org/drawingml/2006/main" noGrp="1"/>
-          </p:cNvSpPr>
-          <p:nvPr/>
-        </p:nvSpPr>
-        <p:spPr>
-          <a:xfrm xmlns:a="http://schemas.openxmlformats.org/drawingml/2006/main">
-            <a:off x="819150" y="2133600"/>
-            <a:ext cx="5143500" cy="1238250"/>
+                <a16:creationId xmlns:a16="http://schemas.microsoft.com/office/drawing/2014/main" id="{37535C8F-37E7-4BD7-BE0C-B20D5EA80C2A}"/>
+              </a:ext>
+            </a:extLst>
+          </p:cNvPr>
+          <p:cNvSpPr>
+            <a:spLocks xmlns:a="http://schemas.openxmlformats.org/drawingml/2006/main" noGrp="1"/>
+          </p:cNvSpPr>
+          <p:nvPr/>
+        </p:nvSpPr>
+        <p:spPr>
+          <a:xfrm xmlns:a="http://schemas.openxmlformats.org/drawingml/2006/main">
+            <a:off x="819150" y="2047875"/>
+            <a:ext cx="4857750" cy="1238250"/>
           </a:xfrm>
           <a:prstGeom xmlns:a="http://schemas.openxmlformats.org/drawingml/2006/main" prst="rect">
             <a:avLst/>
@@ -15019,19 +15019,19 @@
           <p:cNvPr id="6" name="오늘 나눈 내용을 저장하면&#10;빠진 수칙을 다시 짚을 수 있습">
             <a:extLst xmlns:a="http://schemas.openxmlformats.org/drawingml/2006/main">
               <a:ext uri="{FF2B5EF4-FFF2-40B4-BE49-F238E27FC236}">
-                <a16:creationId xmlns:a16="http://schemas.microsoft.com/office/drawing/2014/main" id="{D4596F60-3951-4ADF-9AF2-F9FDDC31EACB}"/>
-              </a:ext>
-            </a:extLst>
-          </p:cNvPr>
-          <p:cNvSpPr>
-            <a:spLocks xmlns:a="http://schemas.openxmlformats.org/drawingml/2006/main" noGrp="1"/>
-          </p:cNvSpPr>
-          <p:nvPr/>
-        </p:nvSpPr>
-        <p:spPr>
-          <a:xfrm xmlns:a="http://schemas.openxmlformats.org/drawingml/2006/main">
-            <a:off x="819150" y="3590925"/>
-            <a:ext cx="5095875" cy="1666875"/>
+                <a16:creationId xmlns:a16="http://schemas.microsoft.com/office/drawing/2014/main" id="{7446023F-81DC-4D11-8C98-373965EC46EE}"/>
+              </a:ext>
+            </a:extLst>
+          </p:cNvPr>
+          <p:cNvSpPr>
+            <a:spLocks xmlns:a="http://schemas.openxmlformats.org/drawingml/2006/main" noGrp="1"/>
+          </p:cNvSpPr>
+          <p:nvPr/>
+        </p:nvSpPr>
+        <p:spPr>
+          <a:xfrm xmlns:a="http://schemas.openxmlformats.org/drawingml/2006/main">
+            <a:off x="819150" y="3429000"/>
+            <a:ext cx="4857750" cy="1666875"/>
           </a:xfrm>
           <a:prstGeom xmlns:a="http://schemas.openxmlformats.org/drawingml/2006/main" prst="rect">
             <a:avLst/>
@@ -15110,19 +15110,19 @@
           <p:cNvPr id="7" name="현재 누락 점검은 규칙·표현 비교이며&#10;회의 의미 전체를 분">
             <a:extLst xmlns:a="http://schemas.openxmlformats.org/drawingml/2006/main">
               <a:ext uri="{FF2B5EF4-FFF2-40B4-BE49-F238E27FC236}">
-                <a16:creationId xmlns:a16="http://schemas.microsoft.com/office/drawing/2014/main" id="{6EAD506C-C2F4-4979-BE16-FA6DA4C95E09}"/>
-              </a:ext>
-            </a:extLst>
-          </p:cNvPr>
-          <p:cNvSpPr>
-            <a:spLocks xmlns:a="http://schemas.openxmlformats.org/drawingml/2006/main" noGrp="1"/>
-          </p:cNvSpPr>
-          <p:nvPr/>
-        </p:nvSpPr>
-        <p:spPr>
-          <a:xfrm xmlns:a="http://schemas.openxmlformats.org/drawingml/2006/main">
-            <a:off x="819150" y="5467350"/>
-            <a:ext cx="5143500" cy="619125"/>
+                <a16:creationId xmlns:a16="http://schemas.microsoft.com/office/drawing/2014/main" id="{1947A9EB-288B-4836-9464-C83050DC57D7}"/>
+              </a:ext>
+            </a:extLst>
+          </p:cNvPr>
+          <p:cNvSpPr>
+            <a:spLocks xmlns:a="http://schemas.openxmlformats.org/drawingml/2006/main" noGrp="1"/>
+          </p:cNvSpPr>
+          <p:nvPr/>
+        </p:nvSpPr>
+        <p:spPr>
+          <a:xfrm xmlns:a="http://schemas.openxmlformats.org/drawingml/2006/main">
+            <a:off x="819150" y="5362575"/>
+            <a:ext cx="4857750" cy="619125"/>
           </a:xfrm>
           <a:prstGeom xmlns:a="http://schemas.openxmlformats.org/drawingml/2006/main" prst="rect">
             <a:avLst/>
@@ -15201,7 +15201,7 @@
           <p:cNvPr id="8" name="">
             <a:extLst xmlns:a="http://schemas.openxmlformats.org/drawingml/2006/main">
               <a:ext uri="{FF2B5EF4-FFF2-40B4-BE49-F238E27FC236}">
-                <a16:creationId xmlns:a16="http://schemas.microsoft.com/office/drawing/2014/main" id="{5C168606-46AC-4E03-A67C-CF671B14A74E}"/>
+                <a16:creationId xmlns:a16="http://schemas.microsoft.com/office/drawing/2014/main" id="{DBEDB1BD-6FD8-4F71-AEDD-1A5C177CCF64}"/>
               </a:ext>
             </a:extLst>
           </p:cNvPr>
@@ -15211,13 +15211,13 @@
           <p:nvPr/>
         </p:nvPicPr>
         <p:blipFill>
-          <a:blip xmlns:r="http://schemas.openxmlformats.org/officeDocument/2006/relationships" xmlns:a="http://schemas.openxmlformats.org/drawingml/2006/main" r:embed="Radb497d0212a4410"/>
+          <a:blip xmlns:r="http://schemas.openxmlformats.org/officeDocument/2006/relationships" xmlns:a="http://schemas.openxmlformats.org/drawingml/2006/main" r:embed="Ra3b4e374ea9d4785"/>
           <a:stretch xmlns:a="http://schemas.openxmlformats.org/drawingml/2006/main"/>
         </p:blipFill>
         <p:spPr>
           <a:xfrm xmlns:a="http://schemas.openxmlformats.org/drawingml/2006/main">
-            <a:off x="7667625" y="1666875"/>
-            <a:ext cx="2095500" cy="4534877"/>
+            <a:off x="7667625" y="1209675"/>
+            <a:ext cx="2409825" cy="5215108"/>
           </a:xfrm>
           <a:prstGeom xmlns:a="http://schemas.openxmlformats.org/drawingml/2006/main" prst="rect">
             <a:avLst/>
@@ -15227,7 +15227,7 @@
     </p:spTree>
     <p:extLst>
       <p:ext uri="{BB962C8B-B14F-4D97-AF65-F5344CB8AC3E}">
-        <p14:creationId xmlns:p14="http://schemas.microsoft.com/office/powerpoint/2010/main" val="1866749257"/>
+        <p14:creationId xmlns:p14="http://schemas.microsoft.com/office/powerpoint/2010/main" val="1649506637"/>
       </p:ext>
     </p:extLst>
   </p:cSld>
@@ -15251,18 +15251,18 @@
           <p:cNvPr id="12" name="DEMO 03 · 사진 증빙">
             <a:extLst xmlns:a="http://schemas.openxmlformats.org/drawingml/2006/main">
               <a:ext uri="{FF2B5EF4-FFF2-40B4-BE49-F238E27FC236}">
-                <a16:creationId xmlns:a16="http://schemas.microsoft.com/office/drawing/2014/main" id="{7DB9755A-42C1-4E36-B711-C9A42C6B9ABC}"/>
-              </a:ext>
-            </a:extLst>
-          </p:cNvPr>
-          <p:cNvSpPr>
-            <a:spLocks xmlns:a="http://schemas.openxmlformats.org/drawingml/2006/main" noGrp="1"/>
-          </p:cNvSpPr>
-          <p:nvPr/>
-        </p:nvSpPr>
-        <p:spPr>
-          <a:xfrm xmlns:a="http://schemas.openxmlformats.org/drawingml/2006/main">
-            <a:off x="819150" y="676275"/>
+                <a16:creationId xmlns:a16="http://schemas.microsoft.com/office/drawing/2014/main" id="{454F9B84-C3BA-4852-B2DE-4D946821B7EE}"/>
+              </a:ext>
+            </a:extLst>
+          </p:cNvPr>
+          <p:cNvSpPr>
+            <a:spLocks xmlns:a="http://schemas.openxmlformats.org/drawingml/2006/main" noGrp="1"/>
+          </p:cNvSpPr>
+          <p:nvPr/>
+        </p:nvSpPr>
+        <p:spPr>
+          <a:xfrm xmlns:a="http://schemas.openxmlformats.org/drawingml/2006/main">
+            <a:off x="819150" y="400050"/>
             <a:ext cx="8096250" cy="285750"/>
           </a:xfrm>
           <a:prstGeom xmlns:a="http://schemas.openxmlformats.org/drawingml/2006/main" prst="rect">
@@ -15319,19 +15319,19 @@
           <p:cNvPr id="2" name="판단이 어려운 사진은 관리자 확인으로 이어집니다">
             <a:extLst xmlns:a="http://schemas.openxmlformats.org/drawingml/2006/main">
               <a:ext uri="{FF2B5EF4-FFF2-40B4-BE49-F238E27FC236}">
-                <a16:creationId xmlns:a16="http://schemas.microsoft.com/office/drawing/2014/main" id="{2AA1159D-D893-485D-A354-04A3D5E7A959}"/>
-              </a:ext>
-            </a:extLst>
-          </p:cNvPr>
-          <p:cNvSpPr>
-            <a:spLocks xmlns:a="http://schemas.openxmlformats.org/drawingml/2006/main" noGrp="1"/>
-          </p:cNvSpPr>
-          <p:nvPr/>
-        </p:nvSpPr>
-        <p:spPr>
-          <a:xfrm xmlns:a="http://schemas.openxmlformats.org/drawingml/2006/main">
-            <a:off x="819150" y="1019175"/>
-            <a:ext cx="10668000" cy="571500"/>
+                <a16:creationId xmlns:a16="http://schemas.microsoft.com/office/drawing/2014/main" id="{76C97AC8-138F-409E-BE20-3194F6CF7034}"/>
+              </a:ext>
+            </a:extLst>
+          </p:cNvPr>
+          <p:cNvSpPr>
+            <a:spLocks xmlns:a="http://schemas.openxmlformats.org/drawingml/2006/main" noGrp="1"/>
+          </p:cNvSpPr>
+          <p:nvPr/>
+        </p:nvSpPr>
+        <p:spPr>
+          <a:xfrm xmlns:a="http://schemas.openxmlformats.org/drawingml/2006/main">
+            <a:off x="819150" y="723900"/>
+            <a:ext cx="10668000" cy="457200"/>
           </a:xfrm>
           <a:prstGeom xmlns:a="http://schemas.openxmlformats.org/drawingml/2006/main" prst="rect">
             <a:avLst/>
@@ -15387,19 +15387,19 @@
           <p:cNvPr id="3" name="안전반장 · TEAM 0x02">
             <a:extLst xmlns:a="http://schemas.openxmlformats.org/drawingml/2006/main">
               <a:ext uri="{FF2B5EF4-FFF2-40B4-BE49-F238E27FC236}">
-                <a16:creationId xmlns:a16="http://schemas.microsoft.com/office/drawing/2014/main" id="{8268A93D-F0E9-4BB2-9CA8-CD3791DE129E}"/>
-              </a:ext>
-            </a:extLst>
-          </p:cNvPr>
-          <p:cNvSpPr>
-            <a:spLocks xmlns:a="http://schemas.openxmlformats.org/drawingml/2006/main" noGrp="1"/>
-          </p:cNvSpPr>
-          <p:nvPr/>
-        </p:nvSpPr>
-        <p:spPr>
-          <a:xfrm xmlns:a="http://schemas.openxmlformats.org/drawingml/2006/main">
-            <a:off x="819150" y="6334125"/>
-            <a:ext cx="6667500" cy="238125"/>
+                <a16:creationId xmlns:a16="http://schemas.microsoft.com/office/drawing/2014/main" id="{E8FF06EF-8590-4073-B3A1-D3D46E45077F}"/>
+              </a:ext>
+            </a:extLst>
+          </p:cNvPr>
+          <p:cNvSpPr>
+            <a:spLocks xmlns:a="http://schemas.openxmlformats.org/drawingml/2006/main" noGrp="1"/>
+          </p:cNvSpPr>
+          <p:nvPr/>
+        </p:nvSpPr>
+        <p:spPr>
+          <a:xfrm xmlns:a="http://schemas.openxmlformats.org/drawingml/2006/main">
+            <a:off x="819150" y="6562725"/>
+            <a:ext cx="6667500" cy="209550"/>
           </a:xfrm>
           <a:prstGeom xmlns:a="http://schemas.openxmlformats.org/drawingml/2006/main" prst="rect">
             <a:avLst/>
@@ -15455,19 +15455,19 @@
           <p:cNvPr id="4" name="08 / 14">
             <a:extLst xmlns:a="http://schemas.openxmlformats.org/drawingml/2006/main">
               <a:ext uri="{FF2B5EF4-FFF2-40B4-BE49-F238E27FC236}">
-                <a16:creationId xmlns:a16="http://schemas.microsoft.com/office/drawing/2014/main" id="{1F717463-4653-47D9-BBA1-E661EEE0D7DD}"/>
-              </a:ext>
-            </a:extLst>
-          </p:cNvPr>
-          <p:cNvSpPr>
-            <a:spLocks xmlns:a="http://schemas.openxmlformats.org/drawingml/2006/main" noGrp="1"/>
-          </p:cNvSpPr>
-          <p:nvPr/>
-        </p:nvSpPr>
-        <p:spPr>
-          <a:xfrm xmlns:a="http://schemas.openxmlformats.org/drawingml/2006/main">
-            <a:off x="10668000" y="6334125"/>
-            <a:ext cx="952500" cy="238125"/>
+                <a16:creationId xmlns:a16="http://schemas.microsoft.com/office/drawing/2014/main" id="{D2A118D6-126C-459B-8572-52BF24392381}"/>
+              </a:ext>
+            </a:extLst>
+          </p:cNvPr>
+          <p:cNvSpPr>
+            <a:spLocks xmlns:a="http://schemas.openxmlformats.org/drawingml/2006/main" noGrp="1"/>
+          </p:cNvSpPr>
+          <p:nvPr/>
+        </p:nvSpPr>
+        <p:spPr>
+          <a:xfrm xmlns:a="http://schemas.openxmlformats.org/drawingml/2006/main">
+            <a:off x="10668000" y="6562725"/>
+            <a:ext cx="952500" cy="209550"/>
           </a:xfrm>
           <a:prstGeom xmlns:a="http://schemas.openxmlformats.org/drawingml/2006/main" prst="rect">
             <a:avLst/>
@@ -15523,19 +15523,19 @@
           <p:cNvPr id="5" name="사진에서 확인할 수 있는&#10;조치를 살펴봅니다">
             <a:extLst xmlns:a="http://schemas.openxmlformats.org/drawingml/2006/main">
               <a:ext uri="{FF2B5EF4-FFF2-40B4-BE49-F238E27FC236}">
-                <a16:creationId xmlns:a16="http://schemas.microsoft.com/office/drawing/2014/main" id="{4BA88019-9A18-42EB-B4BE-1E16F36209D5}"/>
-              </a:ext>
-            </a:extLst>
-          </p:cNvPr>
-          <p:cNvSpPr>
-            <a:spLocks xmlns:a="http://schemas.openxmlformats.org/drawingml/2006/main" noGrp="1"/>
-          </p:cNvSpPr>
-          <p:nvPr/>
-        </p:nvSpPr>
-        <p:spPr>
-          <a:xfrm xmlns:a="http://schemas.openxmlformats.org/drawingml/2006/main">
-            <a:off x="819150" y="2133600"/>
-            <a:ext cx="5143500" cy="1238250"/>
+                <a16:creationId xmlns:a16="http://schemas.microsoft.com/office/drawing/2014/main" id="{64DB1F38-2747-4CFB-AD03-AA25EAADED91}"/>
+              </a:ext>
+            </a:extLst>
+          </p:cNvPr>
+          <p:cNvSpPr>
+            <a:spLocks xmlns:a="http://schemas.openxmlformats.org/drawingml/2006/main" noGrp="1"/>
+          </p:cNvSpPr>
+          <p:nvPr/>
+        </p:nvSpPr>
+        <p:spPr>
+          <a:xfrm xmlns:a="http://schemas.openxmlformats.org/drawingml/2006/main">
+            <a:off x="819150" y="2047875"/>
+            <a:ext cx="4857750" cy="1238250"/>
           </a:xfrm>
           <a:prstGeom xmlns:a="http://schemas.openxmlformats.org/drawingml/2006/main" prst="rect">
             <a:avLst/>
@@ -15614,19 +15614,19 @@
           <p:cNvPr id="6" name="확인됨 · 안 보임 · 판단불가&#10;판정 이유와 함께 검토합니">
             <a:extLst xmlns:a="http://schemas.openxmlformats.org/drawingml/2006/main">
               <a:ext uri="{FF2B5EF4-FFF2-40B4-BE49-F238E27FC236}">
-                <a16:creationId xmlns:a16="http://schemas.microsoft.com/office/drawing/2014/main" id="{2117389F-F4BB-42AA-A851-ACA4A7347D80}"/>
-              </a:ext>
-            </a:extLst>
-          </p:cNvPr>
-          <p:cNvSpPr>
-            <a:spLocks xmlns:a="http://schemas.openxmlformats.org/drawingml/2006/main" noGrp="1"/>
-          </p:cNvSpPr>
-          <p:nvPr/>
-        </p:nvSpPr>
-        <p:spPr>
-          <a:xfrm xmlns:a="http://schemas.openxmlformats.org/drawingml/2006/main">
-            <a:off x="819150" y="3590925"/>
-            <a:ext cx="5095875" cy="1666875"/>
+                <a16:creationId xmlns:a16="http://schemas.microsoft.com/office/drawing/2014/main" id="{1606FEDA-1D7D-4C85-B0F4-B4AD6EE2C7D1}"/>
+              </a:ext>
+            </a:extLst>
+          </p:cNvPr>
+          <p:cNvSpPr>
+            <a:spLocks xmlns:a="http://schemas.openxmlformats.org/drawingml/2006/main" noGrp="1"/>
+          </p:cNvSpPr>
+          <p:nvPr/>
+        </p:nvSpPr>
+        <p:spPr>
+          <a:xfrm xmlns:a="http://schemas.openxmlformats.org/drawingml/2006/main">
+            <a:off x="819150" y="3429000"/>
+            <a:ext cx="4857750" cy="1666875"/>
           </a:xfrm>
           <a:prstGeom xmlns:a="http://schemas.openxmlformats.org/drawingml/2006/main" prst="rect">
             <a:avLst/>
@@ -15705,19 +15705,19 @@
           <p:cNvPr id="7" name="캡처는 mock 동작 시연입니다.&#10;실제 사진 AI 분석 결">
             <a:extLst xmlns:a="http://schemas.openxmlformats.org/drawingml/2006/main">
               <a:ext uri="{FF2B5EF4-FFF2-40B4-BE49-F238E27FC236}">
-                <a16:creationId xmlns:a16="http://schemas.microsoft.com/office/drawing/2014/main" id="{C08E216A-4903-4141-9F9E-D17F1173D5A7}"/>
-              </a:ext>
-            </a:extLst>
-          </p:cNvPr>
-          <p:cNvSpPr>
-            <a:spLocks xmlns:a="http://schemas.openxmlformats.org/drawingml/2006/main" noGrp="1"/>
-          </p:cNvSpPr>
-          <p:nvPr/>
-        </p:nvSpPr>
-        <p:spPr>
-          <a:xfrm xmlns:a="http://schemas.openxmlformats.org/drawingml/2006/main">
-            <a:off x="819150" y="5467350"/>
-            <a:ext cx="5143500" cy="619125"/>
+                <a16:creationId xmlns:a16="http://schemas.microsoft.com/office/drawing/2014/main" id="{62A06FFE-0221-45AB-9C27-8F0B6FAD4715}"/>
+              </a:ext>
+            </a:extLst>
+          </p:cNvPr>
+          <p:cNvSpPr>
+            <a:spLocks xmlns:a="http://schemas.openxmlformats.org/drawingml/2006/main" noGrp="1"/>
+          </p:cNvSpPr>
+          <p:nvPr/>
+        </p:nvSpPr>
+        <p:spPr>
+          <a:xfrm xmlns:a="http://schemas.openxmlformats.org/drawingml/2006/main">
+            <a:off x="819150" y="5362575"/>
+            <a:ext cx="4857750" cy="619125"/>
           </a:xfrm>
           <a:prstGeom xmlns:a="http://schemas.openxmlformats.org/drawingml/2006/main" prst="rect">
             <a:avLst/>
@@ -15796,19 +15796,19 @@
           <p:cNvPr id="8" name="사진 제출">
             <a:extLst xmlns:a="http://schemas.openxmlformats.org/drawingml/2006/main">
               <a:ext uri="{FF2B5EF4-FFF2-40B4-BE49-F238E27FC236}">
-                <a16:creationId xmlns:a16="http://schemas.microsoft.com/office/drawing/2014/main" id="{5D34D5CA-2B20-4651-B21E-1AF365AD5306}"/>
-              </a:ext>
-            </a:extLst>
-          </p:cNvPr>
-          <p:cNvSpPr>
-            <a:spLocks xmlns:a="http://schemas.openxmlformats.org/drawingml/2006/main" noGrp="1"/>
-          </p:cNvSpPr>
-          <p:nvPr/>
-        </p:nvSpPr>
-        <p:spPr>
-          <a:xfrm xmlns:a="http://schemas.openxmlformats.org/drawingml/2006/main">
-            <a:off x="6524625" y="1609725"/>
-            <a:ext cx="2095500" cy="238125"/>
+                <a16:creationId xmlns:a16="http://schemas.microsoft.com/office/drawing/2014/main" id="{74D1F0E5-469B-4DD4-8268-2C4F25D96B1E}"/>
+              </a:ext>
+            </a:extLst>
+          </p:cNvPr>
+          <p:cNvSpPr>
+            <a:spLocks xmlns:a="http://schemas.openxmlformats.org/drawingml/2006/main" noGrp="1"/>
+          </p:cNvSpPr>
+          <p:nvPr/>
+        </p:nvSpPr>
+        <p:spPr>
+          <a:xfrm xmlns:a="http://schemas.openxmlformats.org/drawingml/2006/main">
+            <a:off x="6096000" y="1257300"/>
+            <a:ext cx="2245519" cy="238125"/>
           </a:xfrm>
           <a:prstGeom xmlns:a="http://schemas.openxmlformats.org/drawingml/2006/main" prst="rect">
             <a:avLst/>
@@ -15864,19 +15864,19 @@
           <p:cNvPr id="9" name="관리자 확인">
             <a:extLst xmlns:a="http://schemas.openxmlformats.org/drawingml/2006/main">
               <a:ext uri="{FF2B5EF4-FFF2-40B4-BE49-F238E27FC236}">
-                <a16:creationId xmlns:a16="http://schemas.microsoft.com/office/drawing/2014/main" id="{6E1EC917-286B-48EB-831F-5D3052F5F324}"/>
-              </a:ext>
-            </a:extLst>
-          </p:cNvPr>
-          <p:cNvSpPr>
-            <a:spLocks xmlns:a="http://schemas.openxmlformats.org/drawingml/2006/main" noGrp="1"/>
-          </p:cNvSpPr>
-          <p:nvPr/>
-        </p:nvSpPr>
-        <p:spPr>
-          <a:xfrm xmlns:a="http://schemas.openxmlformats.org/drawingml/2006/main">
-            <a:off x="9048750" y="1609725"/>
-            <a:ext cx="2095500" cy="238125"/>
+                <a16:creationId xmlns:a16="http://schemas.microsoft.com/office/drawing/2014/main" id="{49955550-0DB8-404B-A370-D752909C20AA}"/>
+              </a:ext>
+            </a:extLst>
+          </p:cNvPr>
+          <p:cNvSpPr>
+            <a:spLocks xmlns:a="http://schemas.openxmlformats.org/drawingml/2006/main" noGrp="1"/>
+          </p:cNvSpPr>
+          <p:nvPr/>
+        </p:nvSpPr>
+        <p:spPr>
+          <a:xfrm xmlns:a="http://schemas.openxmlformats.org/drawingml/2006/main">
+            <a:off x="8858250" y="1257300"/>
+            <a:ext cx="2245519" cy="238125"/>
           </a:xfrm>
           <a:prstGeom xmlns:a="http://schemas.openxmlformats.org/drawingml/2006/main" prst="rect">
             <a:avLst/>
@@ -15932,7 +15932,7 @@
           <p:cNvPr id="10" name="">
             <a:extLst xmlns:a="http://schemas.openxmlformats.org/drawingml/2006/main">
               <a:ext uri="{FF2B5EF4-FFF2-40B4-BE49-F238E27FC236}">
-                <a16:creationId xmlns:a16="http://schemas.microsoft.com/office/drawing/2014/main" id="{5196DE1E-F4E9-4A20-9CC1-E4D5DAEDFDA0}"/>
+                <a16:creationId xmlns:a16="http://schemas.microsoft.com/office/drawing/2014/main" id="{ECACAF89-B597-4319-B392-170C23792DC4}"/>
               </a:ext>
             </a:extLst>
           </p:cNvPr>
@@ -15942,13 +15942,13 @@
           <p:nvPr/>
         </p:nvPicPr>
         <p:blipFill>
-          <a:blip xmlns:r="http://schemas.openxmlformats.org/officeDocument/2006/relationships" xmlns:a="http://schemas.openxmlformats.org/drawingml/2006/main" r:embed="R27b5b554815840a4"/>
+          <a:blip xmlns:r="http://schemas.openxmlformats.org/officeDocument/2006/relationships" xmlns:a="http://schemas.openxmlformats.org/drawingml/2006/main" r:embed="R85896b2f2fd0483d"/>
           <a:stretch xmlns:a="http://schemas.openxmlformats.org/drawingml/2006/main"/>
         </p:blipFill>
         <p:spPr>
           <a:xfrm xmlns:a="http://schemas.openxmlformats.org/drawingml/2006/main">
-            <a:off x="6524625" y="1924050"/>
-            <a:ext cx="1952625" cy="4225681"/>
+            <a:off x="6096000" y="1524000"/>
+            <a:ext cx="2245519" cy="4859533"/>
           </a:xfrm>
           <a:prstGeom xmlns:a="http://schemas.openxmlformats.org/drawingml/2006/main" prst="rect">
             <a:avLst/>
@@ -15960,7 +15960,7 @@
           <p:cNvPr id="11" name="">
             <a:extLst xmlns:a="http://schemas.openxmlformats.org/drawingml/2006/main">
               <a:ext uri="{FF2B5EF4-FFF2-40B4-BE49-F238E27FC236}">
-                <a16:creationId xmlns:a16="http://schemas.microsoft.com/office/drawing/2014/main" id="{71772BFE-A6E3-4AFA-BF07-FA8C37790C7E}"/>
+                <a16:creationId xmlns:a16="http://schemas.microsoft.com/office/drawing/2014/main" id="{41EE0EAA-ADB9-4D82-8BA0-3AB78F7011B9}"/>
               </a:ext>
             </a:extLst>
           </p:cNvPr>
@@ -15970,13 +15970,13 @@
           <p:nvPr/>
         </p:nvPicPr>
         <p:blipFill>
-          <a:blip xmlns:r="http://schemas.openxmlformats.org/officeDocument/2006/relationships" xmlns:a="http://schemas.openxmlformats.org/drawingml/2006/main" r:embed="Rad5fd512ed29452b"/>
+          <a:blip xmlns:r="http://schemas.openxmlformats.org/officeDocument/2006/relationships" xmlns:a="http://schemas.openxmlformats.org/drawingml/2006/main" r:embed="Re9229294af824a07"/>
           <a:stretch xmlns:a="http://schemas.openxmlformats.org/drawingml/2006/main"/>
         </p:blipFill>
         <p:spPr>
           <a:xfrm xmlns:a="http://schemas.openxmlformats.org/drawingml/2006/main">
-            <a:off x="9048750" y="1924050"/>
-            <a:ext cx="1952625" cy="4225681"/>
+            <a:off x="8858250" y="1524000"/>
+            <a:ext cx="2245519" cy="4859533"/>
           </a:xfrm>
           <a:prstGeom xmlns:a="http://schemas.openxmlformats.org/drawingml/2006/main" prst="rect">
             <a:avLst/>
@@ -15986,7 +15986,7 @@
     </p:spTree>
     <p:extLst>
       <p:ext uri="{BB962C8B-B14F-4D97-AF65-F5344CB8AC3E}">
-        <p14:creationId xmlns:p14="http://schemas.microsoft.com/office/powerpoint/2010/main" val="78255879"/>
+        <p14:creationId xmlns:p14="http://schemas.microsoft.com/office/powerpoint/2010/main" val="1068557706"/>
       </p:ext>
     </p:extLst>
   </p:cSld>
@@ -16010,18 +16010,18 @@
           <p:cNvPr id="12" name="DEMO 04 · 근로자와 관리자">
             <a:extLst xmlns:a="http://schemas.openxmlformats.org/drawingml/2006/main">
               <a:ext uri="{FF2B5EF4-FFF2-40B4-BE49-F238E27FC236}">
-                <a16:creationId xmlns:a16="http://schemas.microsoft.com/office/drawing/2014/main" id="{0C34FA8A-7705-48EA-8672-CDE3EE9783B2}"/>
-              </a:ext>
-            </a:extLst>
-          </p:cNvPr>
-          <p:cNvSpPr>
-            <a:spLocks xmlns:a="http://schemas.openxmlformats.org/drawingml/2006/main" noGrp="1"/>
-          </p:cNvSpPr>
-          <p:nvPr/>
-        </p:nvSpPr>
-        <p:spPr>
-          <a:xfrm xmlns:a="http://schemas.openxmlformats.org/drawingml/2006/main">
-            <a:off x="819150" y="676275"/>
+                <a16:creationId xmlns:a16="http://schemas.microsoft.com/office/drawing/2014/main" id="{13DDA614-1B1E-47B9-93B4-F015A61161BE}"/>
+              </a:ext>
+            </a:extLst>
+          </p:cNvPr>
+          <p:cNvSpPr>
+            <a:spLocks xmlns:a="http://schemas.openxmlformats.org/drawingml/2006/main" noGrp="1"/>
+          </p:cNvSpPr>
+          <p:nvPr/>
+        </p:nvSpPr>
+        <p:spPr>
+          <a:xfrm xmlns:a="http://schemas.openxmlformats.org/drawingml/2006/main">
+            <a:off x="819150" y="400050"/>
             <a:ext cx="8096250" cy="285750"/>
           </a:xfrm>
           <a:prstGeom xmlns:a="http://schemas.openxmlformats.org/drawingml/2006/main" prst="rect">
@@ -16078,19 +16078,19 @@
           <p:cNvPr id="2" name="근로자의 마감 보고를 반장의 검토로 연결합니다">
             <a:extLst xmlns:a="http://schemas.openxmlformats.org/drawingml/2006/main">
               <a:ext uri="{FF2B5EF4-FFF2-40B4-BE49-F238E27FC236}">
-                <a16:creationId xmlns:a16="http://schemas.microsoft.com/office/drawing/2014/main" id="{C9F5D8CF-FE9A-449E-BD68-F15942223C2D}"/>
-              </a:ext>
-            </a:extLst>
-          </p:cNvPr>
-          <p:cNvSpPr>
-            <a:spLocks xmlns:a="http://schemas.openxmlformats.org/drawingml/2006/main" noGrp="1"/>
-          </p:cNvSpPr>
-          <p:nvPr/>
-        </p:nvSpPr>
-        <p:spPr>
-          <a:xfrm xmlns:a="http://schemas.openxmlformats.org/drawingml/2006/main">
-            <a:off x="819150" y="1019175"/>
-            <a:ext cx="10668000" cy="571500"/>
+                <a16:creationId xmlns:a16="http://schemas.microsoft.com/office/drawing/2014/main" id="{3983DB0E-B387-44D7-8FFD-08489049CF85}"/>
+              </a:ext>
+            </a:extLst>
+          </p:cNvPr>
+          <p:cNvSpPr>
+            <a:spLocks xmlns:a="http://schemas.openxmlformats.org/drawingml/2006/main" noGrp="1"/>
+          </p:cNvSpPr>
+          <p:nvPr/>
+        </p:nvSpPr>
+        <p:spPr>
+          <a:xfrm xmlns:a="http://schemas.openxmlformats.org/drawingml/2006/main">
+            <a:off x="819150" y="723900"/>
+            <a:ext cx="10668000" cy="457200"/>
           </a:xfrm>
           <a:prstGeom xmlns:a="http://schemas.openxmlformats.org/drawingml/2006/main" prst="rect">
             <a:avLst/>
@@ -16146,19 +16146,19 @@
           <p:cNvPr id="3" name="안전반장 · TEAM 0x02">
             <a:extLst xmlns:a="http://schemas.openxmlformats.org/drawingml/2006/main">
               <a:ext uri="{FF2B5EF4-FFF2-40B4-BE49-F238E27FC236}">
-                <a16:creationId xmlns:a16="http://schemas.microsoft.com/office/drawing/2014/main" id="{6C36A5FD-6432-4F77-AF65-A5F264AA6325}"/>
-              </a:ext>
-            </a:extLst>
-          </p:cNvPr>
-          <p:cNvSpPr>
-            <a:spLocks xmlns:a="http://schemas.openxmlformats.org/drawingml/2006/main" noGrp="1"/>
-          </p:cNvSpPr>
-          <p:nvPr/>
-        </p:nvSpPr>
-        <p:spPr>
-          <a:xfrm xmlns:a="http://schemas.openxmlformats.org/drawingml/2006/main">
-            <a:off x="819150" y="6334125"/>
-            <a:ext cx="6667500" cy="238125"/>
+                <a16:creationId xmlns:a16="http://schemas.microsoft.com/office/drawing/2014/main" id="{528405C9-FFF5-43C3-BD2A-ACB2B87CFCE3}"/>
+              </a:ext>
+            </a:extLst>
+          </p:cNvPr>
+          <p:cNvSpPr>
+            <a:spLocks xmlns:a="http://schemas.openxmlformats.org/drawingml/2006/main" noGrp="1"/>
+          </p:cNvSpPr>
+          <p:nvPr/>
+        </p:nvSpPr>
+        <p:spPr>
+          <a:xfrm xmlns:a="http://schemas.openxmlformats.org/drawingml/2006/main">
+            <a:off x="819150" y="6562725"/>
+            <a:ext cx="6667500" cy="209550"/>
           </a:xfrm>
           <a:prstGeom xmlns:a="http://schemas.openxmlformats.org/drawingml/2006/main" prst="rect">
             <a:avLst/>
@@ -16214,19 +16214,19 @@
           <p:cNvPr id="4" name="09 / 14">
             <a:extLst xmlns:a="http://schemas.openxmlformats.org/drawingml/2006/main">
               <a:ext uri="{FF2B5EF4-FFF2-40B4-BE49-F238E27FC236}">
-                <a16:creationId xmlns:a16="http://schemas.microsoft.com/office/drawing/2014/main" id="{1660E41C-C8EB-4A59-A1F3-3457AFFAD819}"/>
-              </a:ext>
-            </a:extLst>
-          </p:cNvPr>
-          <p:cNvSpPr>
-            <a:spLocks xmlns:a="http://schemas.openxmlformats.org/drawingml/2006/main" noGrp="1"/>
-          </p:cNvSpPr>
-          <p:nvPr/>
-        </p:nvSpPr>
-        <p:spPr>
-          <a:xfrm xmlns:a="http://schemas.openxmlformats.org/drawingml/2006/main">
-            <a:off x="10668000" y="6334125"/>
-            <a:ext cx="952500" cy="238125"/>
+                <a16:creationId xmlns:a16="http://schemas.microsoft.com/office/drawing/2014/main" id="{CAEF5402-5D8D-4949-81F3-EEC49AC27BBC}"/>
+              </a:ext>
+            </a:extLst>
+          </p:cNvPr>
+          <p:cNvSpPr>
+            <a:spLocks xmlns:a="http://schemas.openxmlformats.org/drawingml/2006/main" noGrp="1"/>
+          </p:cNvSpPr>
+          <p:nvPr/>
+        </p:nvSpPr>
+        <p:spPr>
+          <a:xfrm xmlns:a="http://schemas.openxmlformats.org/drawingml/2006/main">
+            <a:off x="10668000" y="6562725"/>
+            <a:ext cx="952500" cy="209550"/>
           </a:xfrm>
           <a:prstGeom xmlns:a="http://schemas.openxmlformats.org/drawingml/2006/main" prst="rect">
             <a:avLst/>
@@ -16282,19 +16282,19 @@
           <p:cNvPr id="5" name="오늘의 위험과 조치를&#10;다음 작업에 남깁니다">
             <a:extLst xmlns:a="http://schemas.openxmlformats.org/drawingml/2006/main">
               <a:ext uri="{FF2B5EF4-FFF2-40B4-BE49-F238E27FC236}">
-                <a16:creationId xmlns:a16="http://schemas.microsoft.com/office/drawing/2014/main" id="{5BF4664C-D4D9-4CC0-A980-80FD7EEC530A}"/>
-              </a:ext>
-            </a:extLst>
-          </p:cNvPr>
-          <p:cNvSpPr>
-            <a:spLocks xmlns:a="http://schemas.openxmlformats.org/drawingml/2006/main" noGrp="1"/>
-          </p:cNvSpPr>
-          <p:nvPr/>
-        </p:nvSpPr>
-        <p:spPr>
-          <a:xfrm xmlns:a="http://schemas.openxmlformats.org/drawingml/2006/main">
-            <a:off x="819150" y="2133600"/>
-            <a:ext cx="5143500" cy="1238250"/>
+                <a16:creationId xmlns:a16="http://schemas.microsoft.com/office/drawing/2014/main" id="{3997A221-F4CA-4766-9106-0E12C6FE9AFE}"/>
+              </a:ext>
+            </a:extLst>
+          </p:cNvPr>
+          <p:cNvSpPr>
+            <a:spLocks xmlns:a="http://schemas.openxmlformats.org/drawingml/2006/main" noGrp="1"/>
+          </p:cNvSpPr>
+          <p:nvPr/>
+        </p:nvSpPr>
+        <p:spPr>
+          <a:xfrm xmlns:a="http://schemas.openxmlformats.org/drawingml/2006/main">
+            <a:off x="819150" y="2047875"/>
+            <a:ext cx="4857750" cy="1238250"/>
           </a:xfrm>
           <a:prstGeom xmlns:a="http://schemas.openxmlformats.org/drawingml/2006/main" prst="rect">
             <a:avLst/>
@@ -16373,19 +16373,19 @@
           <p:cNvPr id="6" name="근로자는 작업 내용과 위험을 보고하고&#10;반장은 검토함에서 확">
             <a:extLst xmlns:a="http://schemas.openxmlformats.org/drawingml/2006/main">
               <a:ext uri="{FF2B5EF4-FFF2-40B4-BE49-F238E27FC236}">
-                <a16:creationId xmlns:a16="http://schemas.microsoft.com/office/drawing/2014/main" id="{92704365-A1BE-4D86-9949-84374BD427CE}"/>
-              </a:ext>
-            </a:extLst>
-          </p:cNvPr>
-          <p:cNvSpPr>
-            <a:spLocks xmlns:a="http://schemas.openxmlformats.org/drawingml/2006/main" noGrp="1"/>
-          </p:cNvSpPr>
-          <p:nvPr/>
-        </p:nvSpPr>
-        <p:spPr>
-          <a:xfrm xmlns:a="http://schemas.openxmlformats.org/drawingml/2006/main">
-            <a:off x="819150" y="3590925"/>
-            <a:ext cx="5095875" cy="1666875"/>
+                <a16:creationId xmlns:a16="http://schemas.microsoft.com/office/drawing/2014/main" id="{26628BAD-08F2-4380-90B1-57B73A4546E0}"/>
+              </a:ext>
+            </a:extLst>
+          </p:cNvPr>
+          <p:cNvSpPr>
+            <a:spLocks xmlns:a="http://schemas.openxmlformats.org/drawingml/2006/main" noGrp="1"/>
+          </p:cNvSpPr>
+          <p:nvPr/>
+        </p:nvSpPr>
+        <p:spPr>
+          <a:xfrm xmlns:a="http://schemas.openxmlformats.org/drawingml/2006/main">
+            <a:off x="819150" y="3429000"/>
+            <a:ext cx="4857750" cy="1666875"/>
           </a:xfrm>
           <a:prstGeom xmlns:a="http://schemas.openxmlformats.org/drawingml/2006/main" prst="rect">
             <a:avLst/>
@@ -16464,19 +16464,19 @@
           <p:cNvPr id="7" name="제출 여부와 검토 내용을 구분해&#10;후속 조치에 활용합니다.">
             <a:extLst xmlns:a="http://schemas.openxmlformats.org/drawingml/2006/main">
               <a:ext uri="{FF2B5EF4-FFF2-40B4-BE49-F238E27FC236}">
-                <a16:creationId xmlns:a16="http://schemas.microsoft.com/office/drawing/2014/main" id="{39FC3A0E-F080-4042-A628-C8823D462118}"/>
-              </a:ext>
-            </a:extLst>
-          </p:cNvPr>
-          <p:cNvSpPr>
-            <a:spLocks xmlns:a="http://schemas.openxmlformats.org/drawingml/2006/main" noGrp="1"/>
-          </p:cNvSpPr>
-          <p:nvPr/>
-        </p:nvSpPr>
-        <p:spPr>
-          <a:xfrm xmlns:a="http://schemas.openxmlformats.org/drawingml/2006/main">
-            <a:off x="819150" y="5467350"/>
-            <a:ext cx="5143500" cy="619125"/>
+                <a16:creationId xmlns:a16="http://schemas.microsoft.com/office/drawing/2014/main" id="{C6BB07EF-3BAE-4AAF-9B08-1B6397304DE8}"/>
+              </a:ext>
+            </a:extLst>
+          </p:cNvPr>
+          <p:cNvSpPr>
+            <a:spLocks xmlns:a="http://schemas.openxmlformats.org/drawingml/2006/main" noGrp="1"/>
+          </p:cNvSpPr>
+          <p:nvPr/>
+        </p:nvSpPr>
+        <p:spPr>
+          <a:xfrm xmlns:a="http://schemas.openxmlformats.org/drawingml/2006/main">
+            <a:off x="819150" y="5362575"/>
+            <a:ext cx="4857750" cy="619125"/>
           </a:xfrm>
           <a:prstGeom xmlns:a="http://schemas.openxmlformats.org/drawingml/2006/main" prst="rect">
             <a:avLst/>
@@ -16555,19 +16555,19 @@
           <p:cNvPr id="8" name="근로자 보고">
             <a:extLst xmlns:a="http://schemas.openxmlformats.org/drawingml/2006/main">
               <a:ext uri="{FF2B5EF4-FFF2-40B4-BE49-F238E27FC236}">
-                <a16:creationId xmlns:a16="http://schemas.microsoft.com/office/drawing/2014/main" id="{266A110E-7C68-4F07-B4D1-4725E7AA45B6}"/>
-              </a:ext>
-            </a:extLst>
-          </p:cNvPr>
-          <p:cNvSpPr>
-            <a:spLocks xmlns:a="http://schemas.openxmlformats.org/drawingml/2006/main" noGrp="1"/>
-          </p:cNvSpPr>
-          <p:nvPr/>
-        </p:nvSpPr>
-        <p:spPr>
-          <a:xfrm xmlns:a="http://schemas.openxmlformats.org/drawingml/2006/main">
-            <a:off x="6524625" y="1609725"/>
-            <a:ext cx="2095500" cy="238125"/>
+                <a16:creationId xmlns:a16="http://schemas.microsoft.com/office/drawing/2014/main" id="{884E706C-E791-485F-A309-B44D518CFC78}"/>
+              </a:ext>
+            </a:extLst>
+          </p:cNvPr>
+          <p:cNvSpPr>
+            <a:spLocks xmlns:a="http://schemas.openxmlformats.org/drawingml/2006/main" noGrp="1"/>
+          </p:cNvSpPr>
+          <p:nvPr/>
+        </p:nvSpPr>
+        <p:spPr>
+          <a:xfrm xmlns:a="http://schemas.openxmlformats.org/drawingml/2006/main">
+            <a:off x="6096000" y="1257300"/>
+            <a:ext cx="2245519" cy="238125"/>
           </a:xfrm>
           <a:prstGeom xmlns:a="http://schemas.openxmlformats.org/drawingml/2006/main" prst="rect">
             <a:avLst/>
@@ -16623,19 +16623,19 @@
           <p:cNvPr id="9" name="관리자 검토함">
             <a:extLst xmlns:a="http://schemas.openxmlformats.org/drawingml/2006/main">
               <a:ext uri="{FF2B5EF4-FFF2-40B4-BE49-F238E27FC236}">
-                <a16:creationId xmlns:a16="http://schemas.microsoft.com/office/drawing/2014/main" id="{85C30B2D-29E0-4972-8380-70C4DAF99D09}"/>
-              </a:ext>
-            </a:extLst>
-          </p:cNvPr>
-          <p:cNvSpPr>
-            <a:spLocks xmlns:a="http://schemas.openxmlformats.org/drawingml/2006/main" noGrp="1"/>
-          </p:cNvSpPr>
-          <p:nvPr/>
-        </p:nvSpPr>
-        <p:spPr>
-          <a:xfrm xmlns:a="http://schemas.openxmlformats.org/drawingml/2006/main">
-            <a:off x="9048750" y="1609725"/>
-            <a:ext cx="2095500" cy="238125"/>
+                <a16:creationId xmlns:a16="http://schemas.microsoft.com/office/drawing/2014/main" id="{93E91780-D95C-4275-B675-92D5DFC21838}"/>
+              </a:ext>
+            </a:extLst>
+          </p:cNvPr>
+          <p:cNvSpPr>
+            <a:spLocks xmlns:a="http://schemas.openxmlformats.org/drawingml/2006/main" noGrp="1"/>
+          </p:cNvSpPr>
+          <p:nvPr/>
+        </p:nvSpPr>
+        <p:spPr>
+          <a:xfrm xmlns:a="http://schemas.openxmlformats.org/drawingml/2006/main">
+            <a:off x="8858250" y="1257300"/>
+            <a:ext cx="2245519" cy="238125"/>
           </a:xfrm>
           <a:prstGeom xmlns:a="http://schemas.openxmlformats.org/drawingml/2006/main" prst="rect">
             <a:avLst/>
@@ -16691,7 +16691,7 @@
           <p:cNvPr id="10" name="">
             <a:extLst xmlns:a="http://schemas.openxmlformats.org/drawingml/2006/main">
               <a:ext uri="{FF2B5EF4-FFF2-40B4-BE49-F238E27FC236}">
-                <a16:creationId xmlns:a16="http://schemas.microsoft.com/office/drawing/2014/main" id="{C7412174-D595-458E-B00B-5D4F9A8EEC52}"/>
+                <a16:creationId xmlns:a16="http://schemas.microsoft.com/office/drawing/2014/main" id="{0571F7AE-360D-4A53-841B-0A60E8A8E121}"/>
               </a:ext>
             </a:extLst>
           </p:cNvPr>
@@ -16701,13 +16701,13 @@
           <p:nvPr/>
         </p:nvPicPr>
         <p:blipFill>
-          <a:blip xmlns:r="http://schemas.openxmlformats.org/officeDocument/2006/relationships" xmlns:a="http://schemas.openxmlformats.org/drawingml/2006/main" r:embed="R689ef7b468b24d93"/>
+          <a:blip xmlns:r="http://schemas.openxmlformats.org/officeDocument/2006/relationships" xmlns:a="http://schemas.openxmlformats.org/drawingml/2006/main" r:embed="Rc86178ef3fc24be8"/>
           <a:stretch xmlns:a="http://schemas.openxmlformats.org/drawingml/2006/main"/>
         </p:blipFill>
         <p:spPr>
           <a:xfrm xmlns:a="http://schemas.openxmlformats.org/drawingml/2006/main">
-            <a:off x="6524625" y="1924050"/>
-            <a:ext cx="1952625" cy="4225681"/>
+            <a:off x="6096000" y="1524000"/>
+            <a:ext cx="2245519" cy="4859533"/>
           </a:xfrm>
           <a:prstGeom xmlns:a="http://schemas.openxmlformats.org/drawingml/2006/main" prst="rect">
             <a:avLst/>
@@ -16719,7 +16719,7 @@
           <p:cNvPr id="11" name="">
             <a:extLst xmlns:a="http://schemas.openxmlformats.org/drawingml/2006/main">
               <a:ext uri="{FF2B5EF4-FFF2-40B4-BE49-F238E27FC236}">
-                <a16:creationId xmlns:a16="http://schemas.microsoft.com/office/drawing/2014/main" id="{449A7C71-404B-46DE-8E7C-53AF15870680}"/>
+                <a16:creationId xmlns:a16="http://schemas.microsoft.com/office/drawing/2014/main" id="{C0C56D05-64CD-44F3-808E-FF5203BECCCC}"/>
               </a:ext>
             </a:extLst>
           </p:cNvPr>
@@ -16729,13 +16729,13 @@
           <p:nvPr/>
         </p:nvPicPr>
         <p:blipFill>
-          <a:blip xmlns:r="http://schemas.openxmlformats.org/officeDocument/2006/relationships" xmlns:a="http://schemas.openxmlformats.org/drawingml/2006/main" r:embed="R173a9cd97a3c4d98"/>
+          <a:blip xmlns:r="http://schemas.openxmlformats.org/officeDocument/2006/relationships" xmlns:a="http://schemas.openxmlformats.org/drawingml/2006/main" r:embed="R1cfd65611c5b43e2"/>
           <a:stretch xmlns:a="http://schemas.openxmlformats.org/drawingml/2006/main"/>
         </p:blipFill>
         <p:spPr>
           <a:xfrm xmlns:a="http://schemas.openxmlformats.org/drawingml/2006/main">
-            <a:off x="9048750" y="1924050"/>
-            <a:ext cx="1952625" cy="4225681"/>
+            <a:off x="8858250" y="1524000"/>
+            <a:ext cx="2245519" cy="4859533"/>
           </a:xfrm>
           <a:prstGeom xmlns:a="http://schemas.openxmlformats.org/drawingml/2006/main" prst="rect">
             <a:avLst/>
@@ -16745,7 +16745,7 @@
     </p:spTree>
     <p:extLst>
       <p:ext uri="{BB962C8B-B14F-4D97-AF65-F5344CB8AC3E}">
-        <p14:creationId xmlns:p14="http://schemas.microsoft.com/office/powerpoint/2010/main" val="1526508385"/>
+        <p14:creationId xmlns:p14="http://schemas.microsoft.com/office/powerpoint/2010/main" val="2133366084"/>
       </p:ext>
     </p:extLst>
   </p:cSld>

</xml_diff>